<commit_message>
Add team names and registrations to final report and presentation
</commit_message>
<xml_diff>
--- a/output/assessments_visual/Assessment10_Visual.pptx
+++ b/output/assessments_visual/Assessment10_Visual.pptx
@@ -2,22 +2,22 @@
 <file path=ppt/presentation.xml><?xml version="1.0" encoding="utf-8"?>
 <p:presentation xmlns:p="http://schemas.openxmlformats.org/presentationml/2006/main">
   <p:sldMasterIdLst>
-    <p:sldMasterId xmlns:r="http://schemas.openxmlformats.org/officeDocument/2006/relationships" id="2147483648" r:id="Rb20530a5153d48c1"/>
+    <p:sldMasterId xmlns:r="http://schemas.openxmlformats.org/officeDocument/2006/relationships" id="2147483648" r:id="R91916bdf56e44655"/>
   </p:sldMasterIdLst>
   <p:notesMasterIdLst>
-    <p:notesMasterId xmlns:r="http://schemas.openxmlformats.org/officeDocument/2006/relationships" r:id="Rf43720d7d26a4247"/>
+    <p:notesMasterId xmlns:r="http://schemas.openxmlformats.org/officeDocument/2006/relationships" r:id="Reedb18908a3d4368"/>
   </p:notesMasterIdLst>
   <p:sldIdLst>
-    <p:sldId xmlns:r="http://schemas.openxmlformats.org/officeDocument/2006/relationships" id="256" r:id="R6e60d34d1fac4d08"/>
-    <p:sldId xmlns:r="http://schemas.openxmlformats.org/officeDocument/2006/relationships" id="257" r:id="R6c46cd94c55948cd"/>
-    <p:sldId xmlns:r="http://schemas.openxmlformats.org/officeDocument/2006/relationships" id="258" r:id="R75821cb57c6243f3"/>
-    <p:sldId xmlns:r="http://schemas.openxmlformats.org/officeDocument/2006/relationships" id="259" r:id="Rbe180a39931b455d"/>
-    <p:sldId xmlns:r="http://schemas.openxmlformats.org/officeDocument/2006/relationships" id="260" r:id="Rccd4f62148fb4b71"/>
-    <p:sldId xmlns:r="http://schemas.openxmlformats.org/officeDocument/2006/relationships" id="261" r:id="Rcd70ca1bbd624eaa"/>
-    <p:sldId xmlns:r="http://schemas.openxmlformats.org/officeDocument/2006/relationships" id="262" r:id="Rba10aa65dbfb4ad9"/>
-    <p:sldId xmlns:r="http://schemas.openxmlformats.org/officeDocument/2006/relationships" id="263" r:id="Rcc2e9dee09044882"/>
-    <p:sldId xmlns:r="http://schemas.openxmlformats.org/officeDocument/2006/relationships" id="264" r:id="R30fb700a8489427b"/>
-    <p:sldId xmlns:r="http://schemas.openxmlformats.org/officeDocument/2006/relationships" id="265" r:id="R8dc5ded402c448f2"/>
+    <p:sldId xmlns:r="http://schemas.openxmlformats.org/officeDocument/2006/relationships" id="256" r:id="Rb29cafc0f8d74b7d"/>
+    <p:sldId xmlns:r="http://schemas.openxmlformats.org/officeDocument/2006/relationships" id="257" r:id="R250be6208d7e484b"/>
+    <p:sldId xmlns:r="http://schemas.openxmlformats.org/officeDocument/2006/relationships" id="258" r:id="R3dbafe2cf234456c"/>
+    <p:sldId xmlns:r="http://schemas.openxmlformats.org/officeDocument/2006/relationships" id="259" r:id="R58085d1c673c444c"/>
+    <p:sldId xmlns:r="http://schemas.openxmlformats.org/officeDocument/2006/relationships" id="260" r:id="R36dca6175a804ae4"/>
+    <p:sldId xmlns:r="http://schemas.openxmlformats.org/officeDocument/2006/relationships" id="261" r:id="Rae1f6134bb064f68"/>
+    <p:sldId xmlns:r="http://schemas.openxmlformats.org/officeDocument/2006/relationships" id="262" r:id="R87725c0d3c6b41c2"/>
+    <p:sldId xmlns:r="http://schemas.openxmlformats.org/officeDocument/2006/relationships" id="263" r:id="R75ebed36136d4f5a"/>
+    <p:sldId xmlns:r="http://schemas.openxmlformats.org/officeDocument/2006/relationships" id="264" r:id="R3f4c65a6ade6445c"/>
+    <p:sldId xmlns:r="http://schemas.openxmlformats.org/officeDocument/2006/relationships" id="265" r:id="R1339b4aa42394129"/>
   </p:sldIdLst>
   <p:sldSz cx="12192000" cy="6858000"/>
   <p:notesSz cx="6858000" cy="9144000"/>
@@ -1328,7 +1328,7 @@
           <p:cNvPr id="3" name="Title">
             <a:extLst xmlns:a="http://schemas.openxmlformats.org/drawingml/2006/main">
               <a:ext uri="{FF2B5EF4-FFF2-40B4-BE49-F238E27FC236}">
-                <a16:creationId xmlns:a16="http://schemas.microsoft.com/office/drawing/2014/main" id="{778B19DE-A395-4929-A333-9B19BC5DC8E2}"/>
+                <a16:creationId xmlns:a16="http://schemas.microsoft.com/office/drawing/2014/main" id="{1818F2D0-8E74-447F-8AAD-18A52F56301E}"/>
               </a:ext>
             </a:extLst>
           </p:cNvPr>
@@ -1557,7 +1557,7 @@
           <p:cNvPr id="2" name="Subtitle">
             <a:extLst xmlns:a="http://schemas.openxmlformats.org/drawingml/2006/main">
               <a:ext uri="{FF2B5EF4-FFF2-40B4-BE49-F238E27FC236}">
-                <a16:creationId xmlns:a16="http://schemas.microsoft.com/office/drawing/2014/main" id="{9D27783E-AC20-404C-A77A-1E9BE353AADD}"/>
+                <a16:creationId xmlns:a16="http://schemas.microsoft.com/office/drawing/2014/main" id="{606FF839-E4C3-40BD-82C9-EC301BAEC9DF}"/>
               </a:ext>
             </a:extLst>
           </p:cNvPr>
@@ -1803,7 +1803,7 @@
           <p:cNvPr id="2" name="Section title">
             <a:extLst xmlns:a="http://schemas.openxmlformats.org/drawingml/2006/main">
               <a:ext uri="{FF2B5EF4-FFF2-40B4-BE49-F238E27FC236}">
-                <a16:creationId xmlns:a16="http://schemas.microsoft.com/office/drawing/2014/main" id="{77F4EC5C-9142-44DF-B4E4-79BEAA0D631B}"/>
+                <a16:creationId xmlns:a16="http://schemas.microsoft.com/office/drawing/2014/main" id="{7C214CB4-F683-4035-9E4C-AF34203EFF0D}"/>
               </a:ext>
             </a:extLst>
           </p:cNvPr>
@@ -2049,7 +2049,7 @@
           <p:cNvPr id="3" name="Title">
             <a:extLst xmlns:a="http://schemas.openxmlformats.org/drawingml/2006/main">
               <a:ext uri="{FF2B5EF4-FFF2-40B4-BE49-F238E27FC236}">
-                <a16:creationId xmlns:a16="http://schemas.microsoft.com/office/drawing/2014/main" id="{3536BA30-B0DF-4F12-AE84-36669CBCB4AF}"/>
+                <a16:creationId xmlns:a16="http://schemas.microsoft.com/office/drawing/2014/main" id="{1132142C-AD9F-4249-B644-B925CED3C0DD}"/>
               </a:ext>
             </a:extLst>
           </p:cNvPr>
@@ -2278,7 +2278,7 @@
           <p:cNvPr id="2" name="Body">
             <a:extLst xmlns:a="http://schemas.openxmlformats.org/drawingml/2006/main">
               <a:ext uri="{FF2B5EF4-FFF2-40B4-BE49-F238E27FC236}">
-                <a16:creationId xmlns:a16="http://schemas.microsoft.com/office/drawing/2014/main" id="{07228C3A-3D93-4D36-B21E-65BEC0701568}"/>
+                <a16:creationId xmlns:a16="http://schemas.microsoft.com/office/drawing/2014/main" id="{5407F797-E151-4A23-BC39-4571BFD64718}"/>
               </a:ext>
             </a:extLst>
           </p:cNvPr>
@@ -2524,7 +2524,7 @@
           <p:cNvPr id="4" name="Title">
             <a:extLst xmlns:a="http://schemas.openxmlformats.org/drawingml/2006/main">
               <a:ext uri="{FF2B5EF4-FFF2-40B4-BE49-F238E27FC236}">
-                <a16:creationId xmlns:a16="http://schemas.microsoft.com/office/drawing/2014/main" id="{5E095F5C-5177-4654-9DE1-24D3DB706A92}"/>
+                <a16:creationId xmlns:a16="http://schemas.microsoft.com/office/drawing/2014/main" id="{76FB6328-6F21-49B8-AB8C-A1EC014D6E7A}"/>
               </a:ext>
             </a:extLst>
           </p:cNvPr>
@@ -2753,7 +2753,7 @@
           <p:cNvPr id="2" name="Left column">
             <a:extLst xmlns:a="http://schemas.openxmlformats.org/drawingml/2006/main">
               <a:ext uri="{FF2B5EF4-FFF2-40B4-BE49-F238E27FC236}">
-                <a16:creationId xmlns:a16="http://schemas.microsoft.com/office/drawing/2014/main" id="{E79C25B8-3ED2-408F-8F97-2ABAE58A77F0}"/>
+                <a16:creationId xmlns:a16="http://schemas.microsoft.com/office/drawing/2014/main" id="{BA0A5C04-D6E4-4972-A320-D6824023B595}"/>
               </a:ext>
             </a:extLst>
           </p:cNvPr>
@@ -2982,7 +2982,7 @@
           <p:cNvPr id="3" name="Right column">
             <a:extLst xmlns:a="http://schemas.openxmlformats.org/drawingml/2006/main">
               <a:ext uri="{FF2B5EF4-FFF2-40B4-BE49-F238E27FC236}">
-                <a16:creationId xmlns:a16="http://schemas.microsoft.com/office/drawing/2014/main" id="{2FD1B7AE-DFD5-403E-A5FF-D88DA9F187B5}"/>
+                <a16:creationId xmlns:a16="http://schemas.microsoft.com/office/drawing/2014/main" id="{238056DF-0448-4D31-91E3-A9830476A803}"/>
               </a:ext>
             </a:extLst>
           </p:cNvPr>
@@ -3228,7 +3228,7 @@
           <p:cNvPr id="3" name="Title">
             <a:extLst xmlns:a="http://schemas.openxmlformats.org/drawingml/2006/main">
               <a:ext uri="{FF2B5EF4-FFF2-40B4-BE49-F238E27FC236}">
-                <a16:creationId xmlns:a16="http://schemas.microsoft.com/office/drawing/2014/main" id="{E75B7D52-9631-457C-84BD-75A1521A51BD}"/>
+                <a16:creationId xmlns:a16="http://schemas.microsoft.com/office/drawing/2014/main" id="{85C99016-4690-4B4C-8A15-9D7C4814C2A7}"/>
               </a:ext>
             </a:extLst>
           </p:cNvPr>
@@ -3457,7 +3457,7 @@
           <p:cNvPr id="2" name="Left column">
             <a:extLst xmlns:a="http://schemas.openxmlformats.org/drawingml/2006/main">
               <a:ext uri="{FF2B5EF4-FFF2-40B4-BE49-F238E27FC236}">
-                <a16:creationId xmlns:a16="http://schemas.microsoft.com/office/drawing/2014/main" id="{451278B9-6B11-4C58-98C8-C73C3A80881D}"/>
+                <a16:creationId xmlns:a16="http://schemas.microsoft.com/office/drawing/2014/main" id="{D0F17496-8841-4CC5-B94D-977587E243E0}"/>
               </a:ext>
             </a:extLst>
           </p:cNvPr>
@@ -3724,12 +3724,12 @@
   </p:cSld>
   <p:clrMap bg1="lt1" tx1="dk1" bg2="lt2" tx2="dk2" accent1="accent1" accent2="accent2" accent3="accent3" accent4="accent4" accent5="accent5" accent6="accent6" hlink="hlink" folHlink="folHlink"/>
   <p:sldLayoutIdLst>
-    <p:sldLayoutId xmlns:r="http://schemas.openxmlformats.org/officeDocument/2006/relationships" id="2147483649" r:id="R9223075666304dcb"/>
-    <p:sldLayoutId xmlns:r="http://schemas.openxmlformats.org/officeDocument/2006/relationships" id="2147483650" r:id="Rbc3f6f37d57144d7"/>
-    <p:sldLayoutId xmlns:r="http://schemas.openxmlformats.org/officeDocument/2006/relationships" id="2147483651" r:id="R695c2791162249f0"/>
-    <p:sldLayoutId xmlns:r="http://schemas.openxmlformats.org/officeDocument/2006/relationships" id="2147483652" r:id="Rb8a8e6f63b0e46c2"/>
-    <p:sldLayoutId xmlns:r="http://schemas.openxmlformats.org/officeDocument/2006/relationships" id="2147483653" r:id="R43f8b24e937a4f2c"/>
-    <p:sldLayoutId xmlns:r="http://schemas.openxmlformats.org/officeDocument/2006/relationships" id="2147483654" r:id="Rf72d07a4864b4124"/>
+    <p:sldLayoutId xmlns:r="http://schemas.openxmlformats.org/officeDocument/2006/relationships" id="2147483649" r:id="Ra5555dba3df74cd2"/>
+    <p:sldLayoutId xmlns:r="http://schemas.openxmlformats.org/officeDocument/2006/relationships" id="2147483650" r:id="R75b2d5ddcf3c4420"/>
+    <p:sldLayoutId xmlns:r="http://schemas.openxmlformats.org/officeDocument/2006/relationships" id="2147483651" r:id="Rda47cdd0607c4f6a"/>
+    <p:sldLayoutId xmlns:r="http://schemas.openxmlformats.org/officeDocument/2006/relationships" id="2147483652" r:id="R6268b40bc693446c"/>
+    <p:sldLayoutId xmlns:r="http://schemas.openxmlformats.org/officeDocument/2006/relationships" id="2147483653" r:id="Rcc8f75c771ef40a6"/>
+    <p:sldLayoutId xmlns:r="http://schemas.openxmlformats.org/officeDocument/2006/relationships" id="2147483654" r:id="R3cbbdd6b8dcc4428"/>
   </p:sldLayoutIdLst>
   <p:txStyles>
     <p:titleStyle>
@@ -9168,10 +9168,10 @@
       </p:grpSpPr>
       <p:sp>
         <p:nvSpPr>
-          <p:cNvPr id="2" name="">
+          <p:cNvPr id="18" name="">
             <a:extLst xmlns:a="http://schemas.openxmlformats.org/drawingml/2006/main">
               <a:ext uri="{FF2B5EF4-FFF2-40B4-BE49-F238E27FC236}">
-                <a16:creationId xmlns:a16="http://schemas.microsoft.com/office/drawing/2014/main" id="{228B1CEF-0519-4FFC-86B0-875D85D4F8DA}"/>
+                <a16:creationId xmlns:a16="http://schemas.microsoft.com/office/drawing/2014/main" id="{AA0BAC71-2177-48AD-AA0D-9BE8FBC5A9E7}"/>
               </a:ext>
             </a:extLst>
           </p:cNvPr>
@@ -9326,10 +9326,10 @@
       </p:sp>
       <p:sp>
         <p:nvSpPr>
-          <p:cNvPr id="3" name="">
+          <p:cNvPr id="2" name="">
             <a:extLst xmlns:a="http://schemas.openxmlformats.org/drawingml/2006/main">
               <a:ext uri="{FF2B5EF4-FFF2-40B4-BE49-F238E27FC236}">
-                <a16:creationId xmlns:a16="http://schemas.microsoft.com/office/drawing/2014/main" id="{7E2B2C81-862D-424E-AA7F-6AD5884236C2}"/>
+                <a16:creationId xmlns:a16="http://schemas.microsoft.com/office/drawing/2014/main" id="{2932C0B0-E327-4E71-92F5-4E10316B91A3}"/>
               </a:ext>
             </a:extLst>
           </p:cNvPr>
@@ -9484,10 +9484,10 @@
       </p:sp>
       <p:sp>
         <p:nvSpPr>
-          <p:cNvPr id="4" name="">
+          <p:cNvPr id="3" name="">
             <a:extLst xmlns:a="http://schemas.openxmlformats.org/drawingml/2006/main">
               <a:ext uri="{FF2B5EF4-FFF2-40B4-BE49-F238E27FC236}">
-                <a16:creationId xmlns:a16="http://schemas.microsoft.com/office/drawing/2014/main" id="{71E0791B-CA8B-4E9A-B935-C77CC7189403}"/>
+                <a16:creationId xmlns:a16="http://schemas.microsoft.com/office/drawing/2014/main" id="{8CFA13BA-8A3C-4999-9D79-20D8B2BC27E7}"/>
               </a:ext>
             </a:extLst>
           </p:cNvPr>
@@ -9642,10 +9642,10 @@
       </p:sp>
       <p:sp>
         <p:nvSpPr>
-          <p:cNvPr id="5" name="">
+          <p:cNvPr id="4" name="">
             <a:extLst xmlns:a="http://schemas.openxmlformats.org/drawingml/2006/main">
               <a:ext uri="{FF2B5EF4-FFF2-40B4-BE49-F238E27FC236}">
-                <a16:creationId xmlns:a16="http://schemas.microsoft.com/office/drawing/2014/main" id="{751E6DB8-525E-4D4F-8CFB-224EEBC90FE9}"/>
+                <a16:creationId xmlns:a16="http://schemas.microsoft.com/office/drawing/2014/main" id="{F3EF8D4C-93C7-4848-A06A-7713385E1F44}"/>
               </a:ext>
             </a:extLst>
           </p:cNvPr>
@@ -9800,10 +9800,10 @@
       </p:sp>
       <p:sp>
         <p:nvSpPr>
-          <p:cNvPr id="6" name="">
+          <p:cNvPr id="5" name="">
             <a:extLst xmlns:a="http://schemas.openxmlformats.org/drawingml/2006/main">
               <a:ext uri="{FF2B5EF4-FFF2-40B4-BE49-F238E27FC236}">
-                <a16:creationId xmlns:a16="http://schemas.microsoft.com/office/drawing/2014/main" id="{0D046C89-C0CD-4F46-A9C3-67962078C4C4}"/>
+                <a16:creationId xmlns:a16="http://schemas.microsoft.com/office/drawing/2014/main" id="{4E31C771-146D-4DF6-BA60-8FE333D5D830}"/>
               </a:ext>
             </a:extLst>
           </p:cNvPr>
@@ -9962,10 +9962,10 @@
       </p:sp>
       <p:sp>
         <p:nvSpPr>
-          <p:cNvPr id="7" name="">
+          <p:cNvPr id="6" name="">
             <a:extLst xmlns:a="http://schemas.openxmlformats.org/drawingml/2006/main">
               <a:ext uri="{FF2B5EF4-FFF2-40B4-BE49-F238E27FC236}">
-                <a16:creationId xmlns:a16="http://schemas.microsoft.com/office/drawing/2014/main" id="{7B3A30A9-8DDF-45FD-8539-8420DCA37BCE}"/>
+                <a16:creationId xmlns:a16="http://schemas.microsoft.com/office/drawing/2014/main" id="{2A41746F-3D78-46AB-BDFD-563DC81FD2C2}"/>
               </a:ext>
             </a:extLst>
           </p:cNvPr>
@@ -10120,10 +10120,10 @@
       </p:sp>
       <p:sp>
         <p:nvSpPr>
-          <p:cNvPr id="8" name="">
+          <p:cNvPr id="7" name="">
             <a:extLst xmlns:a="http://schemas.openxmlformats.org/drawingml/2006/main">
               <a:ext uri="{FF2B5EF4-FFF2-40B4-BE49-F238E27FC236}">
-                <a16:creationId xmlns:a16="http://schemas.microsoft.com/office/drawing/2014/main" id="{BB859073-F35D-43C8-9ACE-339F37F73258}"/>
+                <a16:creationId xmlns:a16="http://schemas.microsoft.com/office/drawing/2014/main" id="{94508DED-9250-4127-9E0B-38B51E88AE90}"/>
               </a:ext>
             </a:extLst>
           </p:cNvPr>
@@ -10282,10 +10282,10 @@
       </p:sp>
       <p:sp>
         <p:nvSpPr>
-          <p:cNvPr id="9" name="">
+          <p:cNvPr id="8" name="">
             <a:extLst xmlns:a="http://schemas.openxmlformats.org/drawingml/2006/main">
               <a:ext uri="{FF2B5EF4-FFF2-40B4-BE49-F238E27FC236}">
-                <a16:creationId xmlns:a16="http://schemas.microsoft.com/office/drawing/2014/main" id="{B73DA9CE-A003-4103-810C-B903C435BE11}"/>
+                <a16:creationId xmlns:a16="http://schemas.microsoft.com/office/drawing/2014/main" id="{552B5A2C-0C3B-4DA1-89E4-01A11D0B1F41}"/>
               </a:ext>
             </a:extLst>
           </p:cNvPr>
@@ -10444,10 +10444,10 @@
       </p:sp>
       <p:sp>
         <p:nvSpPr>
-          <p:cNvPr id="10" name="">
+          <p:cNvPr id="9" name="">
             <a:extLst xmlns:a="http://schemas.openxmlformats.org/drawingml/2006/main">
               <a:ext uri="{FF2B5EF4-FFF2-40B4-BE49-F238E27FC236}">
-                <a16:creationId xmlns:a16="http://schemas.microsoft.com/office/drawing/2014/main" id="{D4FDE3D5-E1F5-444C-9336-B6331E425B5E}"/>
+                <a16:creationId xmlns:a16="http://schemas.microsoft.com/office/drawing/2014/main" id="{9644361D-A933-4420-B09B-600C897A7413}"/>
               </a:ext>
             </a:extLst>
           </p:cNvPr>
@@ -10606,10 +10606,10 @@
       </p:sp>
       <p:sp>
         <p:nvSpPr>
-          <p:cNvPr id="11" name="">
+          <p:cNvPr id="10" name="">
             <a:extLst xmlns:a="http://schemas.openxmlformats.org/drawingml/2006/main">
               <a:ext uri="{FF2B5EF4-FFF2-40B4-BE49-F238E27FC236}">
-                <a16:creationId xmlns:a16="http://schemas.microsoft.com/office/drawing/2014/main" id="{DC9A99EB-6EBF-4250-BE97-9A001D69F770}"/>
+                <a16:creationId xmlns:a16="http://schemas.microsoft.com/office/drawing/2014/main" id="{BE9E15FF-F36F-47E7-A3F9-3EB81DB822EF}"/>
               </a:ext>
             </a:extLst>
           </p:cNvPr>
@@ -10768,10 +10768,10 @@
       </p:sp>
       <p:sp>
         <p:nvSpPr>
-          <p:cNvPr id="12" name="">
+          <p:cNvPr id="11" name="">
             <a:extLst xmlns:a="http://schemas.openxmlformats.org/drawingml/2006/main">
               <a:ext uri="{FF2B5EF4-FFF2-40B4-BE49-F238E27FC236}">
-                <a16:creationId xmlns:a16="http://schemas.microsoft.com/office/drawing/2014/main" id="{C2967BEE-8482-4E42-84F4-CA21DD3151FF}"/>
+                <a16:creationId xmlns:a16="http://schemas.microsoft.com/office/drawing/2014/main" id="{9113AECA-EA2E-467E-A1F5-B2D94A922464}"/>
               </a:ext>
             </a:extLst>
           </p:cNvPr>
@@ -10926,10 +10926,10 @@
       </p:sp>
       <p:sp>
         <p:nvSpPr>
-          <p:cNvPr id="13" name="">
+          <p:cNvPr id="12" name="">
             <a:extLst xmlns:a="http://schemas.openxmlformats.org/drawingml/2006/main">
               <a:ext uri="{FF2B5EF4-FFF2-40B4-BE49-F238E27FC236}">
-                <a16:creationId xmlns:a16="http://schemas.microsoft.com/office/drawing/2014/main" id="{80F0AEDA-5B75-4452-9C50-613071888B56}"/>
+                <a16:creationId xmlns:a16="http://schemas.microsoft.com/office/drawing/2014/main" id="{0541DAC9-F9B8-4510-8E36-8C06AF2A5582}"/>
               </a:ext>
             </a:extLst>
           </p:cNvPr>
@@ -10940,8 +10940,8 @@
         </p:nvSpPr>
         <p:spPr>
           <a:xfrm xmlns:a="http://schemas.openxmlformats.org/drawingml/2006/main">
-            <a:off x="666750" y="5753100"/>
-            <a:ext cx="10858500" cy="619125"/>
+            <a:off x="666750" y="5695950"/>
+            <a:ext cx="3524250" cy="342900"/>
           </a:xfrm>
           <a:prstGeom xmlns:a="http://schemas.openxmlformats.org/drawingml/2006/main" prst="rect">
             <a:avLst/>
@@ -10957,7 +10957,7 @@
           </a:bodyPr>
           <a:lstStyle xmlns:a="http://schemas.openxmlformats.org/drawingml/2006/main">
             <a:defPPr>
-              <a:defRPr sz="1875">
+              <a:defRPr sz="1875" b="1">
                 <a:solidFill>
                   <a:srgbClr val="172B3A"/>
                 </a:solidFill>
@@ -10967,7 +10967,7 @@
               </a:defRPr>
             </a:defPPr>
             <a:lvl1pPr>
-              <a:defRPr sz="1875">
+              <a:defRPr sz="1875" b="1">
                 <a:solidFill>
                   <a:srgbClr val="172B3A"/>
                 </a:solidFill>
@@ -10977,7 +10977,7 @@
               </a:defRPr>
             </a:lvl1pPr>
             <a:lvl2pPr>
-              <a:defRPr sz="1875">
+              <a:defRPr sz="1875" b="1">
                 <a:solidFill>
                   <a:srgbClr val="172B3A"/>
                 </a:solidFill>
@@ -10987,7 +10987,7 @@
               </a:defRPr>
             </a:lvl2pPr>
             <a:lvl3pPr>
-              <a:defRPr sz="1875">
+              <a:defRPr sz="1875" b="1">
                 <a:solidFill>
                   <a:srgbClr val="172B3A"/>
                 </a:solidFill>
@@ -10997,7 +10997,7 @@
               </a:defRPr>
             </a:lvl3pPr>
             <a:lvl4pPr>
-              <a:defRPr sz="1875">
+              <a:defRPr sz="1875" b="1">
                 <a:solidFill>
                   <a:srgbClr val="172B3A"/>
                 </a:solidFill>
@@ -11007,7 +11007,7 @@
               </a:defRPr>
             </a:lvl4pPr>
             <a:lvl5pPr>
-              <a:defRPr sz="1875">
+              <a:defRPr sz="1875" b="1">
                 <a:solidFill>
                   <a:srgbClr val="172B3A"/>
                 </a:solidFill>
@@ -11017,7 +11017,7 @@
               </a:defRPr>
             </a:lvl5pPr>
             <a:lvl6pPr>
-              <a:defRPr sz="1875">
+              <a:defRPr sz="1875" b="1">
                 <a:solidFill>
                   <a:srgbClr val="172B3A"/>
                 </a:solidFill>
@@ -11027,7 +11027,7 @@
               </a:defRPr>
             </a:lvl6pPr>
             <a:lvl7pPr>
-              <a:defRPr sz="1875">
+              <a:defRPr sz="1875" b="1">
                 <a:solidFill>
                   <a:srgbClr val="172B3A"/>
                 </a:solidFill>
@@ -11037,7 +11037,7 @@
               </a:defRPr>
             </a:lvl7pPr>
             <a:lvl8pPr>
-              <a:defRPr sz="1875">
+              <a:defRPr sz="1875" b="1">
                 <a:solidFill>
                   <a:srgbClr val="172B3A"/>
                 </a:solidFill>
@@ -11047,7 +11047,7 @@
               </a:defRPr>
             </a:lvl8pPr>
             <a:lvl9pPr>
-              <a:defRPr sz="1875">
+              <a:defRPr sz="1875" b="1">
                 <a:solidFill>
                   <a:srgbClr val="172B3A"/>
                 </a:solidFill>
@@ -11059,7 +11059,7 @@
           </a:lstStyle>
           <a:p xmlns:a="http://schemas.openxmlformats.org/drawingml/2006/main">
             <a:pPr>
-              <a:defRPr sz="1875">
+              <a:defRPr sz="1875" b="1">
                 <a:solidFill>
                   <a:srgbClr val="172B3A"/>
                 </a:solidFill>
@@ -11069,7 +11069,7 @@
               </a:defRPr>
             </a:pPr>
             <a:r>
-              <a:rPr sz="1875">
+              <a:rPr sz="1875" b="1">
                 <a:solidFill>
                   <a:srgbClr val="172B3A"/>
                 </a:solidFill>
@@ -11077,14 +11077,149 @@
                 <a:ea typeface="Arial"/>
                 <a:cs typeface="Arial"/>
               </a:rPr>
-              <a:t>Name: [Your name]</a:t>
+              <a:t>Vihaan Jinesh Jain</a:t>
             </a:r>
           </a:p>
+        </p:txBody>
+      </p:sp>
+      <p:sp>
+        <p:nvSpPr>
+          <p:cNvPr id="13" name="">
+            <a:extLst xmlns:a="http://schemas.openxmlformats.org/drawingml/2006/main">
+              <a:ext uri="{FF2B5EF4-FFF2-40B4-BE49-F238E27FC236}">
+                <a16:creationId xmlns:a16="http://schemas.microsoft.com/office/drawing/2014/main" id="{4A2C14C5-446A-4514-8280-6B677FAA3AA6}"/>
+              </a:ext>
+            </a:extLst>
+          </p:cNvPr>
+          <p:cNvSpPr>
+            <a:spLocks xmlns:a="http://schemas.openxmlformats.org/drawingml/2006/main" noGrp="1"/>
+          </p:cNvSpPr>
+          <p:nvPr/>
+        </p:nvSpPr>
+        <p:spPr>
+          <a:xfrm xmlns:a="http://schemas.openxmlformats.org/drawingml/2006/main">
+            <a:off x="666750" y="6067425"/>
+            <a:ext cx="3524250" cy="285750"/>
+          </a:xfrm>
+          <a:prstGeom xmlns:a="http://schemas.openxmlformats.org/drawingml/2006/main" prst="rect">
+            <a:avLst/>
+          </a:prstGeom>
+          <a:noFill xmlns:a="http://schemas.openxmlformats.org/drawingml/2006/main"/>
+          <a:ln xmlns:a="http://schemas.openxmlformats.org/drawingml/2006/main" w="0">
+            <a:noFill/>
+          </a:ln>
+        </p:spPr>
+        <p:txBody>
+          <a:bodyPr xmlns:a="http://schemas.openxmlformats.org/drawingml/2006/main" wrap="square" lIns="0" tIns="0" rIns="0" bIns="0">
+            <a:noAutofit/>
+          </a:bodyPr>
+          <a:lstStyle xmlns:a="http://schemas.openxmlformats.org/drawingml/2006/main">
+            <a:defPPr>
+              <a:defRPr sz="1725">
+                <a:solidFill>
+                  <a:srgbClr val="637E8E"/>
+                </a:solidFill>
+                <a:latin typeface="Arial"/>
+                <a:ea typeface="Arial"/>
+                <a:cs typeface="Arial"/>
+              </a:defRPr>
+            </a:defPPr>
+            <a:lvl1pPr>
+              <a:defRPr sz="1725">
+                <a:solidFill>
+                  <a:srgbClr val="637E8E"/>
+                </a:solidFill>
+                <a:latin typeface="Arial"/>
+                <a:ea typeface="Arial"/>
+                <a:cs typeface="Arial"/>
+              </a:defRPr>
+            </a:lvl1pPr>
+            <a:lvl2pPr>
+              <a:defRPr sz="1725">
+                <a:solidFill>
+                  <a:srgbClr val="637E8E"/>
+                </a:solidFill>
+                <a:latin typeface="Arial"/>
+                <a:ea typeface="Arial"/>
+                <a:cs typeface="Arial"/>
+              </a:defRPr>
+            </a:lvl2pPr>
+            <a:lvl3pPr>
+              <a:defRPr sz="1725">
+                <a:solidFill>
+                  <a:srgbClr val="637E8E"/>
+                </a:solidFill>
+                <a:latin typeface="Arial"/>
+                <a:ea typeface="Arial"/>
+                <a:cs typeface="Arial"/>
+              </a:defRPr>
+            </a:lvl3pPr>
+            <a:lvl4pPr>
+              <a:defRPr sz="1725">
+                <a:solidFill>
+                  <a:srgbClr val="637E8E"/>
+                </a:solidFill>
+                <a:latin typeface="Arial"/>
+                <a:ea typeface="Arial"/>
+                <a:cs typeface="Arial"/>
+              </a:defRPr>
+            </a:lvl4pPr>
+            <a:lvl5pPr>
+              <a:defRPr sz="1725">
+                <a:solidFill>
+                  <a:srgbClr val="637E8E"/>
+                </a:solidFill>
+                <a:latin typeface="Arial"/>
+                <a:ea typeface="Arial"/>
+                <a:cs typeface="Arial"/>
+              </a:defRPr>
+            </a:lvl5pPr>
+            <a:lvl6pPr>
+              <a:defRPr sz="1725">
+                <a:solidFill>
+                  <a:srgbClr val="637E8E"/>
+                </a:solidFill>
+                <a:latin typeface="Arial"/>
+                <a:ea typeface="Arial"/>
+                <a:cs typeface="Arial"/>
+              </a:defRPr>
+            </a:lvl6pPr>
+            <a:lvl7pPr>
+              <a:defRPr sz="1725">
+                <a:solidFill>
+                  <a:srgbClr val="637E8E"/>
+                </a:solidFill>
+                <a:latin typeface="Arial"/>
+                <a:ea typeface="Arial"/>
+                <a:cs typeface="Arial"/>
+              </a:defRPr>
+            </a:lvl7pPr>
+            <a:lvl8pPr>
+              <a:defRPr sz="1725">
+                <a:solidFill>
+                  <a:srgbClr val="637E8E"/>
+                </a:solidFill>
+                <a:latin typeface="Arial"/>
+                <a:ea typeface="Arial"/>
+                <a:cs typeface="Arial"/>
+              </a:defRPr>
+            </a:lvl8pPr>
+            <a:lvl9pPr>
+              <a:defRPr sz="1725">
+                <a:solidFill>
+                  <a:srgbClr val="637E8E"/>
+                </a:solidFill>
+                <a:latin typeface="Arial"/>
+                <a:ea typeface="Arial"/>
+                <a:cs typeface="Arial"/>
+              </a:defRPr>
+            </a:lvl9pPr>
+          </a:lstStyle>
           <a:p xmlns:a="http://schemas.openxmlformats.org/drawingml/2006/main">
             <a:pPr>
-              <a:defRPr sz="1875">
-                <a:solidFill>
-                  <a:srgbClr val="172B3A"/>
+              <a:defRPr sz="1725">
+                <a:solidFill>
+                  <a:srgbClr val="637E8E"/>
                 </a:solidFill>
                 <a:latin typeface="Arial"/>
                 <a:ea typeface="Arial"/>
@@ -11092,15 +11227,647 @@
               </a:defRPr>
             </a:pPr>
             <a:r>
-              <a:rPr sz="1875">
-                <a:solidFill>
-                  <a:srgbClr val="172B3A"/>
+              <a:rPr sz="1725">
+                <a:solidFill>
+                  <a:srgbClr val="637E8E"/>
                 </a:solidFill>
                 <a:latin typeface="Arial"/>
                 <a:ea typeface="Arial"/>
                 <a:cs typeface="Arial"/>
               </a:rPr>
-              <a:t>Registration: [Your registration number]</a:t>
+              <a:t>25BYB0103</a:t>
+            </a:r>
+          </a:p>
+        </p:txBody>
+      </p:sp>
+      <p:sp>
+        <p:nvSpPr>
+          <p:cNvPr id="14" name="">
+            <a:extLst xmlns:a="http://schemas.openxmlformats.org/drawingml/2006/main">
+              <a:ext uri="{FF2B5EF4-FFF2-40B4-BE49-F238E27FC236}">
+                <a16:creationId xmlns:a16="http://schemas.microsoft.com/office/drawing/2014/main" id="{40088458-9B29-4ED7-8CA0-E6552CA7FD92}"/>
+              </a:ext>
+            </a:extLst>
+          </p:cNvPr>
+          <p:cNvSpPr>
+            <a:spLocks xmlns:a="http://schemas.openxmlformats.org/drawingml/2006/main" noGrp="1"/>
+          </p:cNvSpPr>
+          <p:nvPr/>
+        </p:nvSpPr>
+        <p:spPr>
+          <a:xfrm xmlns:a="http://schemas.openxmlformats.org/drawingml/2006/main">
+            <a:off x="4381500" y="5695950"/>
+            <a:ext cx="3524250" cy="342900"/>
+          </a:xfrm>
+          <a:prstGeom xmlns:a="http://schemas.openxmlformats.org/drawingml/2006/main" prst="rect">
+            <a:avLst/>
+          </a:prstGeom>
+          <a:noFill xmlns:a="http://schemas.openxmlformats.org/drawingml/2006/main"/>
+          <a:ln xmlns:a="http://schemas.openxmlformats.org/drawingml/2006/main" w="0">
+            <a:noFill/>
+          </a:ln>
+        </p:spPr>
+        <p:txBody>
+          <a:bodyPr xmlns:a="http://schemas.openxmlformats.org/drawingml/2006/main" wrap="square" lIns="0" tIns="0" rIns="0" bIns="0">
+            <a:noAutofit/>
+          </a:bodyPr>
+          <a:lstStyle xmlns:a="http://schemas.openxmlformats.org/drawingml/2006/main">
+            <a:defPPr>
+              <a:defRPr sz="1875" b="1">
+                <a:solidFill>
+                  <a:srgbClr val="172B3A"/>
+                </a:solidFill>
+                <a:latin typeface="Arial"/>
+                <a:ea typeface="Arial"/>
+                <a:cs typeface="Arial"/>
+              </a:defRPr>
+            </a:defPPr>
+            <a:lvl1pPr>
+              <a:defRPr sz="1875" b="1">
+                <a:solidFill>
+                  <a:srgbClr val="172B3A"/>
+                </a:solidFill>
+                <a:latin typeface="Arial"/>
+                <a:ea typeface="Arial"/>
+                <a:cs typeface="Arial"/>
+              </a:defRPr>
+            </a:lvl1pPr>
+            <a:lvl2pPr>
+              <a:defRPr sz="1875" b="1">
+                <a:solidFill>
+                  <a:srgbClr val="172B3A"/>
+                </a:solidFill>
+                <a:latin typeface="Arial"/>
+                <a:ea typeface="Arial"/>
+                <a:cs typeface="Arial"/>
+              </a:defRPr>
+            </a:lvl2pPr>
+            <a:lvl3pPr>
+              <a:defRPr sz="1875" b="1">
+                <a:solidFill>
+                  <a:srgbClr val="172B3A"/>
+                </a:solidFill>
+                <a:latin typeface="Arial"/>
+                <a:ea typeface="Arial"/>
+                <a:cs typeface="Arial"/>
+              </a:defRPr>
+            </a:lvl3pPr>
+            <a:lvl4pPr>
+              <a:defRPr sz="1875" b="1">
+                <a:solidFill>
+                  <a:srgbClr val="172B3A"/>
+                </a:solidFill>
+                <a:latin typeface="Arial"/>
+                <a:ea typeface="Arial"/>
+                <a:cs typeface="Arial"/>
+              </a:defRPr>
+            </a:lvl4pPr>
+            <a:lvl5pPr>
+              <a:defRPr sz="1875" b="1">
+                <a:solidFill>
+                  <a:srgbClr val="172B3A"/>
+                </a:solidFill>
+                <a:latin typeface="Arial"/>
+                <a:ea typeface="Arial"/>
+                <a:cs typeface="Arial"/>
+              </a:defRPr>
+            </a:lvl5pPr>
+            <a:lvl6pPr>
+              <a:defRPr sz="1875" b="1">
+                <a:solidFill>
+                  <a:srgbClr val="172B3A"/>
+                </a:solidFill>
+                <a:latin typeface="Arial"/>
+                <a:ea typeface="Arial"/>
+                <a:cs typeface="Arial"/>
+              </a:defRPr>
+            </a:lvl6pPr>
+            <a:lvl7pPr>
+              <a:defRPr sz="1875" b="1">
+                <a:solidFill>
+                  <a:srgbClr val="172B3A"/>
+                </a:solidFill>
+                <a:latin typeface="Arial"/>
+                <a:ea typeface="Arial"/>
+                <a:cs typeface="Arial"/>
+              </a:defRPr>
+            </a:lvl7pPr>
+            <a:lvl8pPr>
+              <a:defRPr sz="1875" b="1">
+                <a:solidFill>
+                  <a:srgbClr val="172B3A"/>
+                </a:solidFill>
+                <a:latin typeface="Arial"/>
+                <a:ea typeface="Arial"/>
+                <a:cs typeface="Arial"/>
+              </a:defRPr>
+            </a:lvl8pPr>
+            <a:lvl9pPr>
+              <a:defRPr sz="1875" b="1">
+                <a:solidFill>
+                  <a:srgbClr val="172B3A"/>
+                </a:solidFill>
+                <a:latin typeface="Arial"/>
+                <a:ea typeface="Arial"/>
+                <a:cs typeface="Arial"/>
+              </a:defRPr>
+            </a:lvl9pPr>
+          </a:lstStyle>
+          <a:p xmlns:a="http://schemas.openxmlformats.org/drawingml/2006/main">
+            <a:pPr>
+              <a:defRPr sz="1875" b="1">
+                <a:solidFill>
+                  <a:srgbClr val="172B3A"/>
+                </a:solidFill>
+                <a:latin typeface="Arial"/>
+                <a:ea typeface="Arial"/>
+                <a:cs typeface="Arial"/>
+              </a:defRPr>
+            </a:pPr>
+            <a:r>
+              <a:rPr sz="1875" b="1">
+                <a:solidFill>
+                  <a:srgbClr val="172B3A"/>
+                </a:solidFill>
+                <a:latin typeface="Arial"/>
+                <a:ea typeface="Arial"/>
+                <a:cs typeface="Arial"/>
+              </a:rPr>
+              <a:t>Kaashvi Goel</a:t>
+            </a:r>
+          </a:p>
+        </p:txBody>
+      </p:sp>
+      <p:sp>
+        <p:nvSpPr>
+          <p:cNvPr id="15" name="">
+            <a:extLst xmlns:a="http://schemas.openxmlformats.org/drawingml/2006/main">
+              <a:ext uri="{FF2B5EF4-FFF2-40B4-BE49-F238E27FC236}">
+                <a16:creationId xmlns:a16="http://schemas.microsoft.com/office/drawing/2014/main" id="{FB3D9CF0-FA10-422A-9517-693D81E65E9E}"/>
+              </a:ext>
+            </a:extLst>
+          </p:cNvPr>
+          <p:cNvSpPr>
+            <a:spLocks xmlns:a="http://schemas.openxmlformats.org/drawingml/2006/main" noGrp="1"/>
+          </p:cNvSpPr>
+          <p:nvPr/>
+        </p:nvSpPr>
+        <p:spPr>
+          <a:xfrm xmlns:a="http://schemas.openxmlformats.org/drawingml/2006/main">
+            <a:off x="4381500" y="6067425"/>
+            <a:ext cx="3524250" cy="285750"/>
+          </a:xfrm>
+          <a:prstGeom xmlns:a="http://schemas.openxmlformats.org/drawingml/2006/main" prst="rect">
+            <a:avLst/>
+          </a:prstGeom>
+          <a:noFill xmlns:a="http://schemas.openxmlformats.org/drawingml/2006/main"/>
+          <a:ln xmlns:a="http://schemas.openxmlformats.org/drawingml/2006/main" w="0">
+            <a:noFill/>
+          </a:ln>
+        </p:spPr>
+        <p:txBody>
+          <a:bodyPr xmlns:a="http://schemas.openxmlformats.org/drawingml/2006/main" wrap="square" lIns="0" tIns="0" rIns="0" bIns="0">
+            <a:noAutofit/>
+          </a:bodyPr>
+          <a:lstStyle xmlns:a="http://schemas.openxmlformats.org/drawingml/2006/main">
+            <a:defPPr>
+              <a:defRPr sz="1725">
+                <a:solidFill>
+                  <a:srgbClr val="637E8E"/>
+                </a:solidFill>
+                <a:latin typeface="Arial"/>
+                <a:ea typeface="Arial"/>
+                <a:cs typeface="Arial"/>
+              </a:defRPr>
+            </a:defPPr>
+            <a:lvl1pPr>
+              <a:defRPr sz="1725">
+                <a:solidFill>
+                  <a:srgbClr val="637E8E"/>
+                </a:solidFill>
+                <a:latin typeface="Arial"/>
+                <a:ea typeface="Arial"/>
+                <a:cs typeface="Arial"/>
+              </a:defRPr>
+            </a:lvl1pPr>
+            <a:lvl2pPr>
+              <a:defRPr sz="1725">
+                <a:solidFill>
+                  <a:srgbClr val="637E8E"/>
+                </a:solidFill>
+                <a:latin typeface="Arial"/>
+                <a:ea typeface="Arial"/>
+                <a:cs typeface="Arial"/>
+              </a:defRPr>
+            </a:lvl2pPr>
+            <a:lvl3pPr>
+              <a:defRPr sz="1725">
+                <a:solidFill>
+                  <a:srgbClr val="637E8E"/>
+                </a:solidFill>
+                <a:latin typeface="Arial"/>
+                <a:ea typeface="Arial"/>
+                <a:cs typeface="Arial"/>
+              </a:defRPr>
+            </a:lvl3pPr>
+            <a:lvl4pPr>
+              <a:defRPr sz="1725">
+                <a:solidFill>
+                  <a:srgbClr val="637E8E"/>
+                </a:solidFill>
+                <a:latin typeface="Arial"/>
+                <a:ea typeface="Arial"/>
+                <a:cs typeface="Arial"/>
+              </a:defRPr>
+            </a:lvl4pPr>
+            <a:lvl5pPr>
+              <a:defRPr sz="1725">
+                <a:solidFill>
+                  <a:srgbClr val="637E8E"/>
+                </a:solidFill>
+                <a:latin typeface="Arial"/>
+                <a:ea typeface="Arial"/>
+                <a:cs typeface="Arial"/>
+              </a:defRPr>
+            </a:lvl5pPr>
+            <a:lvl6pPr>
+              <a:defRPr sz="1725">
+                <a:solidFill>
+                  <a:srgbClr val="637E8E"/>
+                </a:solidFill>
+                <a:latin typeface="Arial"/>
+                <a:ea typeface="Arial"/>
+                <a:cs typeface="Arial"/>
+              </a:defRPr>
+            </a:lvl6pPr>
+            <a:lvl7pPr>
+              <a:defRPr sz="1725">
+                <a:solidFill>
+                  <a:srgbClr val="637E8E"/>
+                </a:solidFill>
+                <a:latin typeface="Arial"/>
+                <a:ea typeface="Arial"/>
+                <a:cs typeface="Arial"/>
+              </a:defRPr>
+            </a:lvl7pPr>
+            <a:lvl8pPr>
+              <a:defRPr sz="1725">
+                <a:solidFill>
+                  <a:srgbClr val="637E8E"/>
+                </a:solidFill>
+                <a:latin typeface="Arial"/>
+                <a:ea typeface="Arial"/>
+                <a:cs typeface="Arial"/>
+              </a:defRPr>
+            </a:lvl8pPr>
+            <a:lvl9pPr>
+              <a:defRPr sz="1725">
+                <a:solidFill>
+                  <a:srgbClr val="637E8E"/>
+                </a:solidFill>
+                <a:latin typeface="Arial"/>
+                <a:ea typeface="Arial"/>
+                <a:cs typeface="Arial"/>
+              </a:defRPr>
+            </a:lvl9pPr>
+          </a:lstStyle>
+          <a:p xmlns:a="http://schemas.openxmlformats.org/drawingml/2006/main">
+            <a:pPr>
+              <a:defRPr sz="1725">
+                <a:solidFill>
+                  <a:srgbClr val="637E8E"/>
+                </a:solidFill>
+                <a:latin typeface="Arial"/>
+                <a:ea typeface="Arial"/>
+                <a:cs typeface="Arial"/>
+              </a:defRPr>
+            </a:pPr>
+            <a:r>
+              <a:rPr sz="1725">
+                <a:solidFill>
+                  <a:srgbClr val="637E8E"/>
+                </a:solidFill>
+                <a:latin typeface="Arial"/>
+                <a:ea typeface="Arial"/>
+                <a:cs typeface="Arial"/>
+              </a:rPr>
+              <a:t>25BYB0129</a:t>
+            </a:r>
+          </a:p>
+        </p:txBody>
+      </p:sp>
+      <p:sp>
+        <p:nvSpPr>
+          <p:cNvPr id="16" name="">
+            <a:extLst xmlns:a="http://schemas.openxmlformats.org/drawingml/2006/main">
+              <a:ext uri="{FF2B5EF4-FFF2-40B4-BE49-F238E27FC236}">
+                <a16:creationId xmlns:a16="http://schemas.microsoft.com/office/drawing/2014/main" id="{537E54EF-4578-4FD5-B090-CCDB672DC95B}"/>
+              </a:ext>
+            </a:extLst>
+          </p:cNvPr>
+          <p:cNvSpPr>
+            <a:spLocks xmlns:a="http://schemas.openxmlformats.org/drawingml/2006/main" noGrp="1"/>
+          </p:cNvSpPr>
+          <p:nvPr/>
+        </p:nvSpPr>
+        <p:spPr>
+          <a:xfrm xmlns:a="http://schemas.openxmlformats.org/drawingml/2006/main">
+            <a:off x="8096250" y="5695950"/>
+            <a:ext cx="3524250" cy="342900"/>
+          </a:xfrm>
+          <a:prstGeom xmlns:a="http://schemas.openxmlformats.org/drawingml/2006/main" prst="rect">
+            <a:avLst/>
+          </a:prstGeom>
+          <a:noFill xmlns:a="http://schemas.openxmlformats.org/drawingml/2006/main"/>
+          <a:ln xmlns:a="http://schemas.openxmlformats.org/drawingml/2006/main" w="0">
+            <a:noFill/>
+          </a:ln>
+        </p:spPr>
+        <p:txBody>
+          <a:bodyPr xmlns:a="http://schemas.openxmlformats.org/drawingml/2006/main" wrap="square" lIns="0" tIns="0" rIns="0" bIns="0">
+            <a:noAutofit/>
+          </a:bodyPr>
+          <a:lstStyle xmlns:a="http://schemas.openxmlformats.org/drawingml/2006/main">
+            <a:defPPr>
+              <a:defRPr sz="1875" b="1">
+                <a:solidFill>
+                  <a:srgbClr val="172B3A"/>
+                </a:solidFill>
+                <a:latin typeface="Arial"/>
+                <a:ea typeface="Arial"/>
+                <a:cs typeface="Arial"/>
+              </a:defRPr>
+            </a:defPPr>
+            <a:lvl1pPr>
+              <a:defRPr sz="1875" b="1">
+                <a:solidFill>
+                  <a:srgbClr val="172B3A"/>
+                </a:solidFill>
+                <a:latin typeface="Arial"/>
+                <a:ea typeface="Arial"/>
+                <a:cs typeface="Arial"/>
+              </a:defRPr>
+            </a:lvl1pPr>
+            <a:lvl2pPr>
+              <a:defRPr sz="1875" b="1">
+                <a:solidFill>
+                  <a:srgbClr val="172B3A"/>
+                </a:solidFill>
+                <a:latin typeface="Arial"/>
+                <a:ea typeface="Arial"/>
+                <a:cs typeface="Arial"/>
+              </a:defRPr>
+            </a:lvl2pPr>
+            <a:lvl3pPr>
+              <a:defRPr sz="1875" b="1">
+                <a:solidFill>
+                  <a:srgbClr val="172B3A"/>
+                </a:solidFill>
+                <a:latin typeface="Arial"/>
+                <a:ea typeface="Arial"/>
+                <a:cs typeface="Arial"/>
+              </a:defRPr>
+            </a:lvl3pPr>
+            <a:lvl4pPr>
+              <a:defRPr sz="1875" b="1">
+                <a:solidFill>
+                  <a:srgbClr val="172B3A"/>
+                </a:solidFill>
+                <a:latin typeface="Arial"/>
+                <a:ea typeface="Arial"/>
+                <a:cs typeface="Arial"/>
+              </a:defRPr>
+            </a:lvl4pPr>
+            <a:lvl5pPr>
+              <a:defRPr sz="1875" b="1">
+                <a:solidFill>
+                  <a:srgbClr val="172B3A"/>
+                </a:solidFill>
+                <a:latin typeface="Arial"/>
+                <a:ea typeface="Arial"/>
+                <a:cs typeface="Arial"/>
+              </a:defRPr>
+            </a:lvl5pPr>
+            <a:lvl6pPr>
+              <a:defRPr sz="1875" b="1">
+                <a:solidFill>
+                  <a:srgbClr val="172B3A"/>
+                </a:solidFill>
+                <a:latin typeface="Arial"/>
+                <a:ea typeface="Arial"/>
+                <a:cs typeface="Arial"/>
+              </a:defRPr>
+            </a:lvl6pPr>
+            <a:lvl7pPr>
+              <a:defRPr sz="1875" b="1">
+                <a:solidFill>
+                  <a:srgbClr val="172B3A"/>
+                </a:solidFill>
+                <a:latin typeface="Arial"/>
+                <a:ea typeface="Arial"/>
+                <a:cs typeface="Arial"/>
+              </a:defRPr>
+            </a:lvl7pPr>
+            <a:lvl8pPr>
+              <a:defRPr sz="1875" b="1">
+                <a:solidFill>
+                  <a:srgbClr val="172B3A"/>
+                </a:solidFill>
+                <a:latin typeface="Arial"/>
+                <a:ea typeface="Arial"/>
+                <a:cs typeface="Arial"/>
+              </a:defRPr>
+            </a:lvl8pPr>
+            <a:lvl9pPr>
+              <a:defRPr sz="1875" b="1">
+                <a:solidFill>
+                  <a:srgbClr val="172B3A"/>
+                </a:solidFill>
+                <a:latin typeface="Arial"/>
+                <a:ea typeface="Arial"/>
+                <a:cs typeface="Arial"/>
+              </a:defRPr>
+            </a:lvl9pPr>
+          </a:lstStyle>
+          <a:p xmlns:a="http://schemas.openxmlformats.org/drawingml/2006/main">
+            <a:pPr>
+              <a:defRPr sz="1875" b="1">
+                <a:solidFill>
+                  <a:srgbClr val="172B3A"/>
+                </a:solidFill>
+                <a:latin typeface="Arial"/>
+                <a:ea typeface="Arial"/>
+                <a:cs typeface="Arial"/>
+              </a:defRPr>
+            </a:pPr>
+            <a:r>
+              <a:rPr sz="1875" b="1">
+                <a:solidFill>
+                  <a:srgbClr val="172B3A"/>
+                </a:solidFill>
+                <a:latin typeface="Arial"/>
+                <a:ea typeface="Arial"/>
+                <a:cs typeface="Arial"/>
+              </a:rPr>
+              <a:t>Gaurav Kansal</a:t>
+            </a:r>
+          </a:p>
+        </p:txBody>
+      </p:sp>
+      <p:sp>
+        <p:nvSpPr>
+          <p:cNvPr id="17" name="">
+            <a:extLst xmlns:a="http://schemas.openxmlformats.org/drawingml/2006/main">
+              <a:ext uri="{FF2B5EF4-FFF2-40B4-BE49-F238E27FC236}">
+                <a16:creationId xmlns:a16="http://schemas.microsoft.com/office/drawing/2014/main" id="{E0751116-4E98-4E7F-BF1C-D961B061141E}"/>
+              </a:ext>
+            </a:extLst>
+          </p:cNvPr>
+          <p:cNvSpPr>
+            <a:spLocks xmlns:a="http://schemas.openxmlformats.org/drawingml/2006/main" noGrp="1"/>
+          </p:cNvSpPr>
+          <p:nvPr/>
+        </p:nvSpPr>
+        <p:spPr>
+          <a:xfrm xmlns:a="http://schemas.openxmlformats.org/drawingml/2006/main">
+            <a:off x="8096250" y="6067425"/>
+            <a:ext cx="3524250" cy="285750"/>
+          </a:xfrm>
+          <a:prstGeom xmlns:a="http://schemas.openxmlformats.org/drawingml/2006/main" prst="rect">
+            <a:avLst/>
+          </a:prstGeom>
+          <a:noFill xmlns:a="http://schemas.openxmlformats.org/drawingml/2006/main"/>
+          <a:ln xmlns:a="http://schemas.openxmlformats.org/drawingml/2006/main" w="0">
+            <a:noFill/>
+          </a:ln>
+        </p:spPr>
+        <p:txBody>
+          <a:bodyPr xmlns:a="http://schemas.openxmlformats.org/drawingml/2006/main" wrap="square" lIns="0" tIns="0" rIns="0" bIns="0">
+            <a:noAutofit/>
+          </a:bodyPr>
+          <a:lstStyle xmlns:a="http://schemas.openxmlformats.org/drawingml/2006/main">
+            <a:defPPr>
+              <a:defRPr sz="1725">
+                <a:solidFill>
+                  <a:srgbClr val="637E8E"/>
+                </a:solidFill>
+                <a:latin typeface="Arial"/>
+                <a:ea typeface="Arial"/>
+                <a:cs typeface="Arial"/>
+              </a:defRPr>
+            </a:defPPr>
+            <a:lvl1pPr>
+              <a:defRPr sz="1725">
+                <a:solidFill>
+                  <a:srgbClr val="637E8E"/>
+                </a:solidFill>
+                <a:latin typeface="Arial"/>
+                <a:ea typeface="Arial"/>
+                <a:cs typeface="Arial"/>
+              </a:defRPr>
+            </a:lvl1pPr>
+            <a:lvl2pPr>
+              <a:defRPr sz="1725">
+                <a:solidFill>
+                  <a:srgbClr val="637E8E"/>
+                </a:solidFill>
+                <a:latin typeface="Arial"/>
+                <a:ea typeface="Arial"/>
+                <a:cs typeface="Arial"/>
+              </a:defRPr>
+            </a:lvl2pPr>
+            <a:lvl3pPr>
+              <a:defRPr sz="1725">
+                <a:solidFill>
+                  <a:srgbClr val="637E8E"/>
+                </a:solidFill>
+                <a:latin typeface="Arial"/>
+                <a:ea typeface="Arial"/>
+                <a:cs typeface="Arial"/>
+              </a:defRPr>
+            </a:lvl3pPr>
+            <a:lvl4pPr>
+              <a:defRPr sz="1725">
+                <a:solidFill>
+                  <a:srgbClr val="637E8E"/>
+                </a:solidFill>
+                <a:latin typeface="Arial"/>
+                <a:ea typeface="Arial"/>
+                <a:cs typeface="Arial"/>
+              </a:defRPr>
+            </a:lvl4pPr>
+            <a:lvl5pPr>
+              <a:defRPr sz="1725">
+                <a:solidFill>
+                  <a:srgbClr val="637E8E"/>
+                </a:solidFill>
+                <a:latin typeface="Arial"/>
+                <a:ea typeface="Arial"/>
+                <a:cs typeface="Arial"/>
+              </a:defRPr>
+            </a:lvl5pPr>
+            <a:lvl6pPr>
+              <a:defRPr sz="1725">
+                <a:solidFill>
+                  <a:srgbClr val="637E8E"/>
+                </a:solidFill>
+                <a:latin typeface="Arial"/>
+                <a:ea typeface="Arial"/>
+                <a:cs typeface="Arial"/>
+              </a:defRPr>
+            </a:lvl6pPr>
+            <a:lvl7pPr>
+              <a:defRPr sz="1725">
+                <a:solidFill>
+                  <a:srgbClr val="637E8E"/>
+                </a:solidFill>
+                <a:latin typeface="Arial"/>
+                <a:ea typeface="Arial"/>
+                <a:cs typeface="Arial"/>
+              </a:defRPr>
+            </a:lvl7pPr>
+            <a:lvl8pPr>
+              <a:defRPr sz="1725">
+                <a:solidFill>
+                  <a:srgbClr val="637E8E"/>
+                </a:solidFill>
+                <a:latin typeface="Arial"/>
+                <a:ea typeface="Arial"/>
+                <a:cs typeface="Arial"/>
+              </a:defRPr>
+            </a:lvl8pPr>
+            <a:lvl9pPr>
+              <a:defRPr sz="1725">
+                <a:solidFill>
+                  <a:srgbClr val="637E8E"/>
+                </a:solidFill>
+                <a:latin typeface="Arial"/>
+                <a:ea typeface="Arial"/>
+                <a:cs typeface="Arial"/>
+              </a:defRPr>
+            </a:lvl9pPr>
+          </a:lstStyle>
+          <a:p xmlns:a="http://schemas.openxmlformats.org/drawingml/2006/main">
+            <a:pPr>
+              <a:defRPr sz="1725">
+                <a:solidFill>
+                  <a:srgbClr val="637E8E"/>
+                </a:solidFill>
+                <a:latin typeface="Arial"/>
+                <a:ea typeface="Arial"/>
+                <a:cs typeface="Arial"/>
+              </a:defRPr>
+            </a:pPr>
+            <a:r>
+              <a:rPr sz="1725">
+                <a:solidFill>
+                  <a:srgbClr val="637E8E"/>
+                </a:solidFill>
+                <a:latin typeface="Arial"/>
+                <a:ea typeface="Arial"/>
+                <a:cs typeface="Arial"/>
+              </a:rPr>
+              <a:t>25BYB0157</a:t>
             </a:r>
           </a:p>
         </p:txBody>
@@ -11108,7 +11875,7 @@
     </p:spTree>
     <p:extLst>
       <p:ext uri="{BB962C8B-B14F-4D97-AF65-F5344CB8AC3E}">
-        <p14:creationId xmlns:p14="http://schemas.microsoft.com/office/powerpoint/2010/main" val="203200291"/>
+        <p14:creationId xmlns:p14="http://schemas.microsoft.com/office/powerpoint/2010/main" val="331917222"/>
       </p:ext>
     </p:extLst>
   </p:cSld>
@@ -11136,10 +11903,10 @@
       </p:grpSpPr>
       <p:sp>
         <p:nvSpPr>
-          <p:cNvPr id="2" name="">
+          <p:cNvPr id="32" name="">
             <a:extLst xmlns:a="http://schemas.openxmlformats.org/drawingml/2006/main">
               <a:ext uri="{FF2B5EF4-FFF2-40B4-BE49-F238E27FC236}">
-                <a16:creationId xmlns:a16="http://schemas.microsoft.com/office/drawing/2014/main" id="{EC25822B-0F23-4C69-83BE-84DE0D2B8E60}"/>
+                <a16:creationId xmlns:a16="http://schemas.microsoft.com/office/drawing/2014/main" id="{7C033F4A-B8E5-4023-9DB0-B465481B51CA}"/>
               </a:ext>
             </a:extLst>
           </p:cNvPr>
@@ -11294,10 +12061,10 @@
       </p:sp>
       <p:sp>
         <p:nvSpPr>
-          <p:cNvPr id="3" name="">
+          <p:cNvPr id="2" name="">
             <a:extLst xmlns:a="http://schemas.openxmlformats.org/drawingml/2006/main">
               <a:ext uri="{FF2B5EF4-FFF2-40B4-BE49-F238E27FC236}">
-                <a16:creationId xmlns:a16="http://schemas.microsoft.com/office/drawing/2014/main" id="{65750EFE-40C1-407C-9AC5-FF5A6B102A85}"/>
+                <a16:creationId xmlns:a16="http://schemas.microsoft.com/office/drawing/2014/main" id="{8CFF7541-CFD1-4BDB-A6C0-E7230C082628}"/>
               </a:ext>
             </a:extLst>
           </p:cNvPr>
@@ -11452,10 +12219,10 @@
       </p:sp>
       <p:sp>
         <p:nvSpPr>
-          <p:cNvPr id="4" name="">
+          <p:cNvPr id="3" name="">
             <a:extLst xmlns:a="http://schemas.openxmlformats.org/drawingml/2006/main">
               <a:ext uri="{FF2B5EF4-FFF2-40B4-BE49-F238E27FC236}">
-                <a16:creationId xmlns:a16="http://schemas.microsoft.com/office/drawing/2014/main" id="{E0D748D3-8F7B-4580-A402-5F3BDB32182E}"/>
+                <a16:creationId xmlns:a16="http://schemas.microsoft.com/office/drawing/2014/main" id="{A502F024-3265-44BF-9AE3-34BC64E16F9E}"/>
               </a:ext>
             </a:extLst>
           </p:cNvPr>
@@ -11610,10 +12377,10 @@
       </p:sp>
       <p:sp>
         <p:nvSpPr>
-          <p:cNvPr id="5" name="">
+          <p:cNvPr id="4" name="">
             <a:extLst xmlns:a="http://schemas.openxmlformats.org/drawingml/2006/main">
               <a:ext uri="{FF2B5EF4-FFF2-40B4-BE49-F238E27FC236}">
-                <a16:creationId xmlns:a16="http://schemas.microsoft.com/office/drawing/2014/main" id="{7C5A2CEC-EDF0-4275-8FCA-0E6639AD308D}"/>
+                <a16:creationId xmlns:a16="http://schemas.microsoft.com/office/drawing/2014/main" id="{F590C8E7-07C4-4AA0-BBD8-6230DBA53B9D}"/>
               </a:ext>
             </a:extLst>
           </p:cNvPr>
@@ -11649,10 +12416,10 @@
       </p:sp>
       <p:sp>
         <p:nvSpPr>
-          <p:cNvPr id="6" name="">
+          <p:cNvPr id="5" name="">
             <a:extLst xmlns:a="http://schemas.openxmlformats.org/drawingml/2006/main">
               <a:ext uri="{FF2B5EF4-FFF2-40B4-BE49-F238E27FC236}">
-                <a16:creationId xmlns:a16="http://schemas.microsoft.com/office/drawing/2014/main" id="{5E907CF1-FC7F-4837-A507-34C64320B634}"/>
+                <a16:creationId xmlns:a16="http://schemas.microsoft.com/office/drawing/2014/main" id="{16D728EC-D048-4D2B-83B8-B9C12B02F686}"/>
               </a:ext>
             </a:extLst>
           </p:cNvPr>
@@ -11807,10 +12574,10 @@
       </p:sp>
       <p:sp>
         <p:nvSpPr>
-          <p:cNvPr id="7" name="">
+          <p:cNvPr id="6" name="">
             <a:extLst xmlns:a="http://schemas.openxmlformats.org/drawingml/2006/main">
               <a:ext uri="{FF2B5EF4-FFF2-40B4-BE49-F238E27FC236}">
-                <a16:creationId xmlns:a16="http://schemas.microsoft.com/office/drawing/2014/main" id="{E9D6A414-C18B-4B2F-BFD8-6B3C401D7692}"/>
+                <a16:creationId xmlns:a16="http://schemas.microsoft.com/office/drawing/2014/main" id="{4A356A5E-6929-4D0B-AF23-AE6B2300FF5E}"/>
               </a:ext>
             </a:extLst>
           </p:cNvPr>
@@ -11846,10 +12613,10 @@
       </p:sp>
       <p:sp>
         <p:nvSpPr>
-          <p:cNvPr id="8" name="">
+          <p:cNvPr id="7" name="">
             <a:extLst xmlns:a="http://schemas.openxmlformats.org/drawingml/2006/main">
               <a:ext uri="{FF2B5EF4-FFF2-40B4-BE49-F238E27FC236}">
-                <a16:creationId xmlns:a16="http://schemas.microsoft.com/office/drawing/2014/main" id="{F813B935-BE8C-48B6-8351-486A8B8E983F}"/>
+                <a16:creationId xmlns:a16="http://schemas.microsoft.com/office/drawing/2014/main" id="{D49833FA-0E76-4EB6-B839-A5FF3E634826}"/>
               </a:ext>
             </a:extLst>
           </p:cNvPr>
@@ -11876,10 +12643,10 @@
       </p:sp>
       <p:sp>
         <p:nvSpPr>
-          <p:cNvPr id="9" name="">
+          <p:cNvPr id="8" name="">
             <a:extLst xmlns:a="http://schemas.openxmlformats.org/drawingml/2006/main">
               <a:ext uri="{FF2B5EF4-FFF2-40B4-BE49-F238E27FC236}">
-                <a16:creationId xmlns:a16="http://schemas.microsoft.com/office/drawing/2014/main" id="{5959A345-5977-44D5-8C1F-30E20B716643}"/>
+                <a16:creationId xmlns:a16="http://schemas.microsoft.com/office/drawing/2014/main" id="{D1CE8668-F32B-446A-A6D6-059DBD80B72F}"/>
               </a:ext>
             </a:extLst>
           </p:cNvPr>
@@ -12034,10 +12801,10 @@
       </p:sp>
       <p:sp>
         <p:nvSpPr>
-          <p:cNvPr id="10" name="">
+          <p:cNvPr id="9" name="">
             <a:extLst xmlns:a="http://schemas.openxmlformats.org/drawingml/2006/main">
               <a:ext uri="{FF2B5EF4-FFF2-40B4-BE49-F238E27FC236}">
-                <a16:creationId xmlns:a16="http://schemas.microsoft.com/office/drawing/2014/main" id="{15182053-9E05-452B-85B1-C90B51268731}"/>
+                <a16:creationId xmlns:a16="http://schemas.microsoft.com/office/drawing/2014/main" id="{B0617BB3-6EE3-41F5-80D1-1184505D34A1}"/>
               </a:ext>
             </a:extLst>
           </p:cNvPr>
@@ -12192,10 +12959,10 @@
       </p:sp>
       <p:sp>
         <p:nvSpPr>
-          <p:cNvPr id="11" name="">
+          <p:cNvPr id="10" name="">
             <a:extLst xmlns:a="http://schemas.openxmlformats.org/drawingml/2006/main">
               <a:ext uri="{FF2B5EF4-FFF2-40B4-BE49-F238E27FC236}">
-                <a16:creationId xmlns:a16="http://schemas.microsoft.com/office/drawing/2014/main" id="{2C645F12-27DA-439F-836C-EA76DC1B8779}"/>
+                <a16:creationId xmlns:a16="http://schemas.microsoft.com/office/drawing/2014/main" id="{80E96457-DDDB-45D5-8598-05B05DB21C97}"/>
               </a:ext>
             </a:extLst>
           </p:cNvPr>
@@ -12231,10 +12998,10 @@
       </p:sp>
       <p:sp>
         <p:nvSpPr>
-          <p:cNvPr id="12" name="">
+          <p:cNvPr id="11" name="">
             <a:extLst xmlns:a="http://schemas.openxmlformats.org/drawingml/2006/main">
               <a:ext uri="{FF2B5EF4-FFF2-40B4-BE49-F238E27FC236}">
-                <a16:creationId xmlns:a16="http://schemas.microsoft.com/office/drawing/2014/main" id="{3EFCBEC7-909B-433E-8CC3-A06C4F1FAE88}"/>
+                <a16:creationId xmlns:a16="http://schemas.microsoft.com/office/drawing/2014/main" id="{49E0BC68-F960-4608-80E2-B5441C4D00FF}"/>
               </a:ext>
             </a:extLst>
           </p:cNvPr>
@@ -12261,10 +13028,10 @@
       </p:sp>
       <p:sp>
         <p:nvSpPr>
-          <p:cNvPr id="13" name="">
+          <p:cNvPr id="12" name="">
             <a:extLst xmlns:a="http://schemas.openxmlformats.org/drawingml/2006/main">
               <a:ext uri="{FF2B5EF4-FFF2-40B4-BE49-F238E27FC236}">
-                <a16:creationId xmlns:a16="http://schemas.microsoft.com/office/drawing/2014/main" id="{CF42723E-6F5C-473D-9271-39C8103A7043}"/>
+                <a16:creationId xmlns:a16="http://schemas.microsoft.com/office/drawing/2014/main" id="{5BB7AF20-A263-4F1E-B5FB-05B08D859330}"/>
               </a:ext>
             </a:extLst>
           </p:cNvPr>
@@ -12419,10 +13186,10 @@
       </p:sp>
       <p:sp>
         <p:nvSpPr>
-          <p:cNvPr id="14" name="">
+          <p:cNvPr id="13" name="">
             <a:extLst xmlns:a="http://schemas.openxmlformats.org/drawingml/2006/main">
               <a:ext uri="{FF2B5EF4-FFF2-40B4-BE49-F238E27FC236}">
-                <a16:creationId xmlns:a16="http://schemas.microsoft.com/office/drawing/2014/main" id="{4CC2C48E-B199-4531-832C-9194A8A9A294}"/>
+                <a16:creationId xmlns:a16="http://schemas.microsoft.com/office/drawing/2014/main" id="{7A5730AB-CD49-466F-9878-AA9E1963C59B}"/>
               </a:ext>
             </a:extLst>
           </p:cNvPr>
@@ -12577,10 +13344,10 @@
       </p:sp>
       <p:sp>
         <p:nvSpPr>
-          <p:cNvPr id="15" name="">
+          <p:cNvPr id="14" name="">
             <a:extLst xmlns:a="http://schemas.openxmlformats.org/drawingml/2006/main">
               <a:ext uri="{FF2B5EF4-FFF2-40B4-BE49-F238E27FC236}">
-                <a16:creationId xmlns:a16="http://schemas.microsoft.com/office/drawing/2014/main" id="{76E9AD49-A05A-4E13-8908-839AA697AB91}"/>
+                <a16:creationId xmlns:a16="http://schemas.microsoft.com/office/drawing/2014/main" id="{49FE828B-17A8-4F1F-8D21-C53D57ABCF86}"/>
               </a:ext>
             </a:extLst>
           </p:cNvPr>
@@ -12616,10 +13383,10 @@
       </p:sp>
       <p:sp>
         <p:nvSpPr>
-          <p:cNvPr id="16" name="">
+          <p:cNvPr id="15" name="">
             <a:extLst xmlns:a="http://schemas.openxmlformats.org/drawingml/2006/main">
               <a:ext uri="{FF2B5EF4-FFF2-40B4-BE49-F238E27FC236}">
-                <a16:creationId xmlns:a16="http://schemas.microsoft.com/office/drawing/2014/main" id="{05A8144F-2D9D-47C0-8AB5-30DA015D5A6F}"/>
+                <a16:creationId xmlns:a16="http://schemas.microsoft.com/office/drawing/2014/main" id="{4B249E68-0DD9-4EDD-B6E5-39D2A3B3B39F}"/>
               </a:ext>
             </a:extLst>
           </p:cNvPr>
@@ -12646,10 +13413,10 @@
       </p:sp>
       <p:sp>
         <p:nvSpPr>
-          <p:cNvPr id="17" name="">
+          <p:cNvPr id="16" name="">
             <a:extLst xmlns:a="http://schemas.openxmlformats.org/drawingml/2006/main">
               <a:ext uri="{FF2B5EF4-FFF2-40B4-BE49-F238E27FC236}">
-                <a16:creationId xmlns:a16="http://schemas.microsoft.com/office/drawing/2014/main" id="{1910C803-5E1D-4854-A4CC-3B101C82AFAD}"/>
+                <a16:creationId xmlns:a16="http://schemas.microsoft.com/office/drawing/2014/main" id="{DB401D77-F04E-483A-8D0A-0D258B7E4FF3}"/>
               </a:ext>
             </a:extLst>
           </p:cNvPr>
@@ -12804,10 +13571,10 @@
       </p:sp>
       <p:sp>
         <p:nvSpPr>
-          <p:cNvPr id="18" name="">
+          <p:cNvPr id="17" name="">
             <a:extLst xmlns:a="http://schemas.openxmlformats.org/drawingml/2006/main">
               <a:ext uri="{FF2B5EF4-FFF2-40B4-BE49-F238E27FC236}">
-                <a16:creationId xmlns:a16="http://schemas.microsoft.com/office/drawing/2014/main" id="{9CE27A4E-DBD9-4EA4-9FED-5A183C3485DA}"/>
+                <a16:creationId xmlns:a16="http://schemas.microsoft.com/office/drawing/2014/main" id="{821016B6-2978-4B25-A4FC-55C5F91A5707}"/>
               </a:ext>
             </a:extLst>
           </p:cNvPr>
@@ -12843,10 +13610,10 @@
       </p:sp>
       <p:sp>
         <p:nvSpPr>
-          <p:cNvPr id="19" name="">
+          <p:cNvPr id="18" name="">
             <a:extLst xmlns:a="http://schemas.openxmlformats.org/drawingml/2006/main">
               <a:ext uri="{FF2B5EF4-FFF2-40B4-BE49-F238E27FC236}">
-                <a16:creationId xmlns:a16="http://schemas.microsoft.com/office/drawing/2014/main" id="{E7E8B76E-643B-4E62-858F-CBC0CB572CF3}"/>
+                <a16:creationId xmlns:a16="http://schemas.microsoft.com/office/drawing/2014/main" id="{81FF3A2B-C40F-4E4B-878A-EB546B9612A9}"/>
               </a:ext>
             </a:extLst>
           </p:cNvPr>
@@ -12882,10 +13649,10 @@
       </p:sp>
       <p:sp>
         <p:nvSpPr>
-          <p:cNvPr id="20" name="">
+          <p:cNvPr id="19" name="">
             <a:extLst xmlns:a="http://schemas.openxmlformats.org/drawingml/2006/main">
               <a:ext uri="{FF2B5EF4-FFF2-40B4-BE49-F238E27FC236}">
-                <a16:creationId xmlns:a16="http://schemas.microsoft.com/office/drawing/2014/main" id="{0AD755BD-1FD7-4A74-B09A-80803A642525}"/>
+                <a16:creationId xmlns:a16="http://schemas.microsoft.com/office/drawing/2014/main" id="{86B83D0E-E1DA-49F4-B939-5F4CA44AABEC}"/>
               </a:ext>
             </a:extLst>
           </p:cNvPr>
@@ -13040,10 +13807,10 @@
       </p:sp>
       <p:sp>
         <p:nvSpPr>
-          <p:cNvPr id="21" name="">
+          <p:cNvPr id="20" name="">
             <a:extLst xmlns:a="http://schemas.openxmlformats.org/drawingml/2006/main">
               <a:ext uri="{FF2B5EF4-FFF2-40B4-BE49-F238E27FC236}">
-                <a16:creationId xmlns:a16="http://schemas.microsoft.com/office/drawing/2014/main" id="{F96EEA8A-8B11-4718-96FF-D727C0C1AF1E}"/>
+                <a16:creationId xmlns:a16="http://schemas.microsoft.com/office/drawing/2014/main" id="{4748CBFC-8B06-4334-80C9-CDD247AD65A3}"/>
               </a:ext>
             </a:extLst>
           </p:cNvPr>
@@ -13079,10 +13846,10 @@
       </p:sp>
       <p:sp>
         <p:nvSpPr>
-          <p:cNvPr id="22" name="">
+          <p:cNvPr id="21" name="">
             <a:extLst xmlns:a="http://schemas.openxmlformats.org/drawingml/2006/main">
               <a:ext uri="{FF2B5EF4-FFF2-40B4-BE49-F238E27FC236}">
-                <a16:creationId xmlns:a16="http://schemas.microsoft.com/office/drawing/2014/main" id="{2AC40591-E326-4BA5-BC03-3B24A6369E65}"/>
+                <a16:creationId xmlns:a16="http://schemas.microsoft.com/office/drawing/2014/main" id="{A8ADC8D9-C212-4B66-BA8E-369F8E623399}"/>
               </a:ext>
             </a:extLst>
           </p:cNvPr>
@@ -13237,10 +14004,10 @@
       </p:sp>
       <p:sp>
         <p:nvSpPr>
-          <p:cNvPr id="23" name="">
+          <p:cNvPr id="22" name="">
             <a:extLst xmlns:a="http://schemas.openxmlformats.org/drawingml/2006/main">
               <a:ext uri="{FF2B5EF4-FFF2-40B4-BE49-F238E27FC236}">
-                <a16:creationId xmlns:a16="http://schemas.microsoft.com/office/drawing/2014/main" id="{1E40318F-B125-4118-9CF9-9152A9697199}"/>
+                <a16:creationId xmlns:a16="http://schemas.microsoft.com/office/drawing/2014/main" id="{53EB1089-AC49-4BE1-BAB9-E1AB5E8B10CB}"/>
               </a:ext>
             </a:extLst>
           </p:cNvPr>
@@ -13276,10 +14043,10 @@
       </p:sp>
       <p:sp>
         <p:nvSpPr>
-          <p:cNvPr id="24" name="">
+          <p:cNvPr id="23" name="">
             <a:extLst xmlns:a="http://schemas.openxmlformats.org/drawingml/2006/main">
               <a:ext uri="{FF2B5EF4-FFF2-40B4-BE49-F238E27FC236}">
-                <a16:creationId xmlns:a16="http://schemas.microsoft.com/office/drawing/2014/main" id="{905227F7-A7B8-4A26-A778-D664F139B1CE}"/>
+                <a16:creationId xmlns:a16="http://schemas.microsoft.com/office/drawing/2014/main" id="{9AA88572-1878-4E76-8F5D-8C9FC3142CDF}"/>
               </a:ext>
             </a:extLst>
           </p:cNvPr>
@@ -13434,10 +14201,10 @@
       </p:sp>
       <p:sp>
         <p:nvSpPr>
-          <p:cNvPr id="25" name="">
+          <p:cNvPr id="24" name="">
             <a:extLst xmlns:a="http://schemas.openxmlformats.org/drawingml/2006/main">
               <a:ext uri="{FF2B5EF4-FFF2-40B4-BE49-F238E27FC236}">
-                <a16:creationId xmlns:a16="http://schemas.microsoft.com/office/drawing/2014/main" id="{FE063C70-F398-4458-9471-C9F04FFCFC1C}"/>
+                <a16:creationId xmlns:a16="http://schemas.microsoft.com/office/drawing/2014/main" id="{7E5CFD73-3057-4ED5-9B16-8144B5DE88EB}"/>
               </a:ext>
             </a:extLst>
           </p:cNvPr>
@@ -13473,10 +14240,10 @@
       </p:sp>
       <p:sp>
         <p:nvSpPr>
-          <p:cNvPr id="26" name="">
+          <p:cNvPr id="25" name="">
             <a:extLst xmlns:a="http://schemas.openxmlformats.org/drawingml/2006/main">
               <a:ext uri="{FF2B5EF4-FFF2-40B4-BE49-F238E27FC236}">
-                <a16:creationId xmlns:a16="http://schemas.microsoft.com/office/drawing/2014/main" id="{A20F7C44-A444-4894-BBF2-38DD4956A662}"/>
+                <a16:creationId xmlns:a16="http://schemas.microsoft.com/office/drawing/2014/main" id="{9A355765-FE24-4CEF-8106-195F85C43BDB}"/>
               </a:ext>
             </a:extLst>
           </p:cNvPr>
@@ -13631,10 +14398,10 @@
       </p:sp>
       <p:sp>
         <p:nvSpPr>
-          <p:cNvPr id="27" name="">
+          <p:cNvPr id="26" name="">
             <a:extLst xmlns:a="http://schemas.openxmlformats.org/drawingml/2006/main">
               <a:ext uri="{FF2B5EF4-FFF2-40B4-BE49-F238E27FC236}">
-                <a16:creationId xmlns:a16="http://schemas.microsoft.com/office/drawing/2014/main" id="{B16E50FD-6133-41AD-BD9E-C6D09506F314}"/>
+                <a16:creationId xmlns:a16="http://schemas.microsoft.com/office/drawing/2014/main" id="{A8247ECF-BFB5-405D-906F-3C6B5CE317B4}"/>
               </a:ext>
             </a:extLst>
           </p:cNvPr>
@@ -13670,10 +14437,10 @@
       </p:sp>
       <p:sp>
         <p:nvSpPr>
-          <p:cNvPr id="28" name="">
+          <p:cNvPr id="27" name="">
             <a:extLst xmlns:a="http://schemas.openxmlformats.org/drawingml/2006/main">
               <a:ext uri="{FF2B5EF4-FFF2-40B4-BE49-F238E27FC236}">
-                <a16:creationId xmlns:a16="http://schemas.microsoft.com/office/drawing/2014/main" id="{E009F195-8908-4324-907F-EE069EBA14E8}"/>
+                <a16:creationId xmlns:a16="http://schemas.microsoft.com/office/drawing/2014/main" id="{14AC11DF-0E3C-43AE-9406-E993195C8094}"/>
               </a:ext>
             </a:extLst>
           </p:cNvPr>
@@ -13828,10 +14595,10 @@
       </p:sp>
       <p:sp>
         <p:nvSpPr>
-          <p:cNvPr id="29" name="">
+          <p:cNvPr id="28" name="">
             <a:extLst xmlns:a="http://schemas.openxmlformats.org/drawingml/2006/main">
               <a:ext uri="{FF2B5EF4-FFF2-40B4-BE49-F238E27FC236}">
-                <a16:creationId xmlns:a16="http://schemas.microsoft.com/office/drawing/2014/main" id="{F208C040-FD8B-4EC3-B4AB-EE13308CE9BB}"/>
+                <a16:creationId xmlns:a16="http://schemas.microsoft.com/office/drawing/2014/main" id="{9F66F91F-449F-4BFA-AC35-BC3B9E4FBE35}"/>
               </a:ext>
             </a:extLst>
           </p:cNvPr>
@@ -13867,10 +14634,10 @@
       </p:sp>
       <p:sp>
         <p:nvSpPr>
-          <p:cNvPr id="30" name="">
+          <p:cNvPr id="29" name="">
             <a:extLst xmlns:a="http://schemas.openxmlformats.org/drawingml/2006/main">
               <a:ext uri="{FF2B5EF4-FFF2-40B4-BE49-F238E27FC236}">
-                <a16:creationId xmlns:a16="http://schemas.microsoft.com/office/drawing/2014/main" id="{E6C76323-7ECB-4ECF-B946-15EFCB2403CD}"/>
+                <a16:creationId xmlns:a16="http://schemas.microsoft.com/office/drawing/2014/main" id="{29292404-200F-4C16-89F6-1361EBA94145}"/>
               </a:ext>
             </a:extLst>
           </p:cNvPr>
@@ -14025,10 +14792,10 @@
       </p:sp>
       <p:sp>
         <p:nvSpPr>
-          <p:cNvPr id="31" name="">
+          <p:cNvPr id="30" name="">
             <a:extLst xmlns:a="http://schemas.openxmlformats.org/drawingml/2006/main">
               <a:ext uri="{FF2B5EF4-FFF2-40B4-BE49-F238E27FC236}">
-                <a16:creationId xmlns:a16="http://schemas.microsoft.com/office/drawing/2014/main" id="{6EDC84B9-E848-4206-9212-8424D7572FFE}"/>
+                <a16:creationId xmlns:a16="http://schemas.microsoft.com/office/drawing/2014/main" id="{9E35CDA8-E92C-4B92-9333-9EF3D3AF2B46}"/>
               </a:ext>
             </a:extLst>
           </p:cNvPr>
@@ -14183,10 +14950,10 @@
       </p:sp>
       <p:sp>
         <p:nvSpPr>
-          <p:cNvPr id="32" name="">
+          <p:cNvPr id="31" name="">
             <a:extLst xmlns:a="http://schemas.openxmlformats.org/drawingml/2006/main">
               <a:ext uri="{FF2B5EF4-FFF2-40B4-BE49-F238E27FC236}">
-                <a16:creationId xmlns:a16="http://schemas.microsoft.com/office/drawing/2014/main" id="{02C7FBFC-8DA1-4A3B-B042-E2B75265FB99}"/>
+                <a16:creationId xmlns:a16="http://schemas.microsoft.com/office/drawing/2014/main" id="{09DCAB17-E5B9-497B-99B0-66EA3AF2CC4C}"/>
               </a:ext>
             </a:extLst>
           </p:cNvPr>
@@ -14342,7 +15109,7 @@
     </p:spTree>
     <p:extLst>
       <p:ext uri="{BB962C8B-B14F-4D97-AF65-F5344CB8AC3E}">
-        <p14:creationId xmlns:p14="http://schemas.microsoft.com/office/powerpoint/2010/main" val="1418234498"/>
+        <p14:creationId xmlns:p14="http://schemas.microsoft.com/office/powerpoint/2010/main" val="495709024"/>
       </p:ext>
     </p:extLst>
   </p:cSld>
@@ -14370,16 +15137,16 @@
       </p:grpSpPr>
       <p:cxnSp>
         <p:nvCxnSpPr>
-          <p:cNvPr id="2" name="">
+          <p:cNvPr id="8" name="">
             <a:extLst xmlns:a="http://schemas.openxmlformats.org/drawingml/2006/main">
               <a:ext uri="{FF2B5EF4-FFF2-40B4-BE49-F238E27FC236}">
-                <a16:creationId xmlns:a16="http://schemas.microsoft.com/office/drawing/2014/main" id="{274BE0F5-E45E-4DD3-9484-915E4C38F412}"/>
+                <a16:creationId xmlns:a16="http://schemas.microsoft.com/office/drawing/2014/main" id="{807857C7-A2E8-4498-8D5D-719FEA959A0C}"/>
               </a:ext>
             </a:extLst>
           </p:cNvPr>
           <p:cNvCxnSpPr>
-            <a:stCxn xmlns:a="http://schemas.openxmlformats.org/drawingml/2006/main" id="8" idx="3"/>
-            <a:endCxn xmlns:a="http://schemas.openxmlformats.org/drawingml/2006/main" id="9" idx="1"/>
+            <a:stCxn xmlns:a="http://schemas.openxmlformats.org/drawingml/2006/main" id="6" idx="3"/>
+            <a:endCxn xmlns:a="http://schemas.openxmlformats.org/drawingml/2006/main" id="7" idx="1"/>
           </p:cNvCxnSpPr>
           <p:nvPr/>
         </p:nvCxnSpPr>
@@ -14401,10 +15168,10 @@
       </p:cxnSp>
       <p:sp>
         <p:nvSpPr>
-          <p:cNvPr id="3" name="">
+          <p:cNvPr id="10" name="">
             <a:extLst xmlns:a="http://schemas.openxmlformats.org/drawingml/2006/main">
               <a:ext uri="{FF2B5EF4-FFF2-40B4-BE49-F238E27FC236}">
-                <a16:creationId xmlns:a16="http://schemas.microsoft.com/office/drawing/2014/main" id="{66EE8E8B-ECD2-4B4D-8503-392B71E84CFE}"/>
+                <a16:creationId xmlns:a16="http://schemas.microsoft.com/office/drawing/2014/main" id="{DDD8F5C7-088E-49C7-A242-B7FD5AC440B9}"/>
               </a:ext>
             </a:extLst>
           </p:cNvPr>
@@ -14559,10 +15326,10 @@
       </p:sp>
       <p:sp>
         <p:nvSpPr>
-          <p:cNvPr id="4" name="">
+          <p:cNvPr id="2" name="">
             <a:extLst xmlns:a="http://schemas.openxmlformats.org/drawingml/2006/main">
               <a:ext uri="{FF2B5EF4-FFF2-40B4-BE49-F238E27FC236}">
-                <a16:creationId xmlns:a16="http://schemas.microsoft.com/office/drawing/2014/main" id="{F3FC13F2-9400-4860-86F6-11EFCBC75495}"/>
+                <a16:creationId xmlns:a16="http://schemas.microsoft.com/office/drawing/2014/main" id="{7CA9730A-30CC-4FED-8739-0DBCC51ABED2}"/>
               </a:ext>
             </a:extLst>
           </p:cNvPr>
@@ -14717,10 +15484,10 @@
       </p:sp>
       <p:graphicFrame>
         <p:nvGraphicFramePr>
-          <p:cNvPr id="5" name="Chart">
+          <p:cNvPr id="3" name="Chart">
             <a:extLst xmlns:a="http://schemas.openxmlformats.org/drawingml/2006/main">
               <a:ext uri="{FF2B5EF4-FFF2-40B4-BE49-F238E27FC236}">
-                <a16:creationId xmlns:a16="http://schemas.microsoft.com/office/drawing/2014/main" id="{A31D0632-7EBA-456D-8CDB-B9CB75F2FDAE}"/>
+                <a16:creationId xmlns:a16="http://schemas.microsoft.com/office/drawing/2014/main" id="{669A0979-86E7-44E7-9679-5D5E8FF82678}"/>
               </a:ext>
             </a:extLst>
           </p:cNvPr>
@@ -14733,16 +15500,16 @@
         </p:xfrm>
         <a:graphic xmlns:a="http://schemas.openxmlformats.org/drawingml/2006/main">
           <a:graphicData uri="http://schemas.openxmlformats.org/drawingml/2006/chart">
-            <c:chart xmlns:r="http://schemas.openxmlformats.org/officeDocument/2006/relationships" xmlns:c="http://schemas.openxmlformats.org/drawingml/2006/chart" r:id="R7b43e423f03b4620"/>
+            <c:chart xmlns:r="http://schemas.openxmlformats.org/officeDocument/2006/relationships" xmlns:c="http://schemas.openxmlformats.org/drawingml/2006/chart" r:id="Rea9f27433e6b4801"/>
           </a:graphicData>
         </a:graphic>
       </p:graphicFrame>
       <p:sp>
         <p:nvSpPr>
-          <p:cNvPr id="6" name="">
+          <p:cNvPr id="4" name="">
             <a:extLst xmlns:a="http://schemas.openxmlformats.org/drawingml/2006/main">
               <a:ext uri="{FF2B5EF4-FFF2-40B4-BE49-F238E27FC236}">
-                <a16:creationId xmlns:a16="http://schemas.microsoft.com/office/drawing/2014/main" id="{29DE76F1-C654-4858-9AD8-17826548D381}"/>
+                <a16:creationId xmlns:a16="http://schemas.microsoft.com/office/drawing/2014/main" id="{C3039C24-C480-40AE-8665-D03B7CB5E7A8}"/>
               </a:ext>
             </a:extLst>
           </p:cNvPr>
@@ -14897,10 +15664,10 @@
       </p:sp>
       <p:sp>
         <p:nvSpPr>
-          <p:cNvPr id="7" name="">
+          <p:cNvPr id="5" name="">
             <a:extLst xmlns:a="http://schemas.openxmlformats.org/drawingml/2006/main">
               <a:ext uri="{FF2B5EF4-FFF2-40B4-BE49-F238E27FC236}">
-                <a16:creationId xmlns:a16="http://schemas.microsoft.com/office/drawing/2014/main" id="{816C4100-8D9B-43D5-9A5A-9A66DE1CE443}"/>
+                <a16:creationId xmlns:a16="http://schemas.microsoft.com/office/drawing/2014/main" id="{07C2704B-49EE-4F2B-9F63-D3FAAAC185EB}"/>
               </a:ext>
             </a:extLst>
           </p:cNvPr>
@@ -15055,10 +15822,10 @@
       </p:sp>
       <p:sp>
         <p:nvSpPr>
-          <p:cNvPr id="8" name="">
+          <p:cNvPr id="6" name="">
             <a:extLst xmlns:a="http://schemas.openxmlformats.org/drawingml/2006/main">
               <a:ext uri="{FF2B5EF4-FFF2-40B4-BE49-F238E27FC236}">
-                <a16:creationId xmlns:a16="http://schemas.microsoft.com/office/drawing/2014/main" id="{BB9E4EA4-6631-475B-A7F5-D70BEE195B75}"/>
+                <a16:creationId xmlns:a16="http://schemas.microsoft.com/office/drawing/2014/main" id="{290644D9-BDD8-46DA-9A43-13AB252E2267}"/>
               </a:ext>
             </a:extLst>
           </p:cNvPr>
@@ -15217,10 +15984,10 @@
       </p:sp>
       <p:sp>
         <p:nvSpPr>
-          <p:cNvPr id="9" name="">
+          <p:cNvPr id="7" name="">
             <a:extLst xmlns:a="http://schemas.openxmlformats.org/drawingml/2006/main">
               <a:ext uri="{FF2B5EF4-FFF2-40B4-BE49-F238E27FC236}">
-                <a16:creationId xmlns:a16="http://schemas.microsoft.com/office/drawing/2014/main" id="{E83ACA0A-BF56-4206-A3A6-83720089E36F}"/>
+                <a16:creationId xmlns:a16="http://schemas.microsoft.com/office/drawing/2014/main" id="{D497699F-09ED-4EF0-BCE6-DF47F6AA1077}"/>
               </a:ext>
             </a:extLst>
           </p:cNvPr>
@@ -15379,10 +16146,10 @@
       </p:sp>
       <p:sp>
         <p:nvSpPr>
-          <p:cNvPr id="10" name="">
+          <p:cNvPr id="9" name="">
             <a:extLst xmlns:a="http://schemas.openxmlformats.org/drawingml/2006/main">
               <a:ext uri="{FF2B5EF4-FFF2-40B4-BE49-F238E27FC236}">
-                <a16:creationId xmlns:a16="http://schemas.microsoft.com/office/drawing/2014/main" id="{3B22888E-633D-4A37-A6E7-E2A0B3108989}"/>
+                <a16:creationId xmlns:a16="http://schemas.microsoft.com/office/drawing/2014/main" id="{3CE44DD7-EE78-479C-A2C0-BE96D5DBFEDF}"/>
               </a:ext>
             </a:extLst>
           </p:cNvPr>
@@ -15538,7 +16305,7 @@
     </p:spTree>
     <p:extLst>
       <p:ext uri="{BB962C8B-B14F-4D97-AF65-F5344CB8AC3E}">
-        <p14:creationId xmlns:p14="http://schemas.microsoft.com/office/powerpoint/2010/main" val="2131350528"/>
+        <p14:creationId xmlns:p14="http://schemas.microsoft.com/office/powerpoint/2010/main" val="1996760935"/>
       </p:ext>
     </p:extLst>
   </p:cSld>
@@ -15566,10 +16333,10 @@
       </p:grpSpPr>
       <p:sp>
         <p:nvSpPr>
-          <p:cNvPr id="2" name="">
+          <p:cNvPr id="15" name="">
             <a:extLst xmlns:a="http://schemas.openxmlformats.org/drawingml/2006/main">
               <a:ext uri="{FF2B5EF4-FFF2-40B4-BE49-F238E27FC236}">
-                <a16:creationId xmlns:a16="http://schemas.microsoft.com/office/drawing/2014/main" id="{D1DA705F-B9E1-445C-BC2E-9CD5774E0E42}"/>
+                <a16:creationId xmlns:a16="http://schemas.microsoft.com/office/drawing/2014/main" id="{7649225A-BE52-4474-ACFB-642A503A78D6}"/>
               </a:ext>
             </a:extLst>
           </p:cNvPr>
@@ -15724,10 +16491,10 @@
       </p:sp>
       <p:sp>
         <p:nvSpPr>
-          <p:cNvPr id="3" name="">
+          <p:cNvPr id="2" name="">
             <a:extLst xmlns:a="http://schemas.openxmlformats.org/drawingml/2006/main">
               <a:ext uri="{FF2B5EF4-FFF2-40B4-BE49-F238E27FC236}">
-                <a16:creationId xmlns:a16="http://schemas.microsoft.com/office/drawing/2014/main" id="{9474B314-7D17-4E34-82C0-4F88A62DE941}"/>
+                <a16:creationId xmlns:a16="http://schemas.microsoft.com/office/drawing/2014/main" id="{A64D0607-4560-4756-8CBE-1F6970FF8FEF}"/>
               </a:ext>
             </a:extLst>
           </p:cNvPr>
@@ -15882,10 +16649,10 @@
       </p:sp>
       <p:sp>
         <p:nvSpPr>
-          <p:cNvPr id="4" name="">
+          <p:cNvPr id="3" name="">
             <a:extLst xmlns:a="http://schemas.openxmlformats.org/drawingml/2006/main">
               <a:ext uri="{FF2B5EF4-FFF2-40B4-BE49-F238E27FC236}">
-                <a16:creationId xmlns:a16="http://schemas.microsoft.com/office/drawing/2014/main" id="{749EB670-097A-47E3-BF1F-8000DB673FEB}"/>
+                <a16:creationId xmlns:a16="http://schemas.microsoft.com/office/drawing/2014/main" id="{CABFA352-6270-4CB8-83FE-09F5A2CDA85A}"/>
               </a:ext>
             </a:extLst>
           </p:cNvPr>
@@ -16040,10 +16807,10 @@
       </p:sp>
       <p:sp>
         <p:nvSpPr>
-          <p:cNvPr id="5" name="">
+          <p:cNvPr id="4" name="">
             <a:extLst xmlns:a="http://schemas.openxmlformats.org/drawingml/2006/main">
               <a:ext uri="{FF2B5EF4-FFF2-40B4-BE49-F238E27FC236}">
-                <a16:creationId xmlns:a16="http://schemas.microsoft.com/office/drawing/2014/main" id="{19F4987B-4F7A-4508-B01F-22E94BF67DAD}"/>
+                <a16:creationId xmlns:a16="http://schemas.microsoft.com/office/drawing/2014/main" id="{E461B17B-5DFE-4E48-BCA9-957CBFAE6B47}"/>
               </a:ext>
             </a:extLst>
           </p:cNvPr>
@@ -16202,10 +16969,10 @@
       </p:sp>
       <p:sp>
         <p:nvSpPr>
-          <p:cNvPr id="6" name="">
+          <p:cNvPr id="5" name="">
             <a:extLst xmlns:a="http://schemas.openxmlformats.org/drawingml/2006/main">
               <a:ext uri="{FF2B5EF4-FFF2-40B4-BE49-F238E27FC236}">
-                <a16:creationId xmlns:a16="http://schemas.microsoft.com/office/drawing/2014/main" id="{91F3AEC2-10D6-4B83-89F6-76892F40B147}"/>
+                <a16:creationId xmlns:a16="http://schemas.microsoft.com/office/drawing/2014/main" id="{DB5C6EEC-2A9D-4627-BB5D-D80600040D95}"/>
               </a:ext>
             </a:extLst>
           </p:cNvPr>
@@ -16364,10 +17131,10 @@
       </p:sp>
       <p:sp>
         <p:nvSpPr>
-          <p:cNvPr id="7" name="">
+          <p:cNvPr id="6" name="">
             <a:extLst xmlns:a="http://schemas.openxmlformats.org/drawingml/2006/main">
               <a:ext uri="{FF2B5EF4-FFF2-40B4-BE49-F238E27FC236}">
-                <a16:creationId xmlns:a16="http://schemas.microsoft.com/office/drawing/2014/main" id="{01DF66B8-38E5-4410-9970-EA5581F9A9D6}"/>
+                <a16:creationId xmlns:a16="http://schemas.microsoft.com/office/drawing/2014/main" id="{0F806911-4411-428D-8F63-2D9501873BD9}"/>
               </a:ext>
             </a:extLst>
           </p:cNvPr>
@@ -16522,10 +17289,10 @@
       </p:sp>
       <p:sp>
         <p:nvSpPr>
-          <p:cNvPr id="8" name="">
+          <p:cNvPr id="7" name="">
             <a:extLst xmlns:a="http://schemas.openxmlformats.org/drawingml/2006/main">
               <a:ext uri="{FF2B5EF4-FFF2-40B4-BE49-F238E27FC236}">
-                <a16:creationId xmlns:a16="http://schemas.microsoft.com/office/drawing/2014/main" id="{DEEFE4EE-5FFE-43AB-9812-6C56A210A8EA}"/>
+                <a16:creationId xmlns:a16="http://schemas.microsoft.com/office/drawing/2014/main" id="{08CDD6A2-73C9-4146-A1EE-A1D144551446}"/>
               </a:ext>
             </a:extLst>
           </p:cNvPr>
@@ -16680,10 +17447,10 @@
       </p:sp>
       <p:sp>
         <p:nvSpPr>
-          <p:cNvPr id="9" name="">
+          <p:cNvPr id="8" name="">
             <a:extLst xmlns:a="http://schemas.openxmlformats.org/drawingml/2006/main">
               <a:ext uri="{FF2B5EF4-FFF2-40B4-BE49-F238E27FC236}">
-                <a16:creationId xmlns:a16="http://schemas.microsoft.com/office/drawing/2014/main" id="{0B7818DD-1242-40B3-BEA3-67B384D3EB04}"/>
+                <a16:creationId xmlns:a16="http://schemas.microsoft.com/office/drawing/2014/main" id="{F5E1081E-18AF-4120-A1B0-914A94EBD2E9}"/>
               </a:ext>
             </a:extLst>
           </p:cNvPr>
@@ -16838,10 +17605,10 @@
       </p:sp>
       <p:sp>
         <p:nvSpPr>
-          <p:cNvPr id="10" name="">
+          <p:cNvPr id="9" name="">
             <a:extLst xmlns:a="http://schemas.openxmlformats.org/drawingml/2006/main">
               <a:ext uri="{FF2B5EF4-FFF2-40B4-BE49-F238E27FC236}">
-                <a16:creationId xmlns:a16="http://schemas.microsoft.com/office/drawing/2014/main" id="{D59E6C05-F78E-4D7B-AA7D-9E454B30A8CB}"/>
+                <a16:creationId xmlns:a16="http://schemas.microsoft.com/office/drawing/2014/main" id="{742F6CFA-9399-45D0-B435-343D1B86DD9A}"/>
               </a:ext>
             </a:extLst>
           </p:cNvPr>
@@ -16996,10 +17763,10 @@
       </p:sp>
       <p:sp>
         <p:nvSpPr>
-          <p:cNvPr id="11" name="">
+          <p:cNvPr id="10" name="">
             <a:extLst xmlns:a="http://schemas.openxmlformats.org/drawingml/2006/main">
               <a:ext uri="{FF2B5EF4-FFF2-40B4-BE49-F238E27FC236}">
-                <a16:creationId xmlns:a16="http://schemas.microsoft.com/office/drawing/2014/main" id="{F97E1844-E345-4633-B0F0-8BED1469B994}"/>
+                <a16:creationId xmlns:a16="http://schemas.microsoft.com/office/drawing/2014/main" id="{437B6777-2C9D-44AD-B3E4-91AD64889B50}"/>
               </a:ext>
             </a:extLst>
           </p:cNvPr>
@@ -17154,10 +17921,10 @@
       </p:sp>
       <p:sp>
         <p:nvSpPr>
-          <p:cNvPr id="12" name="">
+          <p:cNvPr id="11" name="">
             <a:extLst xmlns:a="http://schemas.openxmlformats.org/drawingml/2006/main">
               <a:ext uri="{FF2B5EF4-FFF2-40B4-BE49-F238E27FC236}">
-                <a16:creationId xmlns:a16="http://schemas.microsoft.com/office/drawing/2014/main" id="{53D4C1D6-0E6F-4779-9502-74E3F83475B4}"/>
+                <a16:creationId xmlns:a16="http://schemas.microsoft.com/office/drawing/2014/main" id="{DC81F2F4-539B-4F31-85DE-7045FDD74102}"/>
               </a:ext>
             </a:extLst>
           </p:cNvPr>
@@ -17312,10 +18079,10 @@
       </p:sp>
       <p:sp>
         <p:nvSpPr>
-          <p:cNvPr id="13" name="">
+          <p:cNvPr id="12" name="">
             <a:extLst xmlns:a="http://schemas.openxmlformats.org/drawingml/2006/main">
               <a:ext uri="{FF2B5EF4-FFF2-40B4-BE49-F238E27FC236}">
-                <a16:creationId xmlns:a16="http://schemas.microsoft.com/office/drawing/2014/main" id="{D2F1F1CD-A4EF-4194-B39D-36A6B5323F12}"/>
+                <a16:creationId xmlns:a16="http://schemas.microsoft.com/office/drawing/2014/main" id="{508E0609-BB5C-4E68-A997-F00CFF8B00AD}"/>
               </a:ext>
             </a:extLst>
           </p:cNvPr>
@@ -17470,10 +18237,10 @@
       </p:sp>
       <p:sp>
         <p:nvSpPr>
-          <p:cNvPr id="14" name="">
+          <p:cNvPr id="13" name="">
             <a:extLst xmlns:a="http://schemas.openxmlformats.org/drawingml/2006/main">
               <a:ext uri="{FF2B5EF4-FFF2-40B4-BE49-F238E27FC236}">
-                <a16:creationId xmlns:a16="http://schemas.microsoft.com/office/drawing/2014/main" id="{A497C3EA-405B-4881-9ED8-6DA42A8A63A4}"/>
+                <a16:creationId xmlns:a16="http://schemas.microsoft.com/office/drawing/2014/main" id="{97EAFF10-3F09-44F3-924B-BCC6A889E024}"/>
               </a:ext>
             </a:extLst>
           </p:cNvPr>
@@ -17628,10 +18395,10 @@
       </p:sp>
       <p:sp>
         <p:nvSpPr>
-          <p:cNvPr id="15" name="">
+          <p:cNvPr id="14" name="">
             <a:extLst xmlns:a="http://schemas.openxmlformats.org/drawingml/2006/main">
               <a:ext uri="{FF2B5EF4-FFF2-40B4-BE49-F238E27FC236}">
-                <a16:creationId xmlns:a16="http://schemas.microsoft.com/office/drawing/2014/main" id="{1E85FBD5-928A-4E21-882B-D115D5E5D6B9}"/>
+                <a16:creationId xmlns:a16="http://schemas.microsoft.com/office/drawing/2014/main" id="{1E0864D3-7B60-4D5D-AE1B-DB3033DD493E}"/>
               </a:ext>
             </a:extLst>
           </p:cNvPr>
@@ -17787,7 +18554,7 @@
     </p:spTree>
     <p:extLst>
       <p:ext uri="{BB962C8B-B14F-4D97-AF65-F5344CB8AC3E}">
-        <p14:creationId xmlns:p14="http://schemas.microsoft.com/office/powerpoint/2010/main" val="40935650"/>
+        <p14:creationId xmlns:p14="http://schemas.microsoft.com/office/powerpoint/2010/main" val="1015770288"/>
       </p:ext>
     </p:extLst>
   </p:cSld>
@@ -17815,16 +18582,16 @@
       </p:grpSpPr>
       <p:cxnSp>
         <p:nvCxnSpPr>
-          <p:cNvPr id="2" name="">
+          <p:cNvPr id="13" name="">
             <a:extLst xmlns:a="http://schemas.openxmlformats.org/drawingml/2006/main">
               <a:ext uri="{FF2B5EF4-FFF2-40B4-BE49-F238E27FC236}">
-                <a16:creationId xmlns:a16="http://schemas.microsoft.com/office/drawing/2014/main" id="{BC4362BC-EE2D-4F6A-AE07-C64CAB2A94BC}"/>
+                <a16:creationId xmlns:a16="http://schemas.microsoft.com/office/drawing/2014/main" id="{DFCA2EBB-13C8-4008-9BCF-59FB213E3ACD}"/>
               </a:ext>
             </a:extLst>
           </p:cNvPr>
           <p:cNvCxnSpPr>
-            <a:stCxn xmlns:a="http://schemas.openxmlformats.org/drawingml/2006/main" id="10" idx="2"/>
-            <a:endCxn xmlns:a="http://schemas.openxmlformats.org/drawingml/2006/main" id="14" idx="0"/>
+            <a:stCxn xmlns:a="http://schemas.openxmlformats.org/drawingml/2006/main" id="4" idx="2"/>
+            <a:endCxn xmlns:a="http://schemas.openxmlformats.org/drawingml/2006/main" id="12" idx="0"/>
           </p:cNvCxnSpPr>
           <p:nvPr/>
         </p:nvCxnSpPr>
@@ -17847,16 +18614,16 @@
       </p:cxnSp>
       <p:cxnSp>
         <p:nvCxnSpPr>
-          <p:cNvPr id="3" name="">
+          <p:cNvPr id="11" name="">
             <a:extLst xmlns:a="http://schemas.openxmlformats.org/drawingml/2006/main">
               <a:ext uri="{FF2B5EF4-FFF2-40B4-BE49-F238E27FC236}">
-                <a16:creationId xmlns:a16="http://schemas.microsoft.com/office/drawing/2014/main" id="{D6101B3F-5356-4F0B-8E63-7C344BAC6D20}"/>
+                <a16:creationId xmlns:a16="http://schemas.microsoft.com/office/drawing/2014/main" id="{5813C40A-9C10-4940-BA6B-326294567A3E}"/>
               </a:ext>
             </a:extLst>
           </p:cNvPr>
           <p:cNvCxnSpPr>
-            <a:stCxn xmlns:a="http://schemas.openxmlformats.org/drawingml/2006/main" id="12" idx="3"/>
-            <a:endCxn xmlns:a="http://schemas.openxmlformats.org/drawingml/2006/main" id="13" idx="1"/>
+            <a:stCxn xmlns:a="http://schemas.openxmlformats.org/drawingml/2006/main" id="8" idx="3"/>
+            <a:endCxn xmlns:a="http://schemas.openxmlformats.org/drawingml/2006/main" id="10" idx="1"/>
           </p:cNvCxnSpPr>
           <p:nvPr/>
         </p:nvCxnSpPr>
@@ -17878,16 +18645,16 @@
       </p:cxnSp>
       <p:cxnSp>
         <p:nvCxnSpPr>
-          <p:cNvPr id="4" name="">
+          <p:cNvPr id="9" name="">
             <a:extLst xmlns:a="http://schemas.openxmlformats.org/drawingml/2006/main">
               <a:ext uri="{FF2B5EF4-FFF2-40B4-BE49-F238E27FC236}">
-                <a16:creationId xmlns:a16="http://schemas.microsoft.com/office/drawing/2014/main" id="{C8EDFA6A-458E-4459-9A64-243C9B89F712}"/>
+                <a16:creationId xmlns:a16="http://schemas.microsoft.com/office/drawing/2014/main" id="{9004FF15-AB96-49C2-AA82-D67369EB0206}"/>
               </a:ext>
             </a:extLst>
           </p:cNvPr>
           <p:cNvCxnSpPr>
-            <a:stCxn xmlns:a="http://schemas.openxmlformats.org/drawingml/2006/main" id="11" idx="3"/>
-            <a:endCxn xmlns:a="http://schemas.openxmlformats.org/drawingml/2006/main" id="12" idx="1"/>
+            <a:stCxn xmlns:a="http://schemas.openxmlformats.org/drawingml/2006/main" id="6" idx="3"/>
+            <a:endCxn xmlns:a="http://schemas.openxmlformats.org/drawingml/2006/main" id="8" idx="1"/>
           </p:cNvCxnSpPr>
           <p:nvPr/>
         </p:nvCxnSpPr>
@@ -17909,16 +18676,16 @@
       </p:cxnSp>
       <p:cxnSp>
         <p:nvCxnSpPr>
-          <p:cNvPr id="5" name="">
+          <p:cNvPr id="7" name="">
             <a:extLst xmlns:a="http://schemas.openxmlformats.org/drawingml/2006/main">
               <a:ext uri="{FF2B5EF4-FFF2-40B4-BE49-F238E27FC236}">
-                <a16:creationId xmlns:a16="http://schemas.microsoft.com/office/drawing/2014/main" id="{DDF7A485-BCBE-44BE-8B48-6A8880B973C6}"/>
+                <a16:creationId xmlns:a16="http://schemas.microsoft.com/office/drawing/2014/main" id="{EF7647A2-CD4C-4B7B-9471-E0A6A0336F40}"/>
               </a:ext>
             </a:extLst>
           </p:cNvPr>
           <p:cNvCxnSpPr>
-            <a:stCxn xmlns:a="http://schemas.openxmlformats.org/drawingml/2006/main" id="10" idx="3"/>
-            <a:endCxn xmlns:a="http://schemas.openxmlformats.org/drawingml/2006/main" id="11" idx="1"/>
+            <a:stCxn xmlns:a="http://schemas.openxmlformats.org/drawingml/2006/main" id="4" idx="3"/>
+            <a:endCxn xmlns:a="http://schemas.openxmlformats.org/drawingml/2006/main" id="6" idx="1"/>
           </p:cNvCxnSpPr>
           <p:nvPr/>
         </p:nvCxnSpPr>
@@ -17940,16 +18707,16 @@
       </p:cxnSp>
       <p:cxnSp>
         <p:nvCxnSpPr>
-          <p:cNvPr id="6" name="">
+          <p:cNvPr id="5" name="">
             <a:extLst xmlns:a="http://schemas.openxmlformats.org/drawingml/2006/main">
               <a:ext uri="{FF2B5EF4-FFF2-40B4-BE49-F238E27FC236}">
-                <a16:creationId xmlns:a16="http://schemas.microsoft.com/office/drawing/2014/main" id="{9E60FCA3-70AF-4030-9814-A07DE49C8B01}"/>
+                <a16:creationId xmlns:a16="http://schemas.microsoft.com/office/drawing/2014/main" id="{3ABCB51F-8EE3-4078-8BB4-7C980B5CD29B}"/>
               </a:ext>
             </a:extLst>
           </p:cNvPr>
           <p:cNvCxnSpPr>
-            <a:stCxn xmlns:a="http://schemas.openxmlformats.org/drawingml/2006/main" id="9" idx="3"/>
-            <a:endCxn xmlns:a="http://schemas.openxmlformats.org/drawingml/2006/main" id="10" idx="1"/>
+            <a:stCxn xmlns:a="http://schemas.openxmlformats.org/drawingml/2006/main" id="3" idx="3"/>
+            <a:endCxn xmlns:a="http://schemas.openxmlformats.org/drawingml/2006/main" id="4" idx="1"/>
           </p:cNvCxnSpPr>
           <p:nvPr/>
         </p:nvCxnSpPr>
@@ -17971,10 +18738,10 @@
       </p:cxnSp>
       <p:sp>
         <p:nvSpPr>
-          <p:cNvPr id="7" name="">
+          <p:cNvPr id="17" name="">
             <a:extLst xmlns:a="http://schemas.openxmlformats.org/drawingml/2006/main">
               <a:ext uri="{FF2B5EF4-FFF2-40B4-BE49-F238E27FC236}">
-                <a16:creationId xmlns:a16="http://schemas.microsoft.com/office/drawing/2014/main" id="{CD242057-3178-4B72-A366-20DB08F16F7C}"/>
+                <a16:creationId xmlns:a16="http://schemas.microsoft.com/office/drawing/2014/main" id="{36974817-8570-4972-88AD-652D5CE42228}"/>
               </a:ext>
             </a:extLst>
           </p:cNvPr>
@@ -18129,10 +18896,10 @@
       </p:sp>
       <p:sp>
         <p:nvSpPr>
-          <p:cNvPr id="8" name="">
+          <p:cNvPr id="2" name="">
             <a:extLst xmlns:a="http://schemas.openxmlformats.org/drawingml/2006/main">
               <a:ext uri="{FF2B5EF4-FFF2-40B4-BE49-F238E27FC236}">
-                <a16:creationId xmlns:a16="http://schemas.microsoft.com/office/drawing/2014/main" id="{C12D1594-452E-464C-A6A6-E1AC0E0876C6}"/>
+                <a16:creationId xmlns:a16="http://schemas.microsoft.com/office/drawing/2014/main" id="{EF76C50D-6B0B-4F06-B70D-36139CB08A7A}"/>
               </a:ext>
             </a:extLst>
           </p:cNvPr>
@@ -18287,10 +19054,10 @@
       </p:sp>
       <p:sp>
         <p:nvSpPr>
-          <p:cNvPr id="9" name="">
+          <p:cNvPr id="3" name="">
             <a:extLst xmlns:a="http://schemas.openxmlformats.org/drawingml/2006/main">
               <a:ext uri="{FF2B5EF4-FFF2-40B4-BE49-F238E27FC236}">
-                <a16:creationId xmlns:a16="http://schemas.microsoft.com/office/drawing/2014/main" id="{CB2497EC-2D77-4674-85E5-0803CF1CEA8D}"/>
+                <a16:creationId xmlns:a16="http://schemas.microsoft.com/office/drawing/2014/main" id="{1D728C0B-10CF-4A7A-92A2-08982266F6D8}"/>
               </a:ext>
             </a:extLst>
           </p:cNvPr>
@@ -18472,10 +19239,10 @@
       </p:sp>
       <p:sp>
         <p:nvSpPr>
-          <p:cNvPr id="10" name="">
+          <p:cNvPr id="4" name="">
             <a:extLst xmlns:a="http://schemas.openxmlformats.org/drawingml/2006/main">
               <a:ext uri="{FF2B5EF4-FFF2-40B4-BE49-F238E27FC236}">
-                <a16:creationId xmlns:a16="http://schemas.microsoft.com/office/drawing/2014/main" id="{F3068546-CCCA-4177-98AD-FA4AF779F917}"/>
+                <a16:creationId xmlns:a16="http://schemas.microsoft.com/office/drawing/2014/main" id="{65C7F7BE-2D94-4283-ACA1-B204F5C88520}"/>
               </a:ext>
             </a:extLst>
           </p:cNvPr>
@@ -18657,10 +19424,10 @@
       </p:sp>
       <p:sp>
         <p:nvSpPr>
-          <p:cNvPr id="11" name="">
+          <p:cNvPr id="6" name="">
             <a:extLst xmlns:a="http://schemas.openxmlformats.org/drawingml/2006/main">
               <a:ext uri="{FF2B5EF4-FFF2-40B4-BE49-F238E27FC236}">
-                <a16:creationId xmlns:a16="http://schemas.microsoft.com/office/drawing/2014/main" id="{D850873C-7703-478D-AD74-52FD19D7557D}"/>
+                <a16:creationId xmlns:a16="http://schemas.microsoft.com/office/drawing/2014/main" id="{DE5CE178-89E9-459B-8922-318A7C69D1B9}"/>
               </a:ext>
             </a:extLst>
           </p:cNvPr>
@@ -18842,10 +19609,10 @@
       </p:sp>
       <p:sp>
         <p:nvSpPr>
-          <p:cNvPr id="12" name="">
+          <p:cNvPr id="8" name="">
             <a:extLst xmlns:a="http://schemas.openxmlformats.org/drawingml/2006/main">
               <a:ext uri="{FF2B5EF4-FFF2-40B4-BE49-F238E27FC236}">
-                <a16:creationId xmlns:a16="http://schemas.microsoft.com/office/drawing/2014/main" id="{ADB68777-3AB5-497C-AA5F-A9D0FED95522}"/>
+                <a16:creationId xmlns:a16="http://schemas.microsoft.com/office/drawing/2014/main" id="{912B6A4E-130E-470B-95E2-C2A2ABE1F3BD}"/>
               </a:ext>
             </a:extLst>
           </p:cNvPr>
@@ -19027,10 +19794,10 @@
       </p:sp>
       <p:sp>
         <p:nvSpPr>
-          <p:cNvPr id="13" name="">
+          <p:cNvPr id="10" name="">
             <a:extLst xmlns:a="http://schemas.openxmlformats.org/drawingml/2006/main">
               <a:ext uri="{FF2B5EF4-FFF2-40B4-BE49-F238E27FC236}">
-                <a16:creationId xmlns:a16="http://schemas.microsoft.com/office/drawing/2014/main" id="{17CFFFD3-E1BF-4FC6-A1DF-407E44367620}"/>
+                <a16:creationId xmlns:a16="http://schemas.microsoft.com/office/drawing/2014/main" id="{A97026E1-91AB-479C-8507-6ADE963B2634}"/>
               </a:ext>
             </a:extLst>
           </p:cNvPr>
@@ -19212,10 +19979,10 @@
       </p:sp>
       <p:sp>
         <p:nvSpPr>
-          <p:cNvPr id="14" name="">
+          <p:cNvPr id="12" name="">
             <a:extLst xmlns:a="http://schemas.openxmlformats.org/drawingml/2006/main">
               <a:ext uri="{FF2B5EF4-FFF2-40B4-BE49-F238E27FC236}">
-                <a16:creationId xmlns:a16="http://schemas.microsoft.com/office/drawing/2014/main" id="{A9F4E70C-BFA3-43FA-AB67-18784E50BC2E}"/>
+                <a16:creationId xmlns:a16="http://schemas.microsoft.com/office/drawing/2014/main" id="{05BA7E0F-C400-4157-8E05-65F7C7F3B9EC}"/>
               </a:ext>
             </a:extLst>
           </p:cNvPr>
@@ -19397,10 +20164,10 @@
       </p:sp>
       <p:sp>
         <p:nvSpPr>
-          <p:cNvPr id="15" name="">
+          <p:cNvPr id="14" name="">
             <a:extLst xmlns:a="http://schemas.openxmlformats.org/drawingml/2006/main">
               <a:ext uri="{FF2B5EF4-FFF2-40B4-BE49-F238E27FC236}">
-                <a16:creationId xmlns:a16="http://schemas.microsoft.com/office/drawing/2014/main" id="{34436999-8EBD-4C5D-BDDC-8005B9D8D8CB}"/>
+                <a16:creationId xmlns:a16="http://schemas.microsoft.com/office/drawing/2014/main" id="{0EDBEC12-1A72-4EEE-B3B7-6A125ABC3930}"/>
               </a:ext>
             </a:extLst>
           </p:cNvPr>
@@ -19555,10 +20322,10 @@
       </p:sp>
       <p:sp>
         <p:nvSpPr>
-          <p:cNvPr id="16" name="">
+          <p:cNvPr id="15" name="">
             <a:extLst xmlns:a="http://schemas.openxmlformats.org/drawingml/2006/main">
               <a:ext uri="{FF2B5EF4-FFF2-40B4-BE49-F238E27FC236}">
-                <a16:creationId xmlns:a16="http://schemas.microsoft.com/office/drawing/2014/main" id="{DE2663B0-FE2D-4511-BA8F-D995D2022F5B}"/>
+                <a16:creationId xmlns:a16="http://schemas.microsoft.com/office/drawing/2014/main" id="{B5D2FAF6-9BA7-4370-9B22-F589EDFEC57E}"/>
               </a:ext>
             </a:extLst>
           </p:cNvPr>
@@ -19713,10 +20480,10 @@
       </p:sp>
       <p:sp>
         <p:nvSpPr>
-          <p:cNvPr id="17" name="">
+          <p:cNvPr id="16" name="">
             <a:extLst xmlns:a="http://schemas.openxmlformats.org/drawingml/2006/main">
               <a:ext uri="{FF2B5EF4-FFF2-40B4-BE49-F238E27FC236}">
-                <a16:creationId xmlns:a16="http://schemas.microsoft.com/office/drawing/2014/main" id="{28D5D2A6-5066-4634-B08D-7287E6891246}"/>
+                <a16:creationId xmlns:a16="http://schemas.microsoft.com/office/drawing/2014/main" id="{F4299190-923A-4A25-AC83-CACE227E413E}"/>
               </a:ext>
             </a:extLst>
           </p:cNvPr>
@@ -19872,7 +20639,7 @@
     </p:spTree>
     <p:extLst>
       <p:ext uri="{BB962C8B-B14F-4D97-AF65-F5344CB8AC3E}">
-        <p14:creationId xmlns:p14="http://schemas.microsoft.com/office/powerpoint/2010/main" val="347360979"/>
+        <p14:creationId xmlns:p14="http://schemas.microsoft.com/office/powerpoint/2010/main" val="204029071"/>
       </p:ext>
     </p:extLst>
   </p:cSld>
@@ -19900,10 +20667,10 @@
       </p:grpSpPr>
       <p:sp>
         <p:nvSpPr>
-          <p:cNvPr id="2" name="">
+          <p:cNvPr id="60" name="">
             <a:extLst xmlns:a="http://schemas.openxmlformats.org/drawingml/2006/main">
               <a:ext uri="{FF2B5EF4-FFF2-40B4-BE49-F238E27FC236}">
-                <a16:creationId xmlns:a16="http://schemas.microsoft.com/office/drawing/2014/main" id="{22BA1A53-7869-4593-A1DA-67962A759F5E}"/>
+                <a16:creationId xmlns:a16="http://schemas.microsoft.com/office/drawing/2014/main" id="{D38CB7ED-9999-478D-AFD3-E6A04EA89810}"/>
               </a:ext>
             </a:extLst>
           </p:cNvPr>
@@ -20058,10 +20825,10 @@
       </p:sp>
       <p:sp>
         <p:nvSpPr>
-          <p:cNvPr id="3" name="">
+          <p:cNvPr id="2" name="">
             <a:extLst xmlns:a="http://schemas.openxmlformats.org/drawingml/2006/main">
               <a:ext uri="{FF2B5EF4-FFF2-40B4-BE49-F238E27FC236}">
-                <a16:creationId xmlns:a16="http://schemas.microsoft.com/office/drawing/2014/main" id="{5B724815-7216-4107-B352-2DBB9059C58D}"/>
+                <a16:creationId xmlns:a16="http://schemas.microsoft.com/office/drawing/2014/main" id="{F268C77E-14C9-45B9-A4F0-E46B43CBEB7B}"/>
               </a:ext>
             </a:extLst>
           </p:cNvPr>
@@ -20216,10 +20983,10 @@
       </p:sp>
       <p:sp>
         <p:nvSpPr>
-          <p:cNvPr id="4" name="">
+          <p:cNvPr id="3" name="">
             <a:extLst xmlns:a="http://schemas.openxmlformats.org/drawingml/2006/main">
               <a:ext uri="{FF2B5EF4-FFF2-40B4-BE49-F238E27FC236}">
-                <a16:creationId xmlns:a16="http://schemas.microsoft.com/office/drawing/2014/main" id="{AB246E1D-69D0-4A66-B608-1745CF929893}"/>
+                <a16:creationId xmlns:a16="http://schemas.microsoft.com/office/drawing/2014/main" id="{CE97B32B-9E71-451E-B4FE-A6ACE9133A7B}"/>
               </a:ext>
             </a:extLst>
           </p:cNvPr>
@@ -20374,10 +21141,10 @@
       </p:sp>
       <p:sp>
         <p:nvSpPr>
-          <p:cNvPr id="5" name="">
+          <p:cNvPr id="4" name="">
             <a:extLst xmlns:a="http://schemas.openxmlformats.org/drawingml/2006/main">
               <a:ext uri="{FF2B5EF4-FFF2-40B4-BE49-F238E27FC236}">
-                <a16:creationId xmlns:a16="http://schemas.microsoft.com/office/drawing/2014/main" id="{B3D658CF-008F-47B2-B1E5-B41182B0A218}"/>
+                <a16:creationId xmlns:a16="http://schemas.microsoft.com/office/drawing/2014/main" id="{336A76C1-0887-4FD4-97C5-CF51F2EBE4CE}"/>
               </a:ext>
             </a:extLst>
           </p:cNvPr>
@@ -20532,10 +21299,10 @@
       </p:sp>
       <p:sp>
         <p:nvSpPr>
-          <p:cNvPr id="6" name="">
+          <p:cNvPr id="5" name="">
             <a:extLst xmlns:a="http://schemas.openxmlformats.org/drawingml/2006/main">
               <a:ext uri="{FF2B5EF4-FFF2-40B4-BE49-F238E27FC236}">
-                <a16:creationId xmlns:a16="http://schemas.microsoft.com/office/drawing/2014/main" id="{EC2A7B13-396F-4F09-8454-E14F8FC1D201}"/>
+                <a16:creationId xmlns:a16="http://schemas.microsoft.com/office/drawing/2014/main" id="{4B9BE822-4841-450A-BE84-283DAB99DF6D}"/>
               </a:ext>
             </a:extLst>
           </p:cNvPr>
@@ -20562,10 +21329,10 @@
       </p:sp>
       <p:sp>
         <p:nvSpPr>
-          <p:cNvPr id="7" name="">
+          <p:cNvPr id="6" name="">
             <a:extLst xmlns:a="http://schemas.openxmlformats.org/drawingml/2006/main">
               <a:ext uri="{FF2B5EF4-FFF2-40B4-BE49-F238E27FC236}">
-                <a16:creationId xmlns:a16="http://schemas.microsoft.com/office/drawing/2014/main" id="{F2959AF5-EFCA-4ADB-9B80-F1298A36CC07}"/>
+                <a16:creationId xmlns:a16="http://schemas.microsoft.com/office/drawing/2014/main" id="{C0532AA1-D516-4A7A-88D4-B95FC6D1079A}"/>
               </a:ext>
             </a:extLst>
           </p:cNvPr>
@@ -20601,10 +21368,10 @@
       </p:sp>
       <p:sp>
         <p:nvSpPr>
-          <p:cNvPr id="8" name="">
+          <p:cNvPr id="7" name="">
             <a:extLst xmlns:a="http://schemas.openxmlformats.org/drawingml/2006/main">
               <a:ext uri="{FF2B5EF4-FFF2-40B4-BE49-F238E27FC236}">
-                <a16:creationId xmlns:a16="http://schemas.microsoft.com/office/drawing/2014/main" id="{2A9C53F4-F648-4AE2-B98D-19A5A613454E}"/>
+                <a16:creationId xmlns:a16="http://schemas.microsoft.com/office/drawing/2014/main" id="{025466D9-DD8A-4A03-A906-049B05BAAB41}"/>
               </a:ext>
             </a:extLst>
           </p:cNvPr>
@@ -20759,10 +21526,10 @@
       </p:sp>
       <p:sp>
         <p:nvSpPr>
-          <p:cNvPr id="9" name="">
+          <p:cNvPr id="8" name="">
             <a:extLst xmlns:a="http://schemas.openxmlformats.org/drawingml/2006/main">
               <a:ext uri="{FF2B5EF4-FFF2-40B4-BE49-F238E27FC236}">
-                <a16:creationId xmlns:a16="http://schemas.microsoft.com/office/drawing/2014/main" id="{EFCC7610-EA1C-4374-B97C-62CBFD702140}"/>
+                <a16:creationId xmlns:a16="http://schemas.microsoft.com/office/drawing/2014/main" id="{4C51F5ED-CF1E-4D1C-A2A6-B4B2D4604F4B}"/>
               </a:ext>
             </a:extLst>
           </p:cNvPr>
@@ -20789,10 +21556,10 @@
       </p:sp>
       <p:sp>
         <p:nvSpPr>
-          <p:cNvPr id="10" name="">
+          <p:cNvPr id="9" name="">
             <a:extLst xmlns:a="http://schemas.openxmlformats.org/drawingml/2006/main">
               <a:ext uri="{FF2B5EF4-FFF2-40B4-BE49-F238E27FC236}">
-                <a16:creationId xmlns:a16="http://schemas.microsoft.com/office/drawing/2014/main" id="{F399F5A1-9C4C-480F-A805-BC0240230095}"/>
+                <a16:creationId xmlns:a16="http://schemas.microsoft.com/office/drawing/2014/main" id="{1935C587-9217-46D7-8C4B-C649E6CE4FDC}"/>
               </a:ext>
             </a:extLst>
           </p:cNvPr>
@@ -20828,10 +21595,10 @@
       </p:sp>
       <p:sp>
         <p:nvSpPr>
-          <p:cNvPr id="11" name="">
+          <p:cNvPr id="10" name="">
             <a:extLst xmlns:a="http://schemas.openxmlformats.org/drawingml/2006/main">
               <a:ext uri="{FF2B5EF4-FFF2-40B4-BE49-F238E27FC236}">
-                <a16:creationId xmlns:a16="http://schemas.microsoft.com/office/drawing/2014/main" id="{4C2CE59F-0F18-45EF-A83E-34F0929E4152}"/>
+                <a16:creationId xmlns:a16="http://schemas.microsoft.com/office/drawing/2014/main" id="{ABB72AE1-8B3E-424C-9D91-B1D39DE963E1}"/>
               </a:ext>
             </a:extLst>
           </p:cNvPr>
@@ -20858,10 +21625,10 @@
       </p:sp>
       <p:sp>
         <p:nvSpPr>
-          <p:cNvPr id="12" name="">
+          <p:cNvPr id="11" name="">
             <a:extLst xmlns:a="http://schemas.openxmlformats.org/drawingml/2006/main">
               <a:ext uri="{FF2B5EF4-FFF2-40B4-BE49-F238E27FC236}">
-                <a16:creationId xmlns:a16="http://schemas.microsoft.com/office/drawing/2014/main" id="{7B608D0F-8501-47A7-A28D-743A914E0EB8}"/>
+                <a16:creationId xmlns:a16="http://schemas.microsoft.com/office/drawing/2014/main" id="{6735D33F-097E-4A44-B3CB-A9B71E73A7F3}"/>
               </a:ext>
             </a:extLst>
           </p:cNvPr>
@@ -21016,10 +21783,10 @@
       </p:sp>
       <p:sp>
         <p:nvSpPr>
-          <p:cNvPr id="13" name="">
+          <p:cNvPr id="12" name="">
             <a:extLst xmlns:a="http://schemas.openxmlformats.org/drawingml/2006/main">
               <a:ext uri="{FF2B5EF4-FFF2-40B4-BE49-F238E27FC236}">
-                <a16:creationId xmlns:a16="http://schemas.microsoft.com/office/drawing/2014/main" id="{2E6862DF-7264-49B9-A21B-8C523D98E8A3}"/>
+                <a16:creationId xmlns:a16="http://schemas.microsoft.com/office/drawing/2014/main" id="{B1CC5607-9B45-4B4D-AA51-8D641EAC04B4}"/>
               </a:ext>
             </a:extLst>
           </p:cNvPr>
@@ -21174,10 +21941,10 @@
       </p:sp>
       <p:sp>
         <p:nvSpPr>
-          <p:cNvPr id="14" name="">
+          <p:cNvPr id="13" name="">
             <a:extLst xmlns:a="http://schemas.openxmlformats.org/drawingml/2006/main">
               <a:ext uri="{FF2B5EF4-FFF2-40B4-BE49-F238E27FC236}">
-                <a16:creationId xmlns:a16="http://schemas.microsoft.com/office/drawing/2014/main" id="{ACB1EC4E-3950-4651-BD3A-8D81BC75CC19}"/>
+                <a16:creationId xmlns:a16="http://schemas.microsoft.com/office/drawing/2014/main" id="{A01680F7-19CC-436B-86EE-179D49B3F6E9}"/>
               </a:ext>
             </a:extLst>
           </p:cNvPr>
@@ -21332,10 +22099,10 @@
       </p:sp>
       <p:sp>
         <p:nvSpPr>
-          <p:cNvPr id="15" name="">
+          <p:cNvPr id="14" name="">
             <a:extLst xmlns:a="http://schemas.openxmlformats.org/drawingml/2006/main">
               <a:ext uri="{FF2B5EF4-FFF2-40B4-BE49-F238E27FC236}">
-                <a16:creationId xmlns:a16="http://schemas.microsoft.com/office/drawing/2014/main" id="{47E52547-8DD0-491B-B8CF-C794774BA1F7}"/>
+                <a16:creationId xmlns:a16="http://schemas.microsoft.com/office/drawing/2014/main" id="{72EF30E1-01D1-4918-919F-301A57AB3D1B}"/>
               </a:ext>
             </a:extLst>
           </p:cNvPr>
@@ -21362,10 +22129,10 @@
       </p:sp>
       <p:sp>
         <p:nvSpPr>
-          <p:cNvPr id="16" name="">
+          <p:cNvPr id="15" name="">
             <a:extLst xmlns:a="http://schemas.openxmlformats.org/drawingml/2006/main">
               <a:ext uri="{FF2B5EF4-FFF2-40B4-BE49-F238E27FC236}">
-                <a16:creationId xmlns:a16="http://schemas.microsoft.com/office/drawing/2014/main" id="{DD87F7A1-00F2-461F-ACA6-6ACD4689212E}"/>
+                <a16:creationId xmlns:a16="http://schemas.microsoft.com/office/drawing/2014/main" id="{1E4EF751-FCBD-4B6D-9FD2-2ABDFE2B71AB}"/>
               </a:ext>
             </a:extLst>
           </p:cNvPr>
@@ -21401,10 +22168,10 @@
       </p:sp>
       <p:sp>
         <p:nvSpPr>
-          <p:cNvPr id="17" name="">
+          <p:cNvPr id="16" name="">
             <a:extLst xmlns:a="http://schemas.openxmlformats.org/drawingml/2006/main">
               <a:ext uri="{FF2B5EF4-FFF2-40B4-BE49-F238E27FC236}">
-                <a16:creationId xmlns:a16="http://schemas.microsoft.com/office/drawing/2014/main" id="{6F9FD88F-1786-484B-BEB6-5F4C209374E8}"/>
+                <a16:creationId xmlns:a16="http://schemas.microsoft.com/office/drawing/2014/main" id="{6497E8B3-A588-437B-873C-01144AA4DCDD}"/>
               </a:ext>
             </a:extLst>
           </p:cNvPr>
@@ -21431,10 +22198,10 @@
       </p:sp>
       <p:sp>
         <p:nvSpPr>
-          <p:cNvPr id="18" name="">
+          <p:cNvPr id="17" name="">
             <a:extLst xmlns:a="http://schemas.openxmlformats.org/drawingml/2006/main">
               <a:ext uri="{FF2B5EF4-FFF2-40B4-BE49-F238E27FC236}">
-                <a16:creationId xmlns:a16="http://schemas.microsoft.com/office/drawing/2014/main" id="{F3F6A71E-0FB6-414C-833C-BAEF77DCCAAD}"/>
+                <a16:creationId xmlns:a16="http://schemas.microsoft.com/office/drawing/2014/main" id="{56E8DE12-D4B6-4E46-BA6F-62BD8A6CF115}"/>
               </a:ext>
             </a:extLst>
           </p:cNvPr>
@@ -21470,10 +22237,10 @@
       </p:sp>
       <p:sp>
         <p:nvSpPr>
-          <p:cNvPr id="19" name="">
+          <p:cNvPr id="18" name="">
             <a:extLst xmlns:a="http://schemas.openxmlformats.org/drawingml/2006/main">
               <a:ext uri="{FF2B5EF4-FFF2-40B4-BE49-F238E27FC236}">
-                <a16:creationId xmlns:a16="http://schemas.microsoft.com/office/drawing/2014/main" id="{BBD321EE-E4BF-4AAD-A2ED-2F8E4416F339}"/>
+                <a16:creationId xmlns:a16="http://schemas.microsoft.com/office/drawing/2014/main" id="{430EA36F-71B1-49F6-85D5-648CCF71D984}"/>
               </a:ext>
             </a:extLst>
           </p:cNvPr>
@@ -21500,10 +22267,10 @@
       </p:sp>
       <p:sp>
         <p:nvSpPr>
-          <p:cNvPr id="20" name="">
+          <p:cNvPr id="19" name="">
             <a:extLst xmlns:a="http://schemas.openxmlformats.org/drawingml/2006/main">
               <a:ext uri="{FF2B5EF4-FFF2-40B4-BE49-F238E27FC236}">
-                <a16:creationId xmlns:a16="http://schemas.microsoft.com/office/drawing/2014/main" id="{B9D5AF84-E320-4472-8EC3-5BDEEB7DDFBA}"/>
+                <a16:creationId xmlns:a16="http://schemas.microsoft.com/office/drawing/2014/main" id="{2CC6B01C-2679-4E13-8109-89A2904199C7}"/>
               </a:ext>
             </a:extLst>
           </p:cNvPr>
@@ -21539,10 +22306,10 @@
       </p:sp>
       <p:sp>
         <p:nvSpPr>
-          <p:cNvPr id="21" name="">
+          <p:cNvPr id="20" name="">
             <a:extLst xmlns:a="http://schemas.openxmlformats.org/drawingml/2006/main">
               <a:ext uri="{FF2B5EF4-FFF2-40B4-BE49-F238E27FC236}">
-                <a16:creationId xmlns:a16="http://schemas.microsoft.com/office/drawing/2014/main" id="{44F74CAA-5CC1-4411-9AF0-66FFB45F0AFC}"/>
+                <a16:creationId xmlns:a16="http://schemas.microsoft.com/office/drawing/2014/main" id="{A7EF4E06-7B8B-49F3-8F8C-3FD4C1492DB4}"/>
               </a:ext>
             </a:extLst>
           </p:cNvPr>
@@ -21569,10 +22336,10 @@
       </p:sp>
       <p:sp>
         <p:nvSpPr>
-          <p:cNvPr id="22" name="">
+          <p:cNvPr id="21" name="">
             <a:extLst xmlns:a="http://schemas.openxmlformats.org/drawingml/2006/main">
               <a:ext uri="{FF2B5EF4-FFF2-40B4-BE49-F238E27FC236}">
-                <a16:creationId xmlns:a16="http://schemas.microsoft.com/office/drawing/2014/main" id="{885FCF13-95C3-4B60-9625-950696A3F997}"/>
+                <a16:creationId xmlns:a16="http://schemas.microsoft.com/office/drawing/2014/main" id="{106352A2-8DCC-418B-BC4D-19273699DB2B}"/>
               </a:ext>
             </a:extLst>
           </p:cNvPr>
@@ -21608,10 +22375,10 @@
       </p:sp>
       <p:sp>
         <p:nvSpPr>
-          <p:cNvPr id="23" name="">
+          <p:cNvPr id="22" name="">
             <a:extLst xmlns:a="http://schemas.openxmlformats.org/drawingml/2006/main">
               <a:ext uri="{FF2B5EF4-FFF2-40B4-BE49-F238E27FC236}">
-                <a16:creationId xmlns:a16="http://schemas.microsoft.com/office/drawing/2014/main" id="{D363FDB2-3F7F-44F4-99A0-69B241C6FAA9}"/>
+                <a16:creationId xmlns:a16="http://schemas.microsoft.com/office/drawing/2014/main" id="{DB02A701-7914-449A-B48E-F946C949EDE0}"/>
               </a:ext>
             </a:extLst>
           </p:cNvPr>
@@ -21638,10 +22405,10 @@
       </p:sp>
       <p:sp>
         <p:nvSpPr>
-          <p:cNvPr id="24" name="">
+          <p:cNvPr id="23" name="">
             <a:extLst xmlns:a="http://schemas.openxmlformats.org/drawingml/2006/main">
               <a:ext uri="{FF2B5EF4-FFF2-40B4-BE49-F238E27FC236}">
-                <a16:creationId xmlns:a16="http://schemas.microsoft.com/office/drawing/2014/main" id="{1A706ED2-94EB-4B7E-BEA2-863DF9A72B47}"/>
+                <a16:creationId xmlns:a16="http://schemas.microsoft.com/office/drawing/2014/main" id="{230BB566-D056-4D42-A834-170C1263AD63}"/>
               </a:ext>
             </a:extLst>
           </p:cNvPr>
@@ -21677,10 +22444,10 @@
       </p:sp>
       <p:sp>
         <p:nvSpPr>
-          <p:cNvPr id="25" name="">
+          <p:cNvPr id="24" name="">
             <a:extLst xmlns:a="http://schemas.openxmlformats.org/drawingml/2006/main">
               <a:ext uri="{FF2B5EF4-FFF2-40B4-BE49-F238E27FC236}">
-                <a16:creationId xmlns:a16="http://schemas.microsoft.com/office/drawing/2014/main" id="{0D37E7D4-C530-4D20-834A-57877EBECAB0}"/>
+                <a16:creationId xmlns:a16="http://schemas.microsoft.com/office/drawing/2014/main" id="{EA9DA135-65CD-44B8-8291-6C098F73778E}"/>
               </a:ext>
             </a:extLst>
           </p:cNvPr>
@@ -21707,10 +22474,10 @@
       </p:sp>
       <p:sp>
         <p:nvSpPr>
-          <p:cNvPr id="26" name="">
+          <p:cNvPr id="25" name="">
             <a:extLst xmlns:a="http://schemas.openxmlformats.org/drawingml/2006/main">
               <a:ext uri="{FF2B5EF4-FFF2-40B4-BE49-F238E27FC236}">
-                <a16:creationId xmlns:a16="http://schemas.microsoft.com/office/drawing/2014/main" id="{970A8B51-4003-4C37-8920-B811319E2843}"/>
+                <a16:creationId xmlns:a16="http://schemas.microsoft.com/office/drawing/2014/main" id="{F6A53A40-99DD-42F6-A126-029FCE9B5632}"/>
               </a:ext>
             </a:extLst>
           </p:cNvPr>
@@ -21746,10 +22513,10 @@
       </p:sp>
       <p:sp>
         <p:nvSpPr>
-          <p:cNvPr id="27" name="">
+          <p:cNvPr id="26" name="">
             <a:extLst xmlns:a="http://schemas.openxmlformats.org/drawingml/2006/main">
               <a:ext uri="{FF2B5EF4-FFF2-40B4-BE49-F238E27FC236}">
-                <a16:creationId xmlns:a16="http://schemas.microsoft.com/office/drawing/2014/main" id="{76968A0E-7322-4D6D-9DFA-65DC0C4B17A8}"/>
+                <a16:creationId xmlns:a16="http://schemas.microsoft.com/office/drawing/2014/main" id="{2961A144-8555-4FF3-9101-F82E0A8456CE}"/>
               </a:ext>
             </a:extLst>
           </p:cNvPr>
@@ -21776,10 +22543,10 @@
       </p:sp>
       <p:sp>
         <p:nvSpPr>
-          <p:cNvPr id="28" name="">
+          <p:cNvPr id="27" name="">
             <a:extLst xmlns:a="http://schemas.openxmlformats.org/drawingml/2006/main">
               <a:ext uri="{FF2B5EF4-FFF2-40B4-BE49-F238E27FC236}">
-                <a16:creationId xmlns:a16="http://schemas.microsoft.com/office/drawing/2014/main" id="{79E02820-F0EC-487F-8FE5-0151B3F2CAC0}"/>
+                <a16:creationId xmlns:a16="http://schemas.microsoft.com/office/drawing/2014/main" id="{C3FBD809-32DC-4FF0-910F-9D718054B462}"/>
               </a:ext>
             </a:extLst>
           </p:cNvPr>
@@ -21815,10 +22582,10 @@
       </p:sp>
       <p:sp>
         <p:nvSpPr>
-          <p:cNvPr id="29" name="">
+          <p:cNvPr id="28" name="">
             <a:extLst xmlns:a="http://schemas.openxmlformats.org/drawingml/2006/main">
               <a:ext uri="{FF2B5EF4-FFF2-40B4-BE49-F238E27FC236}">
-                <a16:creationId xmlns:a16="http://schemas.microsoft.com/office/drawing/2014/main" id="{F140D1ED-5106-4FB3-BA64-37CCEED077F1}"/>
+                <a16:creationId xmlns:a16="http://schemas.microsoft.com/office/drawing/2014/main" id="{0B88F034-8A5A-4C5F-B957-3BD5A4DC55E7}"/>
               </a:ext>
             </a:extLst>
           </p:cNvPr>
@@ -21845,10 +22612,10 @@
       </p:sp>
       <p:sp>
         <p:nvSpPr>
-          <p:cNvPr id="30" name="">
+          <p:cNvPr id="29" name="">
             <a:extLst xmlns:a="http://schemas.openxmlformats.org/drawingml/2006/main">
               <a:ext uri="{FF2B5EF4-FFF2-40B4-BE49-F238E27FC236}">
-                <a16:creationId xmlns:a16="http://schemas.microsoft.com/office/drawing/2014/main" id="{DF269C50-21AB-41A5-B490-E57D9BB03725}"/>
+                <a16:creationId xmlns:a16="http://schemas.microsoft.com/office/drawing/2014/main" id="{2528992A-A04E-4FB0-A4A2-AABAEB6E4573}"/>
               </a:ext>
             </a:extLst>
           </p:cNvPr>
@@ -21884,10 +22651,10 @@
       </p:sp>
       <p:sp>
         <p:nvSpPr>
-          <p:cNvPr id="31" name="">
+          <p:cNvPr id="30" name="">
             <a:extLst xmlns:a="http://schemas.openxmlformats.org/drawingml/2006/main">
               <a:ext uri="{FF2B5EF4-FFF2-40B4-BE49-F238E27FC236}">
-                <a16:creationId xmlns:a16="http://schemas.microsoft.com/office/drawing/2014/main" id="{992CF757-D91E-43E6-BB2D-DB0FA452AA7C}"/>
+                <a16:creationId xmlns:a16="http://schemas.microsoft.com/office/drawing/2014/main" id="{832CD2C8-9095-4207-992A-D91786C457E5}"/>
               </a:ext>
             </a:extLst>
           </p:cNvPr>
@@ -21914,10 +22681,10 @@
       </p:sp>
       <p:sp>
         <p:nvSpPr>
-          <p:cNvPr id="32" name="">
+          <p:cNvPr id="31" name="">
             <a:extLst xmlns:a="http://schemas.openxmlformats.org/drawingml/2006/main">
               <a:ext uri="{FF2B5EF4-FFF2-40B4-BE49-F238E27FC236}">
-                <a16:creationId xmlns:a16="http://schemas.microsoft.com/office/drawing/2014/main" id="{74130D35-37DF-49E5-815B-FD3493A2116C}"/>
+                <a16:creationId xmlns:a16="http://schemas.microsoft.com/office/drawing/2014/main" id="{8C12D87F-1979-4EC2-BC60-C42BF4E56DED}"/>
               </a:ext>
             </a:extLst>
           </p:cNvPr>
@@ -21953,10 +22720,10 @@
       </p:sp>
       <p:sp>
         <p:nvSpPr>
-          <p:cNvPr id="33" name="">
+          <p:cNvPr id="32" name="">
             <a:extLst xmlns:a="http://schemas.openxmlformats.org/drawingml/2006/main">
               <a:ext uri="{FF2B5EF4-FFF2-40B4-BE49-F238E27FC236}">
-                <a16:creationId xmlns:a16="http://schemas.microsoft.com/office/drawing/2014/main" id="{AA6B8C17-EDDE-4231-9851-B2E1A9054E1A}"/>
+                <a16:creationId xmlns:a16="http://schemas.microsoft.com/office/drawing/2014/main" id="{81B82EE5-76A9-495D-A966-B2958B929FC8}"/>
               </a:ext>
             </a:extLst>
           </p:cNvPr>
@@ -21983,10 +22750,10 @@
       </p:sp>
       <p:sp>
         <p:nvSpPr>
-          <p:cNvPr id="34" name="">
+          <p:cNvPr id="33" name="">
             <a:extLst xmlns:a="http://schemas.openxmlformats.org/drawingml/2006/main">
               <a:ext uri="{FF2B5EF4-FFF2-40B4-BE49-F238E27FC236}">
-                <a16:creationId xmlns:a16="http://schemas.microsoft.com/office/drawing/2014/main" id="{5C283B72-6F0A-47DE-A96C-6B64BD69EB87}"/>
+                <a16:creationId xmlns:a16="http://schemas.microsoft.com/office/drawing/2014/main" id="{7C4AB3E4-3EFF-433A-B334-89E1EE7AD36E}"/>
               </a:ext>
             </a:extLst>
           </p:cNvPr>
@@ -22022,10 +22789,10 @@
       </p:sp>
       <p:sp>
         <p:nvSpPr>
-          <p:cNvPr id="35" name="">
+          <p:cNvPr id="34" name="">
             <a:extLst xmlns:a="http://schemas.openxmlformats.org/drawingml/2006/main">
               <a:ext uri="{FF2B5EF4-FFF2-40B4-BE49-F238E27FC236}">
-                <a16:creationId xmlns:a16="http://schemas.microsoft.com/office/drawing/2014/main" id="{D30703E6-1ACE-4E9B-B80A-3217DF4D3AE1}"/>
+                <a16:creationId xmlns:a16="http://schemas.microsoft.com/office/drawing/2014/main" id="{0A31CAFB-D530-4756-BF14-034031850961}"/>
               </a:ext>
             </a:extLst>
           </p:cNvPr>
@@ -22052,10 +22819,10 @@
       </p:sp>
       <p:sp>
         <p:nvSpPr>
-          <p:cNvPr id="36" name="">
+          <p:cNvPr id="35" name="">
             <a:extLst xmlns:a="http://schemas.openxmlformats.org/drawingml/2006/main">
               <a:ext uri="{FF2B5EF4-FFF2-40B4-BE49-F238E27FC236}">
-                <a16:creationId xmlns:a16="http://schemas.microsoft.com/office/drawing/2014/main" id="{6709ECCA-BBB2-48A8-BE87-3F6C0B176A8C}"/>
+                <a16:creationId xmlns:a16="http://schemas.microsoft.com/office/drawing/2014/main" id="{9E18FFD0-F657-4DA2-B8DB-DDACB9928F15}"/>
               </a:ext>
             </a:extLst>
           </p:cNvPr>
@@ -22091,10 +22858,10 @@
       </p:sp>
       <p:sp>
         <p:nvSpPr>
-          <p:cNvPr id="37" name="">
+          <p:cNvPr id="36" name="">
             <a:extLst xmlns:a="http://schemas.openxmlformats.org/drawingml/2006/main">
               <a:ext uri="{FF2B5EF4-FFF2-40B4-BE49-F238E27FC236}">
-                <a16:creationId xmlns:a16="http://schemas.microsoft.com/office/drawing/2014/main" id="{856EE4E8-B9F5-4ED7-A5CF-008D286FDD23}"/>
+                <a16:creationId xmlns:a16="http://schemas.microsoft.com/office/drawing/2014/main" id="{AF8752D8-B982-4D8A-BF34-3E81D8703A3B}"/>
               </a:ext>
             </a:extLst>
           </p:cNvPr>
@@ -22121,10 +22888,10 @@
       </p:sp>
       <p:sp>
         <p:nvSpPr>
-          <p:cNvPr id="38" name="">
+          <p:cNvPr id="37" name="">
             <a:extLst xmlns:a="http://schemas.openxmlformats.org/drawingml/2006/main">
               <a:ext uri="{FF2B5EF4-FFF2-40B4-BE49-F238E27FC236}">
-                <a16:creationId xmlns:a16="http://schemas.microsoft.com/office/drawing/2014/main" id="{AFD96EFA-568F-4EB1-8294-AC47DF7792C6}"/>
+                <a16:creationId xmlns:a16="http://schemas.microsoft.com/office/drawing/2014/main" id="{44357B93-4E81-40AC-BB8B-B59EC6019E04}"/>
               </a:ext>
             </a:extLst>
           </p:cNvPr>
@@ -22160,10 +22927,10 @@
       </p:sp>
       <p:sp>
         <p:nvSpPr>
-          <p:cNvPr id="39" name="">
+          <p:cNvPr id="38" name="">
             <a:extLst xmlns:a="http://schemas.openxmlformats.org/drawingml/2006/main">
               <a:ext uri="{FF2B5EF4-FFF2-40B4-BE49-F238E27FC236}">
-                <a16:creationId xmlns:a16="http://schemas.microsoft.com/office/drawing/2014/main" id="{4CE7B4BA-830C-4FC8-93B0-A6C25530190C}"/>
+                <a16:creationId xmlns:a16="http://schemas.microsoft.com/office/drawing/2014/main" id="{AE150903-67B9-4BD8-9CAC-44C18DD0A505}"/>
               </a:ext>
             </a:extLst>
           </p:cNvPr>
@@ -22190,10 +22957,10 @@
       </p:sp>
       <p:sp>
         <p:nvSpPr>
-          <p:cNvPr id="40" name="">
+          <p:cNvPr id="39" name="">
             <a:extLst xmlns:a="http://schemas.openxmlformats.org/drawingml/2006/main">
               <a:ext uri="{FF2B5EF4-FFF2-40B4-BE49-F238E27FC236}">
-                <a16:creationId xmlns:a16="http://schemas.microsoft.com/office/drawing/2014/main" id="{02A6A0A3-3417-442C-8CAC-36A0BBFC2243}"/>
+                <a16:creationId xmlns:a16="http://schemas.microsoft.com/office/drawing/2014/main" id="{0E8928FC-92F2-4551-B1E7-9BAC7C88CA19}"/>
               </a:ext>
             </a:extLst>
           </p:cNvPr>
@@ -22229,10 +22996,10 @@
       </p:sp>
       <p:sp>
         <p:nvSpPr>
-          <p:cNvPr id="41" name="">
+          <p:cNvPr id="40" name="">
             <a:extLst xmlns:a="http://schemas.openxmlformats.org/drawingml/2006/main">
               <a:ext uri="{FF2B5EF4-FFF2-40B4-BE49-F238E27FC236}">
-                <a16:creationId xmlns:a16="http://schemas.microsoft.com/office/drawing/2014/main" id="{D64782F1-0A07-4B86-92CC-40A6A29F21CE}"/>
+                <a16:creationId xmlns:a16="http://schemas.microsoft.com/office/drawing/2014/main" id="{0BF4304E-AC01-43EA-AF4D-BE6BB65678E2}"/>
               </a:ext>
             </a:extLst>
           </p:cNvPr>
@@ -22259,10 +23026,10 @@
       </p:sp>
       <p:sp>
         <p:nvSpPr>
-          <p:cNvPr id="42" name="">
+          <p:cNvPr id="41" name="">
             <a:extLst xmlns:a="http://schemas.openxmlformats.org/drawingml/2006/main">
               <a:ext uri="{FF2B5EF4-FFF2-40B4-BE49-F238E27FC236}">
-                <a16:creationId xmlns:a16="http://schemas.microsoft.com/office/drawing/2014/main" id="{D1B9D060-F526-4F63-A84B-66FD24C3FD83}"/>
+                <a16:creationId xmlns:a16="http://schemas.microsoft.com/office/drawing/2014/main" id="{B4817CB5-9CB9-4F5E-BD41-BBBD78EF7884}"/>
               </a:ext>
             </a:extLst>
           </p:cNvPr>
@@ -22298,10 +23065,10 @@
       </p:sp>
       <p:sp>
         <p:nvSpPr>
-          <p:cNvPr id="43" name="">
+          <p:cNvPr id="42" name="">
             <a:extLst xmlns:a="http://schemas.openxmlformats.org/drawingml/2006/main">
               <a:ext uri="{FF2B5EF4-FFF2-40B4-BE49-F238E27FC236}">
-                <a16:creationId xmlns:a16="http://schemas.microsoft.com/office/drawing/2014/main" id="{2BA2BE35-87F2-47CA-81CA-52B97501DFD4}"/>
+                <a16:creationId xmlns:a16="http://schemas.microsoft.com/office/drawing/2014/main" id="{ED1FC1E3-87BC-4646-8CEF-EE5EE2DC8A8E}"/>
               </a:ext>
             </a:extLst>
           </p:cNvPr>
@@ -22328,10 +23095,10 @@
       </p:sp>
       <p:sp>
         <p:nvSpPr>
-          <p:cNvPr id="44" name="">
+          <p:cNvPr id="43" name="">
             <a:extLst xmlns:a="http://schemas.openxmlformats.org/drawingml/2006/main">
               <a:ext uri="{FF2B5EF4-FFF2-40B4-BE49-F238E27FC236}">
-                <a16:creationId xmlns:a16="http://schemas.microsoft.com/office/drawing/2014/main" id="{157E17B2-4659-4E40-AFEC-944BABFBA442}"/>
+                <a16:creationId xmlns:a16="http://schemas.microsoft.com/office/drawing/2014/main" id="{4096BDF6-3E21-41A9-9A47-5CE2A8768CF7}"/>
               </a:ext>
             </a:extLst>
           </p:cNvPr>
@@ -22367,10 +23134,10 @@
       </p:sp>
       <p:sp>
         <p:nvSpPr>
-          <p:cNvPr id="45" name="">
+          <p:cNvPr id="44" name="">
             <a:extLst xmlns:a="http://schemas.openxmlformats.org/drawingml/2006/main">
               <a:ext uri="{FF2B5EF4-FFF2-40B4-BE49-F238E27FC236}">
-                <a16:creationId xmlns:a16="http://schemas.microsoft.com/office/drawing/2014/main" id="{BE440E63-C20F-45AE-8257-0BC8D8FF1548}"/>
+                <a16:creationId xmlns:a16="http://schemas.microsoft.com/office/drawing/2014/main" id="{8675F771-01CD-4895-8CFC-C8D3246A6952}"/>
               </a:ext>
             </a:extLst>
           </p:cNvPr>
@@ -22397,10 +23164,10 @@
       </p:sp>
       <p:sp>
         <p:nvSpPr>
-          <p:cNvPr id="46" name="">
+          <p:cNvPr id="45" name="">
             <a:extLst xmlns:a="http://schemas.openxmlformats.org/drawingml/2006/main">
               <a:ext uri="{FF2B5EF4-FFF2-40B4-BE49-F238E27FC236}">
-                <a16:creationId xmlns:a16="http://schemas.microsoft.com/office/drawing/2014/main" id="{2579006B-55B0-4C0D-A7F0-EEF0D9701C60}"/>
+                <a16:creationId xmlns:a16="http://schemas.microsoft.com/office/drawing/2014/main" id="{9DE001AA-A949-449F-95A0-2F5CF41CEDF5}"/>
               </a:ext>
             </a:extLst>
           </p:cNvPr>
@@ -22436,10 +23203,10 @@
       </p:sp>
       <p:sp>
         <p:nvSpPr>
-          <p:cNvPr id="47" name="">
+          <p:cNvPr id="46" name="">
             <a:extLst xmlns:a="http://schemas.openxmlformats.org/drawingml/2006/main">
               <a:ext uri="{FF2B5EF4-FFF2-40B4-BE49-F238E27FC236}">
-                <a16:creationId xmlns:a16="http://schemas.microsoft.com/office/drawing/2014/main" id="{8B295CC0-10D9-47E7-B6B4-4E3114AE9CEC}"/>
+                <a16:creationId xmlns:a16="http://schemas.microsoft.com/office/drawing/2014/main" id="{E2DC3EFC-931C-470E-93E5-30746DDA0577}"/>
               </a:ext>
             </a:extLst>
           </p:cNvPr>
@@ -22466,10 +23233,10 @@
       </p:sp>
       <p:sp>
         <p:nvSpPr>
-          <p:cNvPr id="48" name="">
+          <p:cNvPr id="47" name="">
             <a:extLst xmlns:a="http://schemas.openxmlformats.org/drawingml/2006/main">
               <a:ext uri="{FF2B5EF4-FFF2-40B4-BE49-F238E27FC236}">
-                <a16:creationId xmlns:a16="http://schemas.microsoft.com/office/drawing/2014/main" id="{D7621604-119C-4CB7-AFD1-B2664F0EAD3F}"/>
+                <a16:creationId xmlns:a16="http://schemas.microsoft.com/office/drawing/2014/main" id="{9476EFA5-1957-4390-AD0A-2140E98AB47B}"/>
               </a:ext>
             </a:extLst>
           </p:cNvPr>
@@ -22505,10 +23272,10 @@
       </p:sp>
       <p:sp>
         <p:nvSpPr>
-          <p:cNvPr id="49" name="">
+          <p:cNvPr id="48" name="">
             <a:extLst xmlns:a="http://schemas.openxmlformats.org/drawingml/2006/main">
               <a:ext uri="{FF2B5EF4-FFF2-40B4-BE49-F238E27FC236}">
-                <a16:creationId xmlns:a16="http://schemas.microsoft.com/office/drawing/2014/main" id="{FEB15EA4-74B0-4BA7-91FB-D843C98A35F6}"/>
+                <a16:creationId xmlns:a16="http://schemas.microsoft.com/office/drawing/2014/main" id="{7D1D2240-EFCE-4A51-8C1D-B7073EC68CFF}"/>
               </a:ext>
             </a:extLst>
           </p:cNvPr>
@@ -22535,10 +23302,10 @@
       </p:sp>
       <p:sp>
         <p:nvSpPr>
-          <p:cNvPr id="50" name="">
+          <p:cNvPr id="49" name="">
             <a:extLst xmlns:a="http://schemas.openxmlformats.org/drawingml/2006/main">
               <a:ext uri="{FF2B5EF4-FFF2-40B4-BE49-F238E27FC236}">
-                <a16:creationId xmlns:a16="http://schemas.microsoft.com/office/drawing/2014/main" id="{3F54DE0B-11C5-460C-B3B0-789CDC70ED37}"/>
+                <a16:creationId xmlns:a16="http://schemas.microsoft.com/office/drawing/2014/main" id="{A424DE72-73FA-4F2F-9912-E4E1CA169E0B}"/>
               </a:ext>
             </a:extLst>
           </p:cNvPr>
@@ -22574,10 +23341,10 @@
       </p:sp>
       <p:sp>
         <p:nvSpPr>
-          <p:cNvPr id="51" name="">
+          <p:cNvPr id="50" name="">
             <a:extLst xmlns:a="http://schemas.openxmlformats.org/drawingml/2006/main">
               <a:ext uri="{FF2B5EF4-FFF2-40B4-BE49-F238E27FC236}">
-                <a16:creationId xmlns:a16="http://schemas.microsoft.com/office/drawing/2014/main" id="{5C0B2F32-AE67-4C77-A6A3-D23DD2B6EA0D}"/>
+                <a16:creationId xmlns:a16="http://schemas.microsoft.com/office/drawing/2014/main" id="{BF8E5B35-CF28-4137-ABC9-7748C2080CCB}"/>
               </a:ext>
             </a:extLst>
           </p:cNvPr>
@@ -22604,10 +23371,10 @@
       </p:sp>
       <p:sp>
         <p:nvSpPr>
-          <p:cNvPr id="52" name="">
+          <p:cNvPr id="51" name="">
             <a:extLst xmlns:a="http://schemas.openxmlformats.org/drawingml/2006/main">
               <a:ext uri="{FF2B5EF4-FFF2-40B4-BE49-F238E27FC236}">
-                <a16:creationId xmlns:a16="http://schemas.microsoft.com/office/drawing/2014/main" id="{009FE50C-8527-4450-9076-17B39D0633D8}"/>
+                <a16:creationId xmlns:a16="http://schemas.microsoft.com/office/drawing/2014/main" id="{CB57F13E-2980-4B60-B5EB-AD3851E23D34}"/>
               </a:ext>
             </a:extLst>
           </p:cNvPr>
@@ -22643,10 +23410,10 @@
       </p:sp>
       <p:sp>
         <p:nvSpPr>
-          <p:cNvPr id="53" name="">
+          <p:cNvPr id="52" name="">
             <a:extLst xmlns:a="http://schemas.openxmlformats.org/drawingml/2006/main">
               <a:ext uri="{FF2B5EF4-FFF2-40B4-BE49-F238E27FC236}">
-                <a16:creationId xmlns:a16="http://schemas.microsoft.com/office/drawing/2014/main" id="{2080EFC7-E6F2-401B-8518-261B309F2134}"/>
+                <a16:creationId xmlns:a16="http://schemas.microsoft.com/office/drawing/2014/main" id="{447C004D-AC64-4A01-93AE-05694889CC3B}"/>
               </a:ext>
             </a:extLst>
           </p:cNvPr>
@@ -22673,10 +23440,10 @@
       </p:sp>
       <p:sp>
         <p:nvSpPr>
-          <p:cNvPr id="54" name="">
+          <p:cNvPr id="53" name="">
             <a:extLst xmlns:a="http://schemas.openxmlformats.org/drawingml/2006/main">
               <a:ext uri="{FF2B5EF4-FFF2-40B4-BE49-F238E27FC236}">
-                <a16:creationId xmlns:a16="http://schemas.microsoft.com/office/drawing/2014/main" id="{83860FA4-C552-44E3-9930-881CA223D805}"/>
+                <a16:creationId xmlns:a16="http://schemas.microsoft.com/office/drawing/2014/main" id="{E782050C-DB78-4150-8C68-38886D67FD17}"/>
               </a:ext>
             </a:extLst>
           </p:cNvPr>
@@ -22712,10 +23479,10 @@
       </p:sp>
       <p:sp>
         <p:nvSpPr>
-          <p:cNvPr id="55" name="">
+          <p:cNvPr id="54" name="">
             <a:extLst xmlns:a="http://schemas.openxmlformats.org/drawingml/2006/main">
               <a:ext uri="{FF2B5EF4-FFF2-40B4-BE49-F238E27FC236}">
-                <a16:creationId xmlns:a16="http://schemas.microsoft.com/office/drawing/2014/main" id="{84B9BDE1-DF93-4F33-A11F-89973F955EEE}"/>
+                <a16:creationId xmlns:a16="http://schemas.microsoft.com/office/drawing/2014/main" id="{9BC8FB2F-815F-413B-BB5F-3BECCF783758}"/>
               </a:ext>
             </a:extLst>
           </p:cNvPr>
@@ -22742,10 +23509,10 @@
       </p:sp>
       <p:sp>
         <p:nvSpPr>
-          <p:cNvPr id="56" name="">
+          <p:cNvPr id="55" name="">
             <a:extLst xmlns:a="http://schemas.openxmlformats.org/drawingml/2006/main">
               <a:ext uri="{FF2B5EF4-FFF2-40B4-BE49-F238E27FC236}">
-                <a16:creationId xmlns:a16="http://schemas.microsoft.com/office/drawing/2014/main" id="{FE1DE31A-47A6-48EB-943C-C6B9F0619641}"/>
+                <a16:creationId xmlns:a16="http://schemas.microsoft.com/office/drawing/2014/main" id="{992B23B9-8679-42BC-A5C3-16CF2FDE6A76}"/>
               </a:ext>
             </a:extLst>
           </p:cNvPr>
@@ -22900,10 +23667,10 @@
       </p:sp>
       <p:sp>
         <p:nvSpPr>
-          <p:cNvPr id="57" name="">
+          <p:cNvPr id="56" name="">
             <a:extLst xmlns:a="http://schemas.openxmlformats.org/drawingml/2006/main">
               <a:ext uri="{FF2B5EF4-FFF2-40B4-BE49-F238E27FC236}">
-                <a16:creationId xmlns:a16="http://schemas.microsoft.com/office/drawing/2014/main" id="{63E47BF2-6394-4B3C-930F-C33BEC6AB60C}"/>
+                <a16:creationId xmlns:a16="http://schemas.microsoft.com/office/drawing/2014/main" id="{1B0840FC-8993-4FBA-9BBB-FAE62D25787C}"/>
               </a:ext>
             </a:extLst>
           </p:cNvPr>
@@ -23058,10 +23825,10 @@
       </p:sp>
       <p:sp>
         <p:nvSpPr>
-          <p:cNvPr id="58" name="">
+          <p:cNvPr id="57" name="">
             <a:extLst xmlns:a="http://schemas.openxmlformats.org/drawingml/2006/main">
               <a:ext uri="{FF2B5EF4-FFF2-40B4-BE49-F238E27FC236}">
-                <a16:creationId xmlns:a16="http://schemas.microsoft.com/office/drawing/2014/main" id="{E38011CB-564A-48F9-B6D0-EA1FFC469BB3}"/>
+                <a16:creationId xmlns:a16="http://schemas.microsoft.com/office/drawing/2014/main" id="{573A2DDA-74B3-4AA1-9F74-E365E3F21696}"/>
               </a:ext>
             </a:extLst>
           </p:cNvPr>
@@ -23216,10 +23983,10 @@
       </p:sp>
       <p:sp>
         <p:nvSpPr>
-          <p:cNvPr id="59" name="">
+          <p:cNvPr id="58" name="">
             <a:extLst xmlns:a="http://schemas.openxmlformats.org/drawingml/2006/main">
               <a:ext uri="{FF2B5EF4-FFF2-40B4-BE49-F238E27FC236}">
-                <a16:creationId xmlns:a16="http://schemas.microsoft.com/office/drawing/2014/main" id="{A5CA766E-F396-41DD-8B7B-66DD74242D9A}"/>
+                <a16:creationId xmlns:a16="http://schemas.microsoft.com/office/drawing/2014/main" id="{16C32ABB-22A9-4EF1-BB0D-DD2AD7CB96C1}"/>
               </a:ext>
             </a:extLst>
           </p:cNvPr>
@@ -23374,10 +24141,10 @@
       </p:sp>
       <p:sp>
         <p:nvSpPr>
-          <p:cNvPr id="60" name="">
+          <p:cNvPr id="59" name="">
             <a:extLst xmlns:a="http://schemas.openxmlformats.org/drawingml/2006/main">
               <a:ext uri="{FF2B5EF4-FFF2-40B4-BE49-F238E27FC236}">
-                <a16:creationId xmlns:a16="http://schemas.microsoft.com/office/drawing/2014/main" id="{E040D0CF-EC52-4BE7-9B54-A1E3B18DB5F6}"/>
+                <a16:creationId xmlns:a16="http://schemas.microsoft.com/office/drawing/2014/main" id="{FAD647F7-3294-4AD9-83CB-C767A9A223BA}"/>
               </a:ext>
             </a:extLst>
           </p:cNvPr>
@@ -23533,7 +24300,7 @@
     </p:spTree>
     <p:extLst>
       <p:ext uri="{BB962C8B-B14F-4D97-AF65-F5344CB8AC3E}">
-        <p14:creationId xmlns:p14="http://schemas.microsoft.com/office/powerpoint/2010/main" val="2105632725"/>
+        <p14:creationId xmlns:p14="http://schemas.microsoft.com/office/powerpoint/2010/main" val="1040324636"/>
       </p:ext>
     </p:extLst>
   </p:cSld>
@@ -23561,10 +24328,10 @@
       </p:grpSpPr>
       <p:sp>
         <p:nvSpPr>
-          <p:cNvPr id="2" name="">
+          <p:cNvPr id="16" name="">
             <a:extLst xmlns:a="http://schemas.openxmlformats.org/drawingml/2006/main">
               <a:ext uri="{FF2B5EF4-FFF2-40B4-BE49-F238E27FC236}">
-                <a16:creationId xmlns:a16="http://schemas.microsoft.com/office/drawing/2014/main" id="{19A83C15-061A-4D80-9281-81847573F03E}"/>
+                <a16:creationId xmlns:a16="http://schemas.microsoft.com/office/drawing/2014/main" id="{4EF45259-627E-42F1-A2AE-AF1BCD456876}"/>
               </a:ext>
             </a:extLst>
           </p:cNvPr>
@@ -23719,10 +24486,10 @@
       </p:sp>
       <p:sp>
         <p:nvSpPr>
-          <p:cNvPr id="3" name="">
+          <p:cNvPr id="2" name="">
             <a:extLst xmlns:a="http://schemas.openxmlformats.org/drawingml/2006/main">
               <a:ext uri="{FF2B5EF4-FFF2-40B4-BE49-F238E27FC236}">
-                <a16:creationId xmlns:a16="http://schemas.microsoft.com/office/drawing/2014/main" id="{72CD74CD-3A3A-428F-9B2B-EE1CF75B90D1}"/>
+                <a16:creationId xmlns:a16="http://schemas.microsoft.com/office/drawing/2014/main" id="{225F9CCA-FFF1-4646-BCB9-08BBA7C4C7C0}"/>
               </a:ext>
             </a:extLst>
           </p:cNvPr>
@@ -23877,10 +24644,10 @@
       </p:sp>
       <p:sp>
         <p:nvSpPr>
-          <p:cNvPr id="4" name="">
+          <p:cNvPr id="3" name="">
             <a:extLst xmlns:a="http://schemas.openxmlformats.org/drawingml/2006/main">
               <a:ext uri="{FF2B5EF4-FFF2-40B4-BE49-F238E27FC236}">
-                <a16:creationId xmlns:a16="http://schemas.microsoft.com/office/drawing/2014/main" id="{46EC8C73-515E-4431-B0F8-41CC2698BF28}"/>
+                <a16:creationId xmlns:a16="http://schemas.microsoft.com/office/drawing/2014/main" id="{4C5A805E-A2BB-4783-B3F2-7EA3C794B635}"/>
               </a:ext>
             </a:extLst>
           </p:cNvPr>
@@ -24035,10 +24802,10 @@
       </p:sp>
       <p:sp>
         <p:nvSpPr>
-          <p:cNvPr id="5" name="">
+          <p:cNvPr id="4" name="">
             <a:extLst xmlns:a="http://schemas.openxmlformats.org/drawingml/2006/main">
               <a:ext uri="{FF2B5EF4-FFF2-40B4-BE49-F238E27FC236}">
-                <a16:creationId xmlns:a16="http://schemas.microsoft.com/office/drawing/2014/main" id="{D6EC610C-BE5D-4702-8CB3-74A5BA67DA71}"/>
+                <a16:creationId xmlns:a16="http://schemas.microsoft.com/office/drawing/2014/main" id="{8556E481-E063-4DCE-8C4A-1DD8421CD375}"/>
               </a:ext>
             </a:extLst>
           </p:cNvPr>
@@ -24193,10 +24960,10 @@
       </p:sp>
       <p:sp>
         <p:nvSpPr>
-          <p:cNvPr id="6" name="">
+          <p:cNvPr id="5" name="">
             <a:extLst xmlns:a="http://schemas.openxmlformats.org/drawingml/2006/main">
               <a:ext uri="{FF2B5EF4-FFF2-40B4-BE49-F238E27FC236}">
-                <a16:creationId xmlns:a16="http://schemas.microsoft.com/office/drawing/2014/main" id="{216EB464-8DCB-40CD-902C-CE47B2BC823A}"/>
+                <a16:creationId xmlns:a16="http://schemas.microsoft.com/office/drawing/2014/main" id="{944C912F-D5EE-4E7F-9BEE-3F24292E111B}"/>
               </a:ext>
             </a:extLst>
           </p:cNvPr>
@@ -24355,10 +25122,10 @@
       </p:sp>
       <p:sp>
         <p:nvSpPr>
-          <p:cNvPr id="7" name="">
+          <p:cNvPr id="6" name="">
             <a:extLst xmlns:a="http://schemas.openxmlformats.org/drawingml/2006/main">
               <a:ext uri="{FF2B5EF4-FFF2-40B4-BE49-F238E27FC236}">
-                <a16:creationId xmlns:a16="http://schemas.microsoft.com/office/drawing/2014/main" id="{F353F7E4-A2C4-4F5A-BE6D-4ACC09F58282}"/>
+                <a16:creationId xmlns:a16="http://schemas.microsoft.com/office/drawing/2014/main" id="{FBAFA299-0E84-4192-8D5B-910C17078A13}"/>
               </a:ext>
             </a:extLst>
           </p:cNvPr>
@@ -24513,10 +25280,10 @@
       </p:sp>
       <p:sp>
         <p:nvSpPr>
-          <p:cNvPr id="8" name="">
+          <p:cNvPr id="7" name="">
             <a:extLst xmlns:a="http://schemas.openxmlformats.org/drawingml/2006/main">
               <a:ext uri="{FF2B5EF4-FFF2-40B4-BE49-F238E27FC236}">
-                <a16:creationId xmlns:a16="http://schemas.microsoft.com/office/drawing/2014/main" id="{A291CCFC-9F48-4992-AC70-D738963613B1}"/>
+                <a16:creationId xmlns:a16="http://schemas.microsoft.com/office/drawing/2014/main" id="{1D186CDF-E0CF-4088-A291-7A2C11D49D14}"/>
               </a:ext>
             </a:extLst>
           </p:cNvPr>
@@ -24675,10 +25442,10 @@
       </p:sp>
       <p:sp>
         <p:nvSpPr>
-          <p:cNvPr id="9" name="">
+          <p:cNvPr id="8" name="">
             <a:extLst xmlns:a="http://schemas.openxmlformats.org/drawingml/2006/main">
               <a:ext uri="{FF2B5EF4-FFF2-40B4-BE49-F238E27FC236}">
-                <a16:creationId xmlns:a16="http://schemas.microsoft.com/office/drawing/2014/main" id="{4A6E073E-ABD8-472F-A678-5CB6F721A030}"/>
+                <a16:creationId xmlns:a16="http://schemas.microsoft.com/office/drawing/2014/main" id="{CAC6A929-DB4B-4D30-96C0-260035181061}"/>
               </a:ext>
             </a:extLst>
           </p:cNvPr>
@@ -24837,10 +25604,10 @@
       </p:sp>
       <p:sp>
         <p:nvSpPr>
-          <p:cNvPr id="10" name="">
+          <p:cNvPr id="9" name="">
             <a:extLst xmlns:a="http://schemas.openxmlformats.org/drawingml/2006/main">
               <a:ext uri="{FF2B5EF4-FFF2-40B4-BE49-F238E27FC236}">
-                <a16:creationId xmlns:a16="http://schemas.microsoft.com/office/drawing/2014/main" id="{507E6652-3846-4D7A-87E9-7FBDC6D041F1}"/>
+                <a16:creationId xmlns:a16="http://schemas.microsoft.com/office/drawing/2014/main" id="{8558D8EA-F811-4447-895B-61EC33CB285A}"/>
               </a:ext>
             </a:extLst>
           </p:cNvPr>
@@ -24995,10 +25762,10 @@
       </p:sp>
       <p:sp>
         <p:nvSpPr>
-          <p:cNvPr id="11" name="">
+          <p:cNvPr id="10" name="">
             <a:extLst xmlns:a="http://schemas.openxmlformats.org/drawingml/2006/main">
               <a:ext uri="{FF2B5EF4-FFF2-40B4-BE49-F238E27FC236}">
-                <a16:creationId xmlns:a16="http://schemas.microsoft.com/office/drawing/2014/main" id="{52C74ADD-41C5-4581-904F-75F2F33DE5DD}"/>
+                <a16:creationId xmlns:a16="http://schemas.microsoft.com/office/drawing/2014/main" id="{738F4603-01F5-411B-8583-53F250AD1405}"/>
               </a:ext>
             </a:extLst>
           </p:cNvPr>
@@ -25157,10 +25924,10 @@
       </p:sp>
       <p:sp>
         <p:nvSpPr>
-          <p:cNvPr id="12" name="">
+          <p:cNvPr id="11" name="">
             <a:extLst xmlns:a="http://schemas.openxmlformats.org/drawingml/2006/main">
               <a:ext uri="{FF2B5EF4-FFF2-40B4-BE49-F238E27FC236}">
-                <a16:creationId xmlns:a16="http://schemas.microsoft.com/office/drawing/2014/main" id="{854C6F1A-606C-477D-977A-0E9E4A7E077D}"/>
+                <a16:creationId xmlns:a16="http://schemas.microsoft.com/office/drawing/2014/main" id="{55B2230D-F4BB-484B-BB53-E3955FABA0EC}"/>
               </a:ext>
             </a:extLst>
           </p:cNvPr>
@@ -25319,10 +26086,10 @@
       </p:sp>
       <p:sp>
         <p:nvSpPr>
-          <p:cNvPr id="13" name="">
+          <p:cNvPr id="12" name="">
             <a:extLst xmlns:a="http://schemas.openxmlformats.org/drawingml/2006/main">
               <a:ext uri="{FF2B5EF4-FFF2-40B4-BE49-F238E27FC236}">
-                <a16:creationId xmlns:a16="http://schemas.microsoft.com/office/drawing/2014/main" id="{4F3F9838-0CA4-4AB8-990F-FCFECDAF609D}"/>
+                <a16:creationId xmlns:a16="http://schemas.microsoft.com/office/drawing/2014/main" id="{686C55AC-59A4-40BC-B783-2D49272D1281}"/>
               </a:ext>
             </a:extLst>
           </p:cNvPr>
@@ -25481,10 +26248,10 @@
       </p:sp>
       <p:sp>
         <p:nvSpPr>
-          <p:cNvPr id="14" name="">
+          <p:cNvPr id="13" name="">
             <a:extLst xmlns:a="http://schemas.openxmlformats.org/drawingml/2006/main">
               <a:ext uri="{FF2B5EF4-FFF2-40B4-BE49-F238E27FC236}">
-                <a16:creationId xmlns:a16="http://schemas.microsoft.com/office/drawing/2014/main" id="{1DF97782-9671-45C4-A083-3091D9A8ECD2}"/>
+                <a16:creationId xmlns:a16="http://schemas.microsoft.com/office/drawing/2014/main" id="{F050F075-12A8-4D62-91D9-E8D36D654195}"/>
               </a:ext>
             </a:extLst>
           </p:cNvPr>
@@ -25643,10 +26410,10 @@
       </p:sp>
       <p:sp>
         <p:nvSpPr>
-          <p:cNvPr id="15" name="">
+          <p:cNvPr id="14" name="">
             <a:extLst xmlns:a="http://schemas.openxmlformats.org/drawingml/2006/main">
               <a:ext uri="{FF2B5EF4-FFF2-40B4-BE49-F238E27FC236}">
-                <a16:creationId xmlns:a16="http://schemas.microsoft.com/office/drawing/2014/main" id="{F05C5A0D-9544-48D0-8297-A12011A57CF6}"/>
+                <a16:creationId xmlns:a16="http://schemas.microsoft.com/office/drawing/2014/main" id="{9FD78768-EDFC-44C9-8B8E-684FA93924DA}"/>
               </a:ext>
             </a:extLst>
           </p:cNvPr>
@@ -25801,10 +26568,10 @@
       </p:sp>
       <p:sp>
         <p:nvSpPr>
-          <p:cNvPr id="16" name="">
+          <p:cNvPr id="15" name="">
             <a:extLst xmlns:a="http://schemas.openxmlformats.org/drawingml/2006/main">
               <a:ext uri="{FF2B5EF4-FFF2-40B4-BE49-F238E27FC236}">
-                <a16:creationId xmlns:a16="http://schemas.microsoft.com/office/drawing/2014/main" id="{9BE0D7C9-4A35-4093-BB4E-FC7C3C9AE44E}"/>
+                <a16:creationId xmlns:a16="http://schemas.microsoft.com/office/drawing/2014/main" id="{63A07423-7505-4CC7-B75C-A6F64AB01EE4}"/>
               </a:ext>
             </a:extLst>
           </p:cNvPr>
@@ -25960,7 +26727,7 @@
     </p:spTree>
     <p:extLst>
       <p:ext uri="{BB962C8B-B14F-4D97-AF65-F5344CB8AC3E}">
-        <p14:creationId xmlns:p14="http://schemas.microsoft.com/office/powerpoint/2010/main" val="1303066440"/>
+        <p14:creationId xmlns:p14="http://schemas.microsoft.com/office/powerpoint/2010/main" val="41549408"/>
       </p:ext>
     </p:extLst>
   </p:cSld>
@@ -25988,10 +26755,10 @@
       </p:grpSpPr>
       <p:sp>
         <p:nvSpPr>
-          <p:cNvPr id="2" name="">
+          <p:cNvPr id="6" name="">
             <a:extLst xmlns:a="http://schemas.openxmlformats.org/drawingml/2006/main">
               <a:ext uri="{FF2B5EF4-FFF2-40B4-BE49-F238E27FC236}">
-                <a16:creationId xmlns:a16="http://schemas.microsoft.com/office/drawing/2014/main" id="{ACBC2F98-6867-4480-9469-2BA23E41D0C8}"/>
+                <a16:creationId xmlns:a16="http://schemas.microsoft.com/office/drawing/2014/main" id="{5B0A5B72-E462-4D20-863B-D815E8C7EA70}"/>
               </a:ext>
             </a:extLst>
           </p:cNvPr>
@@ -26146,10 +26913,10 @@
       </p:sp>
       <p:sp>
         <p:nvSpPr>
-          <p:cNvPr id="3" name="">
+          <p:cNvPr id="2" name="">
             <a:extLst xmlns:a="http://schemas.openxmlformats.org/drawingml/2006/main">
               <a:ext uri="{FF2B5EF4-FFF2-40B4-BE49-F238E27FC236}">
-                <a16:creationId xmlns:a16="http://schemas.microsoft.com/office/drawing/2014/main" id="{69F6820D-3ED4-4DED-A6C4-9DFF3A847D45}"/>
+                <a16:creationId xmlns:a16="http://schemas.microsoft.com/office/drawing/2014/main" id="{C7DCAD16-151D-4E73-A27E-CE01C3767CBA}"/>
               </a:ext>
             </a:extLst>
           </p:cNvPr>
@@ -26304,10 +27071,10 @@
       </p:sp>
       <p:graphicFrame>
         <p:nvGraphicFramePr>
-          <p:cNvPr id="4" name="Chart">
+          <p:cNvPr id="3" name="Chart">
             <a:extLst xmlns:a="http://schemas.openxmlformats.org/drawingml/2006/main">
               <a:ext uri="{FF2B5EF4-FFF2-40B4-BE49-F238E27FC236}">
-                <a16:creationId xmlns:a16="http://schemas.microsoft.com/office/drawing/2014/main" id="{8423582E-4E9B-4179-A606-677E6F9F5E58}"/>
+                <a16:creationId xmlns:a16="http://schemas.microsoft.com/office/drawing/2014/main" id="{506C1760-849C-4552-BC04-6E88F29A03C0}"/>
               </a:ext>
             </a:extLst>
           </p:cNvPr>
@@ -26320,16 +27087,16 @@
         </p:xfrm>
         <a:graphic xmlns:a="http://schemas.openxmlformats.org/drawingml/2006/main">
           <a:graphicData uri="http://schemas.openxmlformats.org/drawingml/2006/chart">
-            <c:chart xmlns:r="http://schemas.openxmlformats.org/officeDocument/2006/relationships" xmlns:c="http://schemas.openxmlformats.org/drawingml/2006/chart" r:id="Re0dd28eb2b4741ef"/>
+            <c:chart xmlns:r="http://schemas.openxmlformats.org/officeDocument/2006/relationships" xmlns:c="http://schemas.openxmlformats.org/drawingml/2006/chart" r:id="R0aa4f5f8168b47f9"/>
           </a:graphicData>
         </a:graphic>
       </p:graphicFrame>
       <p:sp>
         <p:nvSpPr>
-          <p:cNvPr id="5" name="">
+          <p:cNvPr id="4" name="">
             <a:extLst xmlns:a="http://schemas.openxmlformats.org/drawingml/2006/main">
               <a:ext uri="{FF2B5EF4-FFF2-40B4-BE49-F238E27FC236}">
-                <a16:creationId xmlns:a16="http://schemas.microsoft.com/office/drawing/2014/main" id="{8F8BD391-E7AA-429D-A552-49F74CBE7E3E}"/>
+                <a16:creationId xmlns:a16="http://schemas.microsoft.com/office/drawing/2014/main" id="{005C5499-188E-4BC0-9810-8017E74D6C26}"/>
               </a:ext>
             </a:extLst>
           </p:cNvPr>
@@ -26484,10 +27251,10 @@
       </p:sp>
       <p:sp>
         <p:nvSpPr>
-          <p:cNvPr id="6" name="">
+          <p:cNvPr id="5" name="">
             <a:extLst xmlns:a="http://schemas.openxmlformats.org/drawingml/2006/main">
               <a:ext uri="{FF2B5EF4-FFF2-40B4-BE49-F238E27FC236}">
-                <a16:creationId xmlns:a16="http://schemas.microsoft.com/office/drawing/2014/main" id="{CF7505A4-B61E-4E0E-A183-35C24D7728A0}"/>
+                <a16:creationId xmlns:a16="http://schemas.microsoft.com/office/drawing/2014/main" id="{948F5842-67E5-45FC-A438-05EF5B120B0C}"/>
               </a:ext>
             </a:extLst>
           </p:cNvPr>
@@ -26643,7 +27410,7 @@
     </p:spTree>
     <p:extLst>
       <p:ext uri="{BB962C8B-B14F-4D97-AF65-F5344CB8AC3E}">
-        <p14:creationId xmlns:p14="http://schemas.microsoft.com/office/powerpoint/2010/main" val="333193287"/>
+        <p14:creationId xmlns:p14="http://schemas.microsoft.com/office/powerpoint/2010/main" val="651166773"/>
       </p:ext>
     </p:extLst>
   </p:cSld>
@@ -26671,10 +27438,10 @@
       </p:grpSpPr>
       <p:sp>
         <p:nvSpPr>
-          <p:cNvPr id="2" name="">
+          <p:cNvPr id="5" name="">
             <a:extLst xmlns:a="http://schemas.openxmlformats.org/drawingml/2006/main">
               <a:ext uri="{FF2B5EF4-FFF2-40B4-BE49-F238E27FC236}">
-                <a16:creationId xmlns:a16="http://schemas.microsoft.com/office/drawing/2014/main" id="{21D4124E-C818-4439-BF1D-3ECC3289E4C6}"/>
+                <a16:creationId xmlns:a16="http://schemas.microsoft.com/office/drawing/2014/main" id="{F0D343CC-1CDB-4472-94E6-B4D88BD0D3FB}"/>
               </a:ext>
             </a:extLst>
           </p:cNvPr>
@@ -26829,10 +27596,10 @@
       </p:sp>
       <p:sp>
         <p:nvSpPr>
-          <p:cNvPr id="3" name="">
+          <p:cNvPr id="2" name="">
             <a:extLst xmlns:a="http://schemas.openxmlformats.org/drawingml/2006/main">
               <a:ext uri="{FF2B5EF4-FFF2-40B4-BE49-F238E27FC236}">
-                <a16:creationId xmlns:a16="http://schemas.microsoft.com/office/drawing/2014/main" id="{07D37D8D-91D1-4BEF-AC89-3280AD505136}"/>
+                <a16:creationId xmlns:a16="http://schemas.microsoft.com/office/drawing/2014/main" id="{D00C819D-3DE7-4F3C-9D0C-0E23CF760194}"/>
               </a:ext>
             </a:extLst>
           </p:cNvPr>
@@ -26987,10 +27754,10 @@
       </p:sp>
       <p:graphicFrame>
         <p:nvGraphicFramePr>
-          <p:cNvPr id="4" name="Chart">
+          <p:cNvPr id="3" name="Chart">
             <a:extLst xmlns:a="http://schemas.openxmlformats.org/drawingml/2006/main">
               <a:ext uri="{FF2B5EF4-FFF2-40B4-BE49-F238E27FC236}">
-                <a16:creationId xmlns:a16="http://schemas.microsoft.com/office/drawing/2014/main" id="{DF756103-FE00-4D27-90BF-2D19C05D43CD}"/>
+                <a16:creationId xmlns:a16="http://schemas.microsoft.com/office/drawing/2014/main" id="{F6C20DE0-71F6-4E57-B832-D7D9FC2AF305}"/>
               </a:ext>
             </a:extLst>
           </p:cNvPr>
@@ -27003,16 +27770,16 @@
         </p:xfrm>
         <a:graphic xmlns:a="http://schemas.openxmlformats.org/drawingml/2006/main">
           <a:graphicData uri="http://schemas.openxmlformats.org/drawingml/2006/chart">
-            <c:chart xmlns:r="http://schemas.openxmlformats.org/officeDocument/2006/relationships" xmlns:c="http://schemas.openxmlformats.org/drawingml/2006/chart" r:id="Rf2693dfbece44fc2"/>
+            <c:chart xmlns:r="http://schemas.openxmlformats.org/officeDocument/2006/relationships" xmlns:c="http://schemas.openxmlformats.org/drawingml/2006/chart" r:id="R8fd2ecac487e4d67"/>
           </a:graphicData>
         </a:graphic>
       </p:graphicFrame>
       <p:sp>
         <p:nvSpPr>
-          <p:cNvPr id="5" name="">
+          <p:cNvPr id="4" name="">
             <a:extLst xmlns:a="http://schemas.openxmlformats.org/drawingml/2006/main">
               <a:ext uri="{FF2B5EF4-FFF2-40B4-BE49-F238E27FC236}">
-                <a16:creationId xmlns:a16="http://schemas.microsoft.com/office/drawing/2014/main" id="{16121F55-663B-4AD5-AB30-1782E12D5273}"/>
+                <a16:creationId xmlns:a16="http://schemas.microsoft.com/office/drawing/2014/main" id="{9DC02A05-20A7-465E-8949-A71729056C4F}"/>
               </a:ext>
             </a:extLst>
           </p:cNvPr>
@@ -27168,7 +27935,7 @@
     </p:spTree>
     <p:extLst>
       <p:ext uri="{BB962C8B-B14F-4D97-AF65-F5344CB8AC3E}">
-        <p14:creationId xmlns:p14="http://schemas.microsoft.com/office/powerpoint/2010/main" val="2119029311"/>
+        <p14:creationId xmlns:p14="http://schemas.microsoft.com/office/powerpoint/2010/main" val="995710271"/>
       </p:ext>
     </p:extLst>
   </p:cSld>
@@ -27196,10 +27963,10 @@
       </p:grpSpPr>
       <p:sp>
         <p:nvSpPr>
-          <p:cNvPr id="2" name="">
+          <p:cNvPr id="6" name="">
             <a:extLst xmlns:a="http://schemas.openxmlformats.org/drawingml/2006/main">
               <a:ext uri="{FF2B5EF4-FFF2-40B4-BE49-F238E27FC236}">
-                <a16:creationId xmlns:a16="http://schemas.microsoft.com/office/drawing/2014/main" id="{B0B50AD5-16CB-4563-B54E-D591B979A676}"/>
+                <a16:creationId xmlns:a16="http://schemas.microsoft.com/office/drawing/2014/main" id="{B50AE451-45DE-488C-BF18-60DA8A396061}"/>
               </a:ext>
             </a:extLst>
           </p:cNvPr>
@@ -27354,10 +28121,10 @@
       </p:sp>
       <p:sp>
         <p:nvSpPr>
-          <p:cNvPr id="3" name="">
+          <p:cNvPr id="2" name="">
             <a:extLst xmlns:a="http://schemas.openxmlformats.org/drawingml/2006/main">
               <a:ext uri="{FF2B5EF4-FFF2-40B4-BE49-F238E27FC236}">
-                <a16:creationId xmlns:a16="http://schemas.microsoft.com/office/drawing/2014/main" id="{05AFB8DE-A798-4F5D-A9AF-42431DDA9FCC}"/>
+                <a16:creationId xmlns:a16="http://schemas.microsoft.com/office/drawing/2014/main" id="{7D645C7C-3D22-4D74-ACD9-C656F4026694}"/>
               </a:ext>
             </a:extLst>
           </p:cNvPr>
@@ -27512,10 +28279,10 @@
       </p:sp>
       <p:graphicFrame>
         <p:nvGraphicFramePr>
-          <p:cNvPr id="4" name="Chart">
+          <p:cNvPr id="3" name="Chart">
             <a:extLst xmlns:a="http://schemas.openxmlformats.org/drawingml/2006/main">
               <a:ext uri="{FF2B5EF4-FFF2-40B4-BE49-F238E27FC236}">
-                <a16:creationId xmlns:a16="http://schemas.microsoft.com/office/drawing/2014/main" id="{598D41FF-3451-44EC-9688-E6B45E1A0D63}"/>
+                <a16:creationId xmlns:a16="http://schemas.microsoft.com/office/drawing/2014/main" id="{442E1C8C-BD8B-4713-A381-B5BA14336778}"/>
               </a:ext>
             </a:extLst>
           </p:cNvPr>
@@ -27528,16 +28295,16 @@
         </p:xfrm>
         <a:graphic xmlns:a="http://schemas.openxmlformats.org/drawingml/2006/main">
           <a:graphicData uri="http://schemas.openxmlformats.org/drawingml/2006/chart">
-            <c:chart xmlns:r="http://schemas.openxmlformats.org/officeDocument/2006/relationships" xmlns:c="http://schemas.openxmlformats.org/drawingml/2006/chart" r:id="R0a905c90619c49c5"/>
+            <c:chart xmlns:r="http://schemas.openxmlformats.org/officeDocument/2006/relationships" xmlns:c="http://schemas.openxmlformats.org/drawingml/2006/chart" r:id="R029fb281b5f34317"/>
           </a:graphicData>
         </a:graphic>
       </p:graphicFrame>
       <p:sp>
         <p:nvSpPr>
-          <p:cNvPr id="5" name="">
+          <p:cNvPr id="4" name="">
             <a:extLst xmlns:a="http://schemas.openxmlformats.org/drawingml/2006/main">
               <a:ext uri="{FF2B5EF4-FFF2-40B4-BE49-F238E27FC236}">
-                <a16:creationId xmlns:a16="http://schemas.microsoft.com/office/drawing/2014/main" id="{249E1987-7883-4A55-B515-9E2256DCE676}"/>
+                <a16:creationId xmlns:a16="http://schemas.microsoft.com/office/drawing/2014/main" id="{447FBF8B-3130-4710-AE8A-A7EFB5A9C6B6}"/>
               </a:ext>
             </a:extLst>
           </p:cNvPr>
@@ -27692,10 +28459,10 @@
       </p:sp>
       <p:sp>
         <p:nvSpPr>
-          <p:cNvPr id="6" name="">
+          <p:cNvPr id="5" name="">
             <a:extLst xmlns:a="http://schemas.openxmlformats.org/drawingml/2006/main">
               <a:ext uri="{FF2B5EF4-FFF2-40B4-BE49-F238E27FC236}">
-                <a16:creationId xmlns:a16="http://schemas.microsoft.com/office/drawing/2014/main" id="{353C76AC-13ED-4FA0-B650-7929B532A976}"/>
+                <a16:creationId xmlns:a16="http://schemas.microsoft.com/office/drawing/2014/main" id="{F0B015A6-21B7-4446-8039-3B36C1566F91}"/>
               </a:ext>
             </a:extLst>
           </p:cNvPr>
@@ -27851,7 +28618,7 @@
     </p:spTree>
     <p:extLst>
       <p:ext uri="{BB962C8B-B14F-4D97-AF65-F5344CB8AC3E}">
-        <p14:creationId xmlns:p14="http://schemas.microsoft.com/office/powerpoint/2010/main" val="1795950604"/>
+        <p14:creationId xmlns:p14="http://schemas.microsoft.com/office/powerpoint/2010/main" val="381150230"/>
       </p:ext>
     </p:extLst>
   </p:cSld>

</xml_diff>

<commit_message>
Correct Vihaan Jinesh Jain registration to 25BYB0130
</commit_message>
<xml_diff>
--- a/output/assessments_visual/Assessment10_Visual.pptx
+++ b/output/assessments_visual/Assessment10_Visual.pptx
@@ -2,22 +2,22 @@
 <file path=ppt/presentation.xml><?xml version="1.0" encoding="utf-8"?>
 <p:presentation xmlns:p="http://schemas.openxmlformats.org/presentationml/2006/main">
   <p:sldMasterIdLst>
-    <p:sldMasterId xmlns:r="http://schemas.openxmlformats.org/officeDocument/2006/relationships" id="2147483648" r:id="R91916bdf56e44655"/>
+    <p:sldMasterId xmlns:r="http://schemas.openxmlformats.org/officeDocument/2006/relationships" id="2147483648" r:id="R7231033e5bf145c2"/>
   </p:sldMasterIdLst>
   <p:notesMasterIdLst>
-    <p:notesMasterId xmlns:r="http://schemas.openxmlformats.org/officeDocument/2006/relationships" r:id="Reedb18908a3d4368"/>
+    <p:notesMasterId xmlns:r="http://schemas.openxmlformats.org/officeDocument/2006/relationships" r:id="Rbe9025acab334b37"/>
   </p:notesMasterIdLst>
   <p:sldIdLst>
-    <p:sldId xmlns:r="http://schemas.openxmlformats.org/officeDocument/2006/relationships" id="256" r:id="Rb29cafc0f8d74b7d"/>
-    <p:sldId xmlns:r="http://schemas.openxmlformats.org/officeDocument/2006/relationships" id="257" r:id="R250be6208d7e484b"/>
-    <p:sldId xmlns:r="http://schemas.openxmlformats.org/officeDocument/2006/relationships" id="258" r:id="R3dbafe2cf234456c"/>
-    <p:sldId xmlns:r="http://schemas.openxmlformats.org/officeDocument/2006/relationships" id="259" r:id="R58085d1c673c444c"/>
-    <p:sldId xmlns:r="http://schemas.openxmlformats.org/officeDocument/2006/relationships" id="260" r:id="R36dca6175a804ae4"/>
-    <p:sldId xmlns:r="http://schemas.openxmlformats.org/officeDocument/2006/relationships" id="261" r:id="Rae1f6134bb064f68"/>
-    <p:sldId xmlns:r="http://schemas.openxmlformats.org/officeDocument/2006/relationships" id="262" r:id="R87725c0d3c6b41c2"/>
-    <p:sldId xmlns:r="http://schemas.openxmlformats.org/officeDocument/2006/relationships" id="263" r:id="R75ebed36136d4f5a"/>
-    <p:sldId xmlns:r="http://schemas.openxmlformats.org/officeDocument/2006/relationships" id="264" r:id="R3f4c65a6ade6445c"/>
-    <p:sldId xmlns:r="http://schemas.openxmlformats.org/officeDocument/2006/relationships" id="265" r:id="R1339b4aa42394129"/>
+    <p:sldId xmlns:r="http://schemas.openxmlformats.org/officeDocument/2006/relationships" id="256" r:id="Rf80af5e6c4ce4f4f"/>
+    <p:sldId xmlns:r="http://schemas.openxmlformats.org/officeDocument/2006/relationships" id="257" r:id="Rd800904d82624875"/>
+    <p:sldId xmlns:r="http://schemas.openxmlformats.org/officeDocument/2006/relationships" id="258" r:id="Rd8708b2805924e18"/>
+    <p:sldId xmlns:r="http://schemas.openxmlformats.org/officeDocument/2006/relationships" id="259" r:id="R5d7d4c4aa6274fc8"/>
+    <p:sldId xmlns:r="http://schemas.openxmlformats.org/officeDocument/2006/relationships" id="260" r:id="Ra98fea940b9e49c3"/>
+    <p:sldId xmlns:r="http://schemas.openxmlformats.org/officeDocument/2006/relationships" id="261" r:id="R2d356c58370c47b1"/>
+    <p:sldId xmlns:r="http://schemas.openxmlformats.org/officeDocument/2006/relationships" id="262" r:id="Rd12a6dde97ef411c"/>
+    <p:sldId xmlns:r="http://schemas.openxmlformats.org/officeDocument/2006/relationships" id="263" r:id="R67a7ed2e7a4649c9"/>
+    <p:sldId xmlns:r="http://schemas.openxmlformats.org/officeDocument/2006/relationships" id="264" r:id="R62c6c41f1f264ab6"/>
+    <p:sldId xmlns:r="http://schemas.openxmlformats.org/officeDocument/2006/relationships" id="265" r:id="R557acd46205d4d9f"/>
   </p:sldIdLst>
   <p:sldSz cx="12192000" cy="6858000"/>
   <p:notesSz cx="6858000" cy="9144000"/>
@@ -1328,7 +1328,7 @@
           <p:cNvPr id="3" name="Title">
             <a:extLst xmlns:a="http://schemas.openxmlformats.org/drawingml/2006/main">
               <a:ext uri="{FF2B5EF4-FFF2-40B4-BE49-F238E27FC236}">
-                <a16:creationId xmlns:a16="http://schemas.microsoft.com/office/drawing/2014/main" id="{1818F2D0-8E74-447F-8AAD-18A52F56301E}"/>
+                <a16:creationId xmlns:a16="http://schemas.microsoft.com/office/drawing/2014/main" id="{EDADCC71-BF95-4D4C-B5FC-70663CF670AF}"/>
               </a:ext>
             </a:extLst>
           </p:cNvPr>
@@ -1557,7 +1557,7 @@
           <p:cNvPr id="2" name="Subtitle">
             <a:extLst xmlns:a="http://schemas.openxmlformats.org/drawingml/2006/main">
               <a:ext uri="{FF2B5EF4-FFF2-40B4-BE49-F238E27FC236}">
-                <a16:creationId xmlns:a16="http://schemas.microsoft.com/office/drawing/2014/main" id="{606FF839-E4C3-40BD-82C9-EC301BAEC9DF}"/>
+                <a16:creationId xmlns:a16="http://schemas.microsoft.com/office/drawing/2014/main" id="{FB4B3211-B4A8-420E-A764-44AE234A2DDB}"/>
               </a:ext>
             </a:extLst>
           </p:cNvPr>
@@ -1803,7 +1803,7 @@
           <p:cNvPr id="2" name="Section title">
             <a:extLst xmlns:a="http://schemas.openxmlformats.org/drawingml/2006/main">
               <a:ext uri="{FF2B5EF4-FFF2-40B4-BE49-F238E27FC236}">
-                <a16:creationId xmlns:a16="http://schemas.microsoft.com/office/drawing/2014/main" id="{7C214CB4-F683-4035-9E4C-AF34203EFF0D}"/>
+                <a16:creationId xmlns:a16="http://schemas.microsoft.com/office/drawing/2014/main" id="{36CF6482-9B7D-48C0-B41C-10EC9C31B20E}"/>
               </a:ext>
             </a:extLst>
           </p:cNvPr>
@@ -2049,7 +2049,7 @@
           <p:cNvPr id="3" name="Title">
             <a:extLst xmlns:a="http://schemas.openxmlformats.org/drawingml/2006/main">
               <a:ext uri="{FF2B5EF4-FFF2-40B4-BE49-F238E27FC236}">
-                <a16:creationId xmlns:a16="http://schemas.microsoft.com/office/drawing/2014/main" id="{1132142C-AD9F-4249-B644-B925CED3C0DD}"/>
+                <a16:creationId xmlns:a16="http://schemas.microsoft.com/office/drawing/2014/main" id="{3CE4420F-0D4D-423A-95DB-7108FAB254BE}"/>
               </a:ext>
             </a:extLst>
           </p:cNvPr>
@@ -2278,7 +2278,7 @@
           <p:cNvPr id="2" name="Body">
             <a:extLst xmlns:a="http://schemas.openxmlformats.org/drawingml/2006/main">
               <a:ext uri="{FF2B5EF4-FFF2-40B4-BE49-F238E27FC236}">
-                <a16:creationId xmlns:a16="http://schemas.microsoft.com/office/drawing/2014/main" id="{5407F797-E151-4A23-BC39-4571BFD64718}"/>
+                <a16:creationId xmlns:a16="http://schemas.microsoft.com/office/drawing/2014/main" id="{DF75247C-C5D0-44F3-9733-DD25B109A185}"/>
               </a:ext>
             </a:extLst>
           </p:cNvPr>
@@ -2524,7 +2524,7 @@
           <p:cNvPr id="4" name="Title">
             <a:extLst xmlns:a="http://schemas.openxmlformats.org/drawingml/2006/main">
               <a:ext uri="{FF2B5EF4-FFF2-40B4-BE49-F238E27FC236}">
-                <a16:creationId xmlns:a16="http://schemas.microsoft.com/office/drawing/2014/main" id="{76FB6328-6F21-49B8-AB8C-A1EC014D6E7A}"/>
+                <a16:creationId xmlns:a16="http://schemas.microsoft.com/office/drawing/2014/main" id="{6779789E-BE51-454D-BC5D-AD74B1034F9A}"/>
               </a:ext>
             </a:extLst>
           </p:cNvPr>
@@ -2753,7 +2753,7 @@
           <p:cNvPr id="2" name="Left column">
             <a:extLst xmlns:a="http://schemas.openxmlformats.org/drawingml/2006/main">
               <a:ext uri="{FF2B5EF4-FFF2-40B4-BE49-F238E27FC236}">
-                <a16:creationId xmlns:a16="http://schemas.microsoft.com/office/drawing/2014/main" id="{BA0A5C04-D6E4-4972-A320-D6824023B595}"/>
+                <a16:creationId xmlns:a16="http://schemas.microsoft.com/office/drawing/2014/main" id="{0D1B5E2E-43FE-453B-A206-2797640DAD57}"/>
               </a:ext>
             </a:extLst>
           </p:cNvPr>
@@ -2982,7 +2982,7 @@
           <p:cNvPr id="3" name="Right column">
             <a:extLst xmlns:a="http://schemas.openxmlformats.org/drawingml/2006/main">
               <a:ext uri="{FF2B5EF4-FFF2-40B4-BE49-F238E27FC236}">
-                <a16:creationId xmlns:a16="http://schemas.microsoft.com/office/drawing/2014/main" id="{238056DF-0448-4D31-91E3-A9830476A803}"/>
+                <a16:creationId xmlns:a16="http://schemas.microsoft.com/office/drawing/2014/main" id="{EF096034-64ED-4F79-81F0-1C845289E023}"/>
               </a:ext>
             </a:extLst>
           </p:cNvPr>
@@ -3228,7 +3228,7 @@
           <p:cNvPr id="3" name="Title">
             <a:extLst xmlns:a="http://schemas.openxmlformats.org/drawingml/2006/main">
               <a:ext uri="{FF2B5EF4-FFF2-40B4-BE49-F238E27FC236}">
-                <a16:creationId xmlns:a16="http://schemas.microsoft.com/office/drawing/2014/main" id="{85C99016-4690-4B4C-8A15-9D7C4814C2A7}"/>
+                <a16:creationId xmlns:a16="http://schemas.microsoft.com/office/drawing/2014/main" id="{5BEED99A-ED67-496F-8803-31DA07F37882}"/>
               </a:ext>
             </a:extLst>
           </p:cNvPr>
@@ -3457,7 +3457,7 @@
           <p:cNvPr id="2" name="Left column">
             <a:extLst xmlns:a="http://schemas.openxmlformats.org/drawingml/2006/main">
               <a:ext uri="{FF2B5EF4-FFF2-40B4-BE49-F238E27FC236}">
-                <a16:creationId xmlns:a16="http://schemas.microsoft.com/office/drawing/2014/main" id="{D0F17496-8841-4CC5-B94D-977587E243E0}"/>
+                <a16:creationId xmlns:a16="http://schemas.microsoft.com/office/drawing/2014/main" id="{580ABE51-840D-48C5-A1B5-5E3518881973}"/>
               </a:ext>
             </a:extLst>
           </p:cNvPr>
@@ -3724,12 +3724,12 @@
   </p:cSld>
   <p:clrMap bg1="lt1" tx1="dk1" bg2="lt2" tx2="dk2" accent1="accent1" accent2="accent2" accent3="accent3" accent4="accent4" accent5="accent5" accent6="accent6" hlink="hlink" folHlink="folHlink"/>
   <p:sldLayoutIdLst>
-    <p:sldLayoutId xmlns:r="http://schemas.openxmlformats.org/officeDocument/2006/relationships" id="2147483649" r:id="Ra5555dba3df74cd2"/>
-    <p:sldLayoutId xmlns:r="http://schemas.openxmlformats.org/officeDocument/2006/relationships" id="2147483650" r:id="R75b2d5ddcf3c4420"/>
-    <p:sldLayoutId xmlns:r="http://schemas.openxmlformats.org/officeDocument/2006/relationships" id="2147483651" r:id="Rda47cdd0607c4f6a"/>
-    <p:sldLayoutId xmlns:r="http://schemas.openxmlformats.org/officeDocument/2006/relationships" id="2147483652" r:id="R6268b40bc693446c"/>
-    <p:sldLayoutId xmlns:r="http://schemas.openxmlformats.org/officeDocument/2006/relationships" id="2147483653" r:id="Rcc8f75c771ef40a6"/>
-    <p:sldLayoutId xmlns:r="http://schemas.openxmlformats.org/officeDocument/2006/relationships" id="2147483654" r:id="R3cbbdd6b8dcc4428"/>
+    <p:sldLayoutId xmlns:r="http://schemas.openxmlformats.org/officeDocument/2006/relationships" id="2147483649" r:id="R5ae76657f5ee411e"/>
+    <p:sldLayoutId xmlns:r="http://schemas.openxmlformats.org/officeDocument/2006/relationships" id="2147483650" r:id="Ra40d5baaa6984673"/>
+    <p:sldLayoutId xmlns:r="http://schemas.openxmlformats.org/officeDocument/2006/relationships" id="2147483651" r:id="Rdd637034123c4bbe"/>
+    <p:sldLayoutId xmlns:r="http://schemas.openxmlformats.org/officeDocument/2006/relationships" id="2147483652" r:id="R2f903530a0e14200"/>
+    <p:sldLayoutId xmlns:r="http://schemas.openxmlformats.org/officeDocument/2006/relationships" id="2147483653" r:id="Rb3dfdb48cd7447db"/>
+    <p:sldLayoutId xmlns:r="http://schemas.openxmlformats.org/officeDocument/2006/relationships" id="2147483654" r:id="R8d26d4ddba664895"/>
   </p:sldLayoutIdLst>
   <p:txStyles>
     <p:titleStyle>
@@ -9171,7 +9171,7 @@
           <p:cNvPr id="18" name="">
             <a:extLst xmlns:a="http://schemas.openxmlformats.org/drawingml/2006/main">
               <a:ext uri="{FF2B5EF4-FFF2-40B4-BE49-F238E27FC236}">
-                <a16:creationId xmlns:a16="http://schemas.microsoft.com/office/drawing/2014/main" id="{AA0BAC71-2177-48AD-AA0D-9BE8FBC5A9E7}"/>
+                <a16:creationId xmlns:a16="http://schemas.microsoft.com/office/drawing/2014/main" id="{BE3C2355-B13F-4317-B7C1-2F72810E7D4D}"/>
               </a:ext>
             </a:extLst>
           </p:cNvPr>
@@ -9329,7 +9329,7 @@
           <p:cNvPr id="2" name="">
             <a:extLst xmlns:a="http://schemas.openxmlformats.org/drawingml/2006/main">
               <a:ext uri="{FF2B5EF4-FFF2-40B4-BE49-F238E27FC236}">
-                <a16:creationId xmlns:a16="http://schemas.microsoft.com/office/drawing/2014/main" id="{2932C0B0-E327-4E71-92F5-4E10316B91A3}"/>
+                <a16:creationId xmlns:a16="http://schemas.microsoft.com/office/drawing/2014/main" id="{A48257E1-07CB-4B4C-9822-D6EE633B2044}"/>
               </a:ext>
             </a:extLst>
           </p:cNvPr>
@@ -9487,7 +9487,7 @@
           <p:cNvPr id="3" name="">
             <a:extLst xmlns:a="http://schemas.openxmlformats.org/drawingml/2006/main">
               <a:ext uri="{FF2B5EF4-FFF2-40B4-BE49-F238E27FC236}">
-                <a16:creationId xmlns:a16="http://schemas.microsoft.com/office/drawing/2014/main" id="{8CFA13BA-8A3C-4999-9D79-20D8B2BC27E7}"/>
+                <a16:creationId xmlns:a16="http://schemas.microsoft.com/office/drawing/2014/main" id="{C2E98CEB-35CB-4112-A46B-36D1766BA7AC}"/>
               </a:ext>
             </a:extLst>
           </p:cNvPr>
@@ -9645,7 +9645,7 @@
           <p:cNvPr id="4" name="">
             <a:extLst xmlns:a="http://schemas.openxmlformats.org/drawingml/2006/main">
               <a:ext uri="{FF2B5EF4-FFF2-40B4-BE49-F238E27FC236}">
-                <a16:creationId xmlns:a16="http://schemas.microsoft.com/office/drawing/2014/main" id="{F3EF8D4C-93C7-4848-A06A-7713385E1F44}"/>
+                <a16:creationId xmlns:a16="http://schemas.microsoft.com/office/drawing/2014/main" id="{DC6515A7-D784-4BB7-8DBB-9A2C971CC9DF}"/>
               </a:ext>
             </a:extLst>
           </p:cNvPr>
@@ -9803,7 +9803,7 @@
           <p:cNvPr id="5" name="">
             <a:extLst xmlns:a="http://schemas.openxmlformats.org/drawingml/2006/main">
               <a:ext uri="{FF2B5EF4-FFF2-40B4-BE49-F238E27FC236}">
-                <a16:creationId xmlns:a16="http://schemas.microsoft.com/office/drawing/2014/main" id="{4E31C771-146D-4DF6-BA60-8FE333D5D830}"/>
+                <a16:creationId xmlns:a16="http://schemas.microsoft.com/office/drawing/2014/main" id="{6E96AD50-4FF1-4469-AAF6-D14D007FEC9B}"/>
               </a:ext>
             </a:extLst>
           </p:cNvPr>
@@ -9965,7 +9965,7 @@
           <p:cNvPr id="6" name="">
             <a:extLst xmlns:a="http://schemas.openxmlformats.org/drawingml/2006/main">
               <a:ext uri="{FF2B5EF4-FFF2-40B4-BE49-F238E27FC236}">
-                <a16:creationId xmlns:a16="http://schemas.microsoft.com/office/drawing/2014/main" id="{2A41746F-3D78-46AB-BDFD-563DC81FD2C2}"/>
+                <a16:creationId xmlns:a16="http://schemas.microsoft.com/office/drawing/2014/main" id="{C1DD7591-76AA-4765-8F7F-15DEB3CBBF36}"/>
               </a:ext>
             </a:extLst>
           </p:cNvPr>
@@ -10123,7 +10123,7 @@
           <p:cNvPr id="7" name="">
             <a:extLst xmlns:a="http://schemas.openxmlformats.org/drawingml/2006/main">
               <a:ext uri="{FF2B5EF4-FFF2-40B4-BE49-F238E27FC236}">
-                <a16:creationId xmlns:a16="http://schemas.microsoft.com/office/drawing/2014/main" id="{94508DED-9250-4127-9E0B-38B51E88AE90}"/>
+                <a16:creationId xmlns:a16="http://schemas.microsoft.com/office/drawing/2014/main" id="{BDDEB099-08B1-4FFA-837B-964BB59B55B1}"/>
               </a:ext>
             </a:extLst>
           </p:cNvPr>
@@ -10285,7 +10285,7 @@
           <p:cNvPr id="8" name="">
             <a:extLst xmlns:a="http://schemas.openxmlformats.org/drawingml/2006/main">
               <a:ext uri="{FF2B5EF4-FFF2-40B4-BE49-F238E27FC236}">
-                <a16:creationId xmlns:a16="http://schemas.microsoft.com/office/drawing/2014/main" id="{552B5A2C-0C3B-4DA1-89E4-01A11D0B1F41}"/>
+                <a16:creationId xmlns:a16="http://schemas.microsoft.com/office/drawing/2014/main" id="{AFD5F6B7-3E7B-413A-95E5-8A25819488C3}"/>
               </a:ext>
             </a:extLst>
           </p:cNvPr>
@@ -10447,7 +10447,7 @@
           <p:cNvPr id="9" name="">
             <a:extLst xmlns:a="http://schemas.openxmlformats.org/drawingml/2006/main">
               <a:ext uri="{FF2B5EF4-FFF2-40B4-BE49-F238E27FC236}">
-                <a16:creationId xmlns:a16="http://schemas.microsoft.com/office/drawing/2014/main" id="{9644361D-A933-4420-B09B-600C897A7413}"/>
+                <a16:creationId xmlns:a16="http://schemas.microsoft.com/office/drawing/2014/main" id="{738A4E6A-3F3D-4521-9739-153A7F4ECBAF}"/>
               </a:ext>
             </a:extLst>
           </p:cNvPr>
@@ -10609,7 +10609,7 @@
           <p:cNvPr id="10" name="">
             <a:extLst xmlns:a="http://schemas.openxmlformats.org/drawingml/2006/main">
               <a:ext uri="{FF2B5EF4-FFF2-40B4-BE49-F238E27FC236}">
-                <a16:creationId xmlns:a16="http://schemas.microsoft.com/office/drawing/2014/main" id="{BE9E15FF-F36F-47E7-A3F9-3EB81DB822EF}"/>
+                <a16:creationId xmlns:a16="http://schemas.microsoft.com/office/drawing/2014/main" id="{37C2284A-8A4F-4762-AC33-F6EE7E5891AA}"/>
               </a:ext>
             </a:extLst>
           </p:cNvPr>
@@ -10771,7 +10771,7 @@
           <p:cNvPr id="11" name="">
             <a:extLst xmlns:a="http://schemas.openxmlformats.org/drawingml/2006/main">
               <a:ext uri="{FF2B5EF4-FFF2-40B4-BE49-F238E27FC236}">
-                <a16:creationId xmlns:a16="http://schemas.microsoft.com/office/drawing/2014/main" id="{9113AECA-EA2E-467E-A1F5-B2D94A922464}"/>
+                <a16:creationId xmlns:a16="http://schemas.microsoft.com/office/drawing/2014/main" id="{5F6467FE-BF0F-4A54-8E52-2448CA4D722C}"/>
               </a:ext>
             </a:extLst>
           </p:cNvPr>
@@ -10929,7 +10929,7 @@
           <p:cNvPr id="12" name="">
             <a:extLst xmlns:a="http://schemas.openxmlformats.org/drawingml/2006/main">
               <a:ext uri="{FF2B5EF4-FFF2-40B4-BE49-F238E27FC236}">
-                <a16:creationId xmlns:a16="http://schemas.microsoft.com/office/drawing/2014/main" id="{0541DAC9-F9B8-4510-8E36-8C06AF2A5582}"/>
+                <a16:creationId xmlns:a16="http://schemas.microsoft.com/office/drawing/2014/main" id="{598745F8-5EE9-4871-9A28-BDB571D396F0}"/>
               </a:ext>
             </a:extLst>
           </p:cNvPr>
@@ -11087,7 +11087,7 @@
           <p:cNvPr id="13" name="">
             <a:extLst xmlns:a="http://schemas.openxmlformats.org/drawingml/2006/main">
               <a:ext uri="{FF2B5EF4-FFF2-40B4-BE49-F238E27FC236}">
-                <a16:creationId xmlns:a16="http://schemas.microsoft.com/office/drawing/2014/main" id="{4A2C14C5-446A-4514-8280-6B677FAA3AA6}"/>
+                <a16:creationId xmlns:a16="http://schemas.microsoft.com/office/drawing/2014/main" id="{72861C56-96FC-401A-B6AF-D47DA1657785}"/>
               </a:ext>
             </a:extLst>
           </p:cNvPr>
@@ -11235,7 +11235,7 @@
                 <a:ea typeface="Arial"/>
                 <a:cs typeface="Arial"/>
               </a:rPr>
-              <a:t>25BYB0103</a:t>
+              <a:t>25BYB0130</a:t>
             </a:r>
           </a:p>
         </p:txBody>
@@ -11245,7 +11245,7 @@
           <p:cNvPr id="14" name="">
             <a:extLst xmlns:a="http://schemas.openxmlformats.org/drawingml/2006/main">
               <a:ext uri="{FF2B5EF4-FFF2-40B4-BE49-F238E27FC236}">
-                <a16:creationId xmlns:a16="http://schemas.microsoft.com/office/drawing/2014/main" id="{40088458-9B29-4ED7-8CA0-E6552CA7FD92}"/>
+                <a16:creationId xmlns:a16="http://schemas.microsoft.com/office/drawing/2014/main" id="{F7660CC7-7D99-4AB0-9FC4-F65CA2E29A22}"/>
               </a:ext>
             </a:extLst>
           </p:cNvPr>
@@ -11403,7 +11403,7 @@
           <p:cNvPr id="15" name="">
             <a:extLst xmlns:a="http://schemas.openxmlformats.org/drawingml/2006/main">
               <a:ext uri="{FF2B5EF4-FFF2-40B4-BE49-F238E27FC236}">
-                <a16:creationId xmlns:a16="http://schemas.microsoft.com/office/drawing/2014/main" id="{FB3D9CF0-FA10-422A-9517-693D81E65E9E}"/>
+                <a16:creationId xmlns:a16="http://schemas.microsoft.com/office/drawing/2014/main" id="{2F20D6DB-0000-4B1E-8868-15F5A9074105}"/>
               </a:ext>
             </a:extLst>
           </p:cNvPr>
@@ -11561,7 +11561,7 @@
           <p:cNvPr id="16" name="">
             <a:extLst xmlns:a="http://schemas.openxmlformats.org/drawingml/2006/main">
               <a:ext uri="{FF2B5EF4-FFF2-40B4-BE49-F238E27FC236}">
-                <a16:creationId xmlns:a16="http://schemas.microsoft.com/office/drawing/2014/main" id="{537E54EF-4578-4FD5-B090-CCDB672DC95B}"/>
+                <a16:creationId xmlns:a16="http://schemas.microsoft.com/office/drawing/2014/main" id="{5695C668-687C-4BE6-9252-9D2779EA66DA}"/>
               </a:ext>
             </a:extLst>
           </p:cNvPr>
@@ -11719,7 +11719,7 @@
           <p:cNvPr id="17" name="">
             <a:extLst xmlns:a="http://schemas.openxmlformats.org/drawingml/2006/main">
               <a:ext uri="{FF2B5EF4-FFF2-40B4-BE49-F238E27FC236}">
-                <a16:creationId xmlns:a16="http://schemas.microsoft.com/office/drawing/2014/main" id="{E0751116-4E98-4E7F-BF1C-D961B061141E}"/>
+                <a16:creationId xmlns:a16="http://schemas.microsoft.com/office/drawing/2014/main" id="{F0B2EDFD-D17F-469E-95FC-557AF414D59E}"/>
               </a:ext>
             </a:extLst>
           </p:cNvPr>
@@ -11875,7 +11875,7 @@
     </p:spTree>
     <p:extLst>
       <p:ext uri="{BB962C8B-B14F-4D97-AF65-F5344CB8AC3E}">
-        <p14:creationId xmlns:p14="http://schemas.microsoft.com/office/powerpoint/2010/main" val="331917222"/>
+        <p14:creationId xmlns:p14="http://schemas.microsoft.com/office/powerpoint/2010/main" val="603227126"/>
       </p:ext>
     </p:extLst>
   </p:cSld>
@@ -11906,7 +11906,7 @@
           <p:cNvPr id="32" name="">
             <a:extLst xmlns:a="http://schemas.openxmlformats.org/drawingml/2006/main">
               <a:ext uri="{FF2B5EF4-FFF2-40B4-BE49-F238E27FC236}">
-                <a16:creationId xmlns:a16="http://schemas.microsoft.com/office/drawing/2014/main" id="{7C033F4A-B8E5-4023-9DB0-B465481B51CA}"/>
+                <a16:creationId xmlns:a16="http://schemas.microsoft.com/office/drawing/2014/main" id="{737EA1F3-3347-4963-AEAC-D5167D2A1FCD}"/>
               </a:ext>
             </a:extLst>
           </p:cNvPr>
@@ -12064,7 +12064,7 @@
           <p:cNvPr id="2" name="">
             <a:extLst xmlns:a="http://schemas.openxmlformats.org/drawingml/2006/main">
               <a:ext uri="{FF2B5EF4-FFF2-40B4-BE49-F238E27FC236}">
-                <a16:creationId xmlns:a16="http://schemas.microsoft.com/office/drawing/2014/main" id="{8CFF7541-CFD1-4BDB-A6C0-E7230C082628}"/>
+                <a16:creationId xmlns:a16="http://schemas.microsoft.com/office/drawing/2014/main" id="{5243EA92-8F7E-4AF2-82EF-7E1C9FCE3D75}"/>
               </a:ext>
             </a:extLst>
           </p:cNvPr>
@@ -12222,7 +12222,7 @@
           <p:cNvPr id="3" name="">
             <a:extLst xmlns:a="http://schemas.openxmlformats.org/drawingml/2006/main">
               <a:ext uri="{FF2B5EF4-FFF2-40B4-BE49-F238E27FC236}">
-                <a16:creationId xmlns:a16="http://schemas.microsoft.com/office/drawing/2014/main" id="{A502F024-3265-44BF-9AE3-34BC64E16F9E}"/>
+                <a16:creationId xmlns:a16="http://schemas.microsoft.com/office/drawing/2014/main" id="{31A5988F-6995-4CA6-95D7-72FC5A490EFD}"/>
               </a:ext>
             </a:extLst>
           </p:cNvPr>
@@ -12380,7 +12380,7 @@
           <p:cNvPr id="4" name="">
             <a:extLst xmlns:a="http://schemas.openxmlformats.org/drawingml/2006/main">
               <a:ext uri="{FF2B5EF4-FFF2-40B4-BE49-F238E27FC236}">
-                <a16:creationId xmlns:a16="http://schemas.microsoft.com/office/drawing/2014/main" id="{F590C8E7-07C4-4AA0-BBD8-6230DBA53B9D}"/>
+                <a16:creationId xmlns:a16="http://schemas.microsoft.com/office/drawing/2014/main" id="{AF26065B-2704-4EE0-8676-F781CEB473C8}"/>
               </a:ext>
             </a:extLst>
           </p:cNvPr>
@@ -12419,7 +12419,7 @@
           <p:cNvPr id="5" name="">
             <a:extLst xmlns:a="http://schemas.openxmlformats.org/drawingml/2006/main">
               <a:ext uri="{FF2B5EF4-FFF2-40B4-BE49-F238E27FC236}">
-                <a16:creationId xmlns:a16="http://schemas.microsoft.com/office/drawing/2014/main" id="{16D728EC-D048-4D2B-83B8-B9C12B02F686}"/>
+                <a16:creationId xmlns:a16="http://schemas.microsoft.com/office/drawing/2014/main" id="{36D6478C-C9A4-499F-B7C0-814316BFA4F6}"/>
               </a:ext>
             </a:extLst>
           </p:cNvPr>
@@ -12577,7 +12577,7 @@
           <p:cNvPr id="6" name="">
             <a:extLst xmlns:a="http://schemas.openxmlformats.org/drawingml/2006/main">
               <a:ext uri="{FF2B5EF4-FFF2-40B4-BE49-F238E27FC236}">
-                <a16:creationId xmlns:a16="http://schemas.microsoft.com/office/drawing/2014/main" id="{4A356A5E-6929-4D0B-AF23-AE6B2300FF5E}"/>
+                <a16:creationId xmlns:a16="http://schemas.microsoft.com/office/drawing/2014/main" id="{C24EC6DF-42CF-4708-9A50-3EF3331C6E0F}"/>
               </a:ext>
             </a:extLst>
           </p:cNvPr>
@@ -12616,7 +12616,7 @@
           <p:cNvPr id="7" name="">
             <a:extLst xmlns:a="http://schemas.openxmlformats.org/drawingml/2006/main">
               <a:ext uri="{FF2B5EF4-FFF2-40B4-BE49-F238E27FC236}">
-                <a16:creationId xmlns:a16="http://schemas.microsoft.com/office/drawing/2014/main" id="{D49833FA-0E76-4EB6-B839-A5FF3E634826}"/>
+                <a16:creationId xmlns:a16="http://schemas.microsoft.com/office/drawing/2014/main" id="{7DD0C05E-9A68-4720-BE8E-180C365F7AE0}"/>
               </a:ext>
             </a:extLst>
           </p:cNvPr>
@@ -12646,7 +12646,7 @@
           <p:cNvPr id="8" name="">
             <a:extLst xmlns:a="http://schemas.openxmlformats.org/drawingml/2006/main">
               <a:ext uri="{FF2B5EF4-FFF2-40B4-BE49-F238E27FC236}">
-                <a16:creationId xmlns:a16="http://schemas.microsoft.com/office/drawing/2014/main" id="{D1CE8668-F32B-446A-A6D6-059DBD80B72F}"/>
+                <a16:creationId xmlns:a16="http://schemas.microsoft.com/office/drawing/2014/main" id="{6192E327-424D-4F06-95F8-4EE4156CA6B5}"/>
               </a:ext>
             </a:extLst>
           </p:cNvPr>
@@ -12804,7 +12804,7 @@
           <p:cNvPr id="9" name="">
             <a:extLst xmlns:a="http://schemas.openxmlformats.org/drawingml/2006/main">
               <a:ext uri="{FF2B5EF4-FFF2-40B4-BE49-F238E27FC236}">
-                <a16:creationId xmlns:a16="http://schemas.microsoft.com/office/drawing/2014/main" id="{B0617BB3-6EE3-41F5-80D1-1184505D34A1}"/>
+                <a16:creationId xmlns:a16="http://schemas.microsoft.com/office/drawing/2014/main" id="{B97B3C42-9260-40DC-8D01-6C5F5197F032}"/>
               </a:ext>
             </a:extLst>
           </p:cNvPr>
@@ -12962,7 +12962,7 @@
           <p:cNvPr id="10" name="">
             <a:extLst xmlns:a="http://schemas.openxmlformats.org/drawingml/2006/main">
               <a:ext uri="{FF2B5EF4-FFF2-40B4-BE49-F238E27FC236}">
-                <a16:creationId xmlns:a16="http://schemas.microsoft.com/office/drawing/2014/main" id="{80E96457-DDDB-45D5-8598-05B05DB21C97}"/>
+                <a16:creationId xmlns:a16="http://schemas.microsoft.com/office/drawing/2014/main" id="{240F9816-97FE-43F6-9F57-02F0E0367ED8}"/>
               </a:ext>
             </a:extLst>
           </p:cNvPr>
@@ -13001,7 +13001,7 @@
           <p:cNvPr id="11" name="">
             <a:extLst xmlns:a="http://schemas.openxmlformats.org/drawingml/2006/main">
               <a:ext uri="{FF2B5EF4-FFF2-40B4-BE49-F238E27FC236}">
-                <a16:creationId xmlns:a16="http://schemas.microsoft.com/office/drawing/2014/main" id="{49E0BC68-F960-4608-80E2-B5441C4D00FF}"/>
+                <a16:creationId xmlns:a16="http://schemas.microsoft.com/office/drawing/2014/main" id="{8561E897-D60E-4C37-A334-70B6B510C9EF}"/>
               </a:ext>
             </a:extLst>
           </p:cNvPr>
@@ -13031,7 +13031,7 @@
           <p:cNvPr id="12" name="">
             <a:extLst xmlns:a="http://schemas.openxmlformats.org/drawingml/2006/main">
               <a:ext uri="{FF2B5EF4-FFF2-40B4-BE49-F238E27FC236}">
-                <a16:creationId xmlns:a16="http://schemas.microsoft.com/office/drawing/2014/main" id="{5BB7AF20-A263-4F1E-B5FB-05B08D859330}"/>
+                <a16:creationId xmlns:a16="http://schemas.microsoft.com/office/drawing/2014/main" id="{56267053-C030-4F53-AC2B-57F3F4F192AB}"/>
               </a:ext>
             </a:extLst>
           </p:cNvPr>
@@ -13189,7 +13189,7 @@
           <p:cNvPr id="13" name="">
             <a:extLst xmlns:a="http://schemas.openxmlformats.org/drawingml/2006/main">
               <a:ext uri="{FF2B5EF4-FFF2-40B4-BE49-F238E27FC236}">
-                <a16:creationId xmlns:a16="http://schemas.microsoft.com/office/drawing/2014/main" id="{7A5730AB-CD49-466F-9878-AA9E1963C59B}"/>
+                <a16:creationId xmlns:a16="http://schemas.microsoft.com/office/drawing/2014/main" id="{093A38E6-7A55-4F5A-8DD6-D3A74188B139}"/>
               </a:ext>
             </a:extLst>
           </p:cNvPr>
@@ -13347,7 +13347,7 @@
           <p:cNvPr id="14" name="">
             <a:extLst xmlns:a="http://schemas.openxmlformats.org/drawingml/2006/main">
               <a:ext uri="{FF2B5EF4-FFF2-40B4-BE49-F238E27FC236}">
-                <a16:creationId xmlns:a16="http://schemas.microsoft.com/office/drawing/2014/main" id="{49FE828B-17A8-4F1F-8D21-C53D57ABCF86}"/>
+                <a16:creationId xmlns:a16="http://schemas.microsoft.com/office/drawing/2014/main" id="{B1767EE9-F8F9-4FF0-A049-97B302A9B82E}"/>
               </a:ext>
             </a:extLst>
           </p:cNvPr>
@@ -13386,7 +13386,7 @@
           <p:cNvPr id="15" name="">
             <a:extLst xmlns:a="http://schemas.openxmlformats.org/drawingml/2006/main">
               <a:ext uri="{FF2B5EF4-FFF2-40B4-BE49-F238E27FC236}">
-                <a16:creationId xmlns:a16="http://schemas.microsoft.com/office/drawing/2014/main" id="{4B249E68-0DD9-4EDD-B6E5-39D2A3B3B39F}"/>
+                <a16:creationId xmlns:a16="http://schemas.microsoft.com/office/drawing/2014/main" id="{F724B7EF-AE3C-43EC-B2B4-77A70D55908F}"/>
               </a:ext>
             </a:extLst>
           </p:cNvPr>
@@ -13416,7 +13416,7 @@
           <p:cNvPr id="16" name="">
             <a:extLst xmlns:a="http://schemas.openxmlformats.org/drawingml/2006/main">
               <a:ext uri="{FF2B5EF4-FFF2-40B4-BE49-F238E27FC236}">
-                <a16:creationId xmlns:a16="http://schemas.microsoft.com/office/drawing/2014/main" id="{DB401D77-F04E-483A-8D0A-0D258B7E4FF3}"/>
+                <a16:creationId xmlns:a16="http://schemas.microsoft.com/office/drawing/2014/main" id="{C110429A-E74B-4A1B-AE48-39125FAC92CC}"/>
               </a:ext>
             </a:extLst>
           </p:cNvPr>
@@ -13574,7 +13574,7 @@
           <p:cNvPr id="17" name="">
             <a:extLst xmlns:a="http://schemas.openxmlformats.org/drawingml/2006/main">
               <a:ext uri="{FF2B5EF4-FFF2-40B4-BE49-F238E27FC236}">
-                <a16:creationId xmlns:a16="http://schemas.microsoft.com/office/drawing/2014/main" id="{821016B6-2978-4B25-A4FC-55C5F91A5707}"/>
+                <a16:creationId xmlns:a16="http://schemas.microsoft.com/office/drawing/2014/main" id="{E79B139E-A598-4DEF-9C67-7FCFD1051BE1}"/>
               </a:ext>
             </a:extLst>
           </p:cNvPr>
@@ -13613,7 +13613,7 @@
           <p:cNvPr id="18" name="">
             <a:extLst xmlns:a="http://schemas.openxmlformats.org/drawingml/2006/main">
               <a:ext uri="{FF2B5EF4-FFF2-40B4-BE49-F238E27FC236}">
-                <a16:creationId xmlns:a16="http://schemas.microsoft.com/office/drawing/2014/main" id="{81FF3A2B-C40F-4E4B-878A-EB546B9612A9}"/>
+                <a16:creationId xmlns:a16="http://schemas.microsoft.com/office/drawing/2014/main" id="{8A68EB70-96AC-4EDA-9DE8-89050EF995FA}"/>
               </a:ext>
             </a:extLst>
           </p:cNvPr>
@@ -13652,7 +13652,7 @@
           <p:cNvPr id="19" name="">
             <a:extLst xmlns:a="http://schemas.openxmlformats.org/drawingml/2006/main">
               <a:ext uri="{FF2B5EF4-FFF2-40B4-BE49-F238E27FC236}">
-                <a16:creationId xmlns:a16="http://schemas.microsoft.com/office/drawing/2014/main" id="{86B83D0E-E1DA-49F4-B939-5F4CA44AABEC}"/>
+                <a16:creationId xmlns:a16="http://schemas.microsoft.com/office/drawing/2014/main" id="{6E69F453-CE0F-456F-BCEC-D84E2C1C8B2F}"/>
               </a:ext>
             </a:extLst>
           </p:cNvPr>
@@ -13810,7 +13810,7 @@
           <p:cNvPr id="20" name="">
             <a:extLst xmlns:a="http://schemas.openxmlformats.org/drawingml/2006/main">
               <a:ext uri="{FF2B5EF4-FFF2-40B4-BE49-F238E27FC236}">
-                <a16:creationId xmlns:a16="http://schemas.microsoft.com/office/drawing/2014/main" id="{4748CBFC-8B06-4334-80C9-CDD247AD65A3}"/>
+                <a16:creationId xmlns:a16="http://schemas.microsoft.com/office/drawing/2014/main" id="{C138A467-EE50-47D2-9A1A-EE5B5FCFC63C}"/>
               </a:ext>
             </a:extLst>
           </p:cNvPr>
@@ -13849,7 +13849,7 @@
           <p:cNvPr id="21" name="">
             <a:extLst xmlns:a="http://schemas.openxmlformats.org/drawingml/2006/main">
               <a:ext uri="{FF2B5EF4-FFF2-40B4-BE49-F238E27FC236}">
-                <a16:creationId xmlns:a16="http://schemas.microsoft.com/office/drawing/2014/main" id="{A8ADC8D9-C212-4B66-BA8E-369F8E623399}"/>
+                <a16:creationId xmlns:a16="http://schemas.microsoft.com/office/drawing/2014/main" id="{3D352AA5-0848-4EC5-9343-542199727D1B}"/>
               </a:ext>
             </a:extLst>
           </p:cNvPr>
@@ -14007,7 +14007,7 @@
           <p:cNvPr id="22" name="">
             <a:extLst xmlns:a="http://schemas.openxmlformats.org/drawingml/2006/main">
               <a:ext uri="{FF2B5EF4-FFF2-40B4-BE49-F238E27FC236}">
-                <a16:creationId xmlns:a16="http://schemas.microsoft.com/office/drawing/2014/main" id="{53EB1089-AC49-4BE1-BAB9-E1AB5E8B10CB}"/>
+                <a16:creationId xmlns:a16="http://schemas.microsoft.com/office/drawing/2014/main" id="{33D11567-7361-46B8-85E4-1B9A3DF8FC80}"/>
               </a:ext>
             </a:extLst>
           </p:cNvPr>
@@ -14046,7 +14046,7 @@
           <p:cNvPr id="23" name="">
             <a:extLst xmlns:a="http://schemas.openxmlformats.org/drawingml/2006/main">
               <a:ext uri="{FF2B5EF4-FFF2-40B4-BE49-F238E27FC236}">
-                <a16:creationId xmlns:a16="http://schemas.microsoft.com/office/drawing/2014/main" id="{9AA88572-1878-4E76-8F5D-8C9FC3142CDF}"/>
+                <a16:creationId xmlns:a16="http://schemas.microsoft.com/office/drawing/2014/main" id="{02621BFE-D368-47F3-81C0-629E6A481867}"/>
               </a:ext>
             </a:extLst>
           </p:cNvPr>
@@ -14204,7 +14204,7 @@
           <p:cNvPr id="24" name="">
             <a:extLst xmlns:a="http://schemas.openxmlformats.org/drawingml/2006/main">
               <a:ext uri="{FF2B5EF4-FFF2-40B4-BE49-F238E27FC236}">
-                <a16:creationId xmlns:a16="http://schemas.microsoft.com/office/drawing/2014/main" id="{7E5CFD73-3057-4ED5-9B16-8144B5DE88EB}"/>
+                <a16:creationId xmlns:a16="http://schemas.microsoft.com/office/drawing/2014/main" id="{A90B3291-643D-4F8B-862A-2B4C5AE27D6B}"/>
               </a:ext>
             </a:extLst>
           </p:cNvPr>
@@ -14243,7 +14243,7 @@
           <p:cNvPr id="25" name="">
             <a:extLst xmlns:a="http://schemas.openxmlformats.org/drawingml/2006/main">
               <a:ext uri="{FF2B5EF4-FFF2-40B4-BE49-F238E27FC236}">
-                <a16:creationId xmlns:a16="http://schemas.microsoft.com/office/drawing/2014/main" id="{9A355765-FE24-4CEF-8106-195F85C43BDB}"/>
+                <a16:creationId xmlns:a16="http://schemas.microsoft.com/office/drawing/2014/main" id="{74BB5D71-A60F-4765-AC7E-EC6D93CE294F}"/>
               </a:ext>
             </a:extLst>
           </p:cNvPr>
@@ -14401,7 +14401,7 @@
           <p:cNvPr id="26" name="">
             <a:extLst xmlns:a="http://schemas.openxmlformats.org/drawingml/2006/main">
               <a:ext uri="{FF2B5EF4-FFF2-40B4-BE49-F238E27FC236}">
-                <a16:creationId xmlns:a16="http://schemas.microsoft.com/office/drawing/2014/main" id="{A8247ECF-BFB5-405D-906F-3C6B5CE317B4}"/>
+                <a16:creationId xmlns:a16="http://schemas.microsoft.com/office/drawing/2014/main" id="{43506D3B-F025-41B7-9DE7-AD133A932A3F}"/>
               </a:ext>
             </a:extLst>
           </p:cNvPr>
@@ -14440,7 +14440,7 @@
           <p:cNvPr id="27" name="">
             <a:extLst xmlns:a="http://schemas.openxmlformats.org/drawingml/2006/main">
               <a:ext uri="{FF2B5EF4-FFF2-40B4-BE49-F238E27FC236}">
-                <a16:creationId xmlns:a16="http://schemas.microsoft.com/office/drawing/2014/main" id="{14AC11DF-0E3C-43AE-9406-E993195C8094}"/>
+                <a16:creationId xmlns:a16="http://schemas.microsoft.com/office/drawing/2014/main" id="{F8538051-F990-4CC2-A33D-0B6A62EAB533}"/>
               </a:ext>
             </a:extLst>
           </p:cNvPr>
@@ -14598,7 +14598,7 @@
           <p:cNvPr id="28" name="">
             <a:extLst xmlns:a="http://schemas.openxmlformats.org/drawingml/2006/main">
               <a:ext uri="{FF2B5EF4-FFF2-40B4-BE49-F238E27FC236}">
-                <a16:creationId xmlns:a16="http://schemas.microsoft.com/office/drawing/2014/main" id="{9F66F91F-449F-4BFA-AC35-BC3B9E4FBE35}"/>
+                <a16:creationId xmlns:a16="http://schemas.microsoft.com/office/drawing/2014/main" id="{6195238B-73EC-437A-B079-7DD20B2526EA}"/>
               </a:ext>
             </a:extLst>
           </p:cNvPr>
@@ -14637,7 +14637,7 @@
           <p:cNvPr id="29" name="">
             <a:extLst xmlns:a="http://schemas.openxmlformats.org/drawingml/2006/main">
               <a:ext uri="{FF2B5EF4-FFF2-40B4-BE49-F238E27FC236}">
-                <a16:creationId xmlns:a16="http://schemas.microsoft.com/office/drawing/2014/main" id="{29292404-200F-4C16-89F6-1361EBA94145}"/>
+                <a16:creationId xmlns:a16="http://schemas.microsoft.com/office/drawing/2014/main" id="{C5BB66BB-22F7-4002-8081-6E003FFEBAB7}"/>
               </a:ext>
             </a:extLst>
           </p:cNvPr>
@@ -14795,7 +14795,7 @@
           <p:cNvPr id="30" name="">
             <a:extLst xmlns:a="http://schemas.openxmlformats.org/drawingml/2006/main">
               <a:ext uri="{FF2B5EF4-FFF2-40B4-BE49-F238E27FC236}">
-                <a16:creationId xmlns:a16="http://schemas.microsoft.com/office/drawing/2014/main" id="{9E35CDA8-E92C-4B92-9333-9EF3D3AF2B46}"/>
+                <a16:creationId xmlns:a16="http://schemas.microsoft.com/office/drawing/2014/main" id="{5F0F193E-197E-4AC4-81BC-7EACEB5DF77F}"/>
               </a:ext>
             </a:extLst>
           </p:cNvPr>
@@ -14953,7 +14953,7 @@
           <p:cNvPr id="31" name="">
             <a:extLst xmlns:a="http://schemas.openxmlformats.org/drawingml/2006/main">
               <a:ext uri="{FF2B5EF4-FFF2-40B4-BE49-F238E27FC236}">
-                <a16:creationId xmlns:a16="http://schemas.microsoft.com/office/drawing/2014/main" id="{09DCAB17-E5B9-497B-99B0-66EA3AF2CC4C}"/>
+                <a16:creationId xmlns:a16="http://schemas.microsoft.com/office/drawing/2014/main" id="{61EAAD21-EDEB-4B68-863A-418355CED9E4}"/>
               </a:ext>
             </a:extLst>
           </p:cNvPr>
@@ -15109,7 +15109,7 @@
     </p:spTree>
     <p:extLst>
       <p:ext uri="{BB962C8B-B14F-4D97-AF65-F5344CB8AC3E}">
-        <p14:creationId xmlns:p14="http://schemas.microsoft.com/office/powerpoint/2010/main" val="495709024"/>
+        <p14:creationId xmlns:p14="http://schemas.microsoft.com/office/powerpoint/2010/main" val="951261989"/>
       </p:ext>
     </p:extLst>
   </p:cSld>
@@ -15140,7 +15140,7 @@
           <p:cNvPr id="8" name="">
             <a:extLst xmlns:a="http://schemas.openxmlformats.org/drawingml/2006/main">
               <a:ext uri="{FF2B5EF4-FFF2-40B4-BE49-F238E27FC236}">
-                <a16:creationId xmlns:a16="http://schemas.microsoft.com/office/drawing/2014/main" id="{807857C7-A2E8-4498-8D5D-719FEA959A0C}"/>
+                <a16:creationId xmlns:a16="http://schemas.microsoft.com/office/drawing/2014/main" id="{7EB6EB47-37C2-4987-A354-C0C0E59CA62B}"/>
               </a:ext>
             </a:extLst>
           </p:cNvPr>
@@ -15171,7 +15171,7 @@
           <p:cNvPr id="10" name="">
             <a:extLst xmlns:a="http://schemas.openxmlformats.org/drawingml/2006/main">
               <a:ext uri="{FF2B5EF4-FFF2-40B4-BE49-F238E27FC236}">
-                <a16:creationId xmlns:a16="http://schemas.microsoft.com/office/drawing/2014/main" id="{DDD8F5C7-088E-49C7-A242-B7FD5AC440B9}"/>
+                <a16:creationId xmlns:a16="http://schemas.microsoft.com/office/drawing/2014/main" id="{91D2352D-09F7-43D9-95C3-CC3931AAB2A3}"/>
               </a:ext>
             </a:extLst>
           </p:cNvPr>
@@ -15329,7 +15329,7 @@
           <p:cNvPr id="2" name="">
             <a:extLst xmlns:a="http://schemas.openxmlformats.org/drawingml/2006/main">
               <a:ext uri="{FF2B5EF4-FFF2-40B4-BE49-F238E27FC236}">
-                <a16:creationId xmlns:a16="http://schemas.microsoft.com/office/drawing/2014/main" id="{7CA9730A-30CC-4FED-8739-0DBCC51ABED2}"/>
+                <a16:creationId xmlns:a16="http://schemas.microsoft.com/office/drawing/2014/main" id="{1DFD6750-C67A-4068-9CF1-058F281A2515}"/>
               </a:ext>
             </a:extLst>
           </p:cNvPr>
@@ -15487,7 +15487,7 @@
           <p:cNvPr id="3" name="Chart">
             <a:extLst xmlns:a="http://schemas.openxmlformats.org/drawingml/2006/main">
               <a:ext uri="{FF2B5EF4-FFF2-40B4-BE49-F238E27FC236}">
-                <a16:creationId xmlns:a16="http://schemas.microsoft.com/office/drawing/2014/main" id="{669A0979-86E7-44E7-9679-5D5E8FF82678}"/>
+                <a16:creationId xmlns:a16="http://schemas.microsoft.com/office/drawing/2014/main" id="{858708BC-17D8-429C-BB05-F9C5E8980E84}"/>
               </a:ext>
             </a:extLst>
           </p:cNvPr>
@@ -15500,7 +15500,7 @@
         </p:xfrm>
         <a:graphic xmlns:a="http://schemas.openxmlformats.org/drawingml/2006/main">
           <a:graphicData uri="http://schemas.openxmlformats.org/drawingml/2006/chart">
-            <c:chart xmlns:r="http://schemas.openxmlformats.org/officeDocument/2006/relationships" xmlns:c="http://schemas.openxmlformats.org/drawingml/2006/chart" r:id="Rea9f27433e6b4801"/>
+            <c:chart xmlns:r="http://schemas.openxmlformats.org/officeDocument/2006/relationships" xmlns:c="http://schemas.openxmlformats.org/drawingml/2006/chart" r:id="R10ee0229b96e43d4"/>
           </a:graphicData>
         </a:graphic>
       </p:graphicFrame>
@@ -15509,7 +15509,7 @@
           <p:cNvPr id="4" name="">
             <a:extLst xmlns:a="http://schemas.openxmlformats.org/drawingml/2006/main">
               <a:ext uri="{FF2B5EF4-FFF2-40B4-BE49-F238E27FC236}">
-                <a16:creationId xmlns:a16="http://schemas.microsoft.com/office/drawing/2014/main" id="{C3039C24-C480-40AE-8665-D03B7CB5E7A8}"/>
+                <a16:creationId xmlns:a16="http://schemas.microsoft.com/office/drawing/2014/main" id="{1F21F612-4271-4E2F-8C2F-9C13436CDA32}"/>
               </a:ext>
             </a:extLst>
           </p:cNvPr>
@@ -15667,7 +15667,7 @@
           <p:cNvPr id="5" name="">
             <a:extLst xmlns:a="http://schemas.openxmlformats.org/drawingml/2006/main">
               <a:ext uri="{FF2B5EF4-FFF2-40B4-BE49-F238E27FC236}">
-                <a16:creationId xmlns:a16="http://schemas.microsoft.com/office/drawing/2014/main" id="{07C2704B-49EE-4F2B-9F63-D3FAAAC185EB}"/>
+                <a16:creationId xmlns:a16="http://schemas.microsoft.com/office/drawing/2014/main" id="{673EA434-4844-4539-996A-947E09B6D4C7}"/>
               </a:ext>
             </a:extLst>
           </p:cNvPr>
@@ -15825,7 +15825,7 @@
           <p:cNvPr id="6" name="">
             <a:extLst xmlns:a="http://schemas.openxmlformats.org/drawingml/2006/main">
               <a:ext uri="{FF2B5EF4-FFF2-40B4-BE49-F238E27FC236}">
-                <a16:creationId xmlns:a16="http://schemas.microsoft.com/office/drawing/2014/main" id="{290644D9-BDD8-46DA-9A43-13AB252E2267}"/>
+                <a16:creationId xmlns:a16="http://schemas.microsoft.com/office/drawing/2014/main" id="{C2534143-5F52-4B82-BD85-E6F7B4D4C9F1}"/>
               </a:ext>
             </a:extLst>
           </p:cNvPr>
@@ -15987,7 +15987,7 @@
           <p:cNvPr id="7" name="">
             <a:extLst xmlns:a="http://schemas.openxmlformats.org/drawingml/2006/main">
               <a:ext uri="{FF2B5EF4-FFF2-40B4-BE49-F238E27FC236}">
-                <a16:creationId xmlns:a16="http://schemas.microsoft.com/office/drawing/2014/main" id="{D497699F-09ED-4EF0-BCE6-DF47F6AA1077}"/>
+                <a16:creationId xmlns:a16="http://schemas.microsoft.com/office/drawing/2014/main" id="{A057D80F-CC6D-4AF3-AC20-15FF7C2CD208}"/>
               </a:ext>
             </a:extLst>
           </p:cNvPr>
@@ -16149,7 +16149,7 @@
           <p:cNvPr id="9" name="">
             <a:extLst xmlns:a="http://schemas.openxmlformats.org/drawingml/2006/main">
               <a:ext uri="{FF2B5EF4-FFF2-40B4-BE49-F238E27FC236}">
-                <a16:creationId xmlns:a16="http://schemas.microsoft.com/office/drawing/2014/main" id="{3CE44DD7-EE78-479C-A2C0-BE96D5DBFEDF}"/>
+                <a16:creationId xmlns:a16="http://schemas.microsoft.com/office/drawing/2014/main" id="{6972F430-C6A6-46C0-A0A3-ED8591B42949}"/>
               </a:ext>
             </a:extLst>
           </p:cNvPr>
@@ -16305,7 +16305,7 @@
     </p:spTree>
     <p:extLst>
       <p:ext uri="{BB962C8B-B14F-4D97-AF65-F5344CB8AC3E}">
-        <p14:creationId xmlns:p14="http://schemas.microsoft.com/office/powerpoint/2010/main" val="1996760935"/>
+        <p14:creationId xmlns:p14="http://schemas.microsoft.com/office/powerpoint/2010/main" val="504667200"/>
       </p:ext>
     </p:extLst>
   </p:cSld>
@@ -16336,7 +16336,7 @@
           <p:cNvPr id="15" name="">
             <a:extLst xmlns:a="http://schemas.openxmlformats.org/drawingml/2006/main">
               <a:ext uri="{FF2B5EF4-FFF2-40B4-BE49-F238E27FC236}">
-                <a16:creationId xmlns:a16="http://schemas.microsoft.com/office/drawing/2014/main" id="{7649225A-BE52-4474-ACFB-642A503A78D6}"/>
+                <a16:creationId xmlns:a16="http://schemas.microsoft.com/office/drawing/2014/main" id="{D71F9736-73E6-4DE0-BC1F-D1B20020D2E8}"/>
               </a:ext>
             </a:extLst>
           </p:cNvPr>
@@ -16494,7 +16494,7 @@
           <p:cNvPr id="2" name="">
             <a:extLst xmlns:a="http://schemas.openxmlformats.org/drawingml/2006/main">
               <a:ext uri="{FF2B5EF4-FFF2-40B4-BE49-F238E27FC236}">
-                <a16:creationId xmlns:a16="http://schemas.microsoft.com/office/drawing/2014/main" id="{A64D0607-4560-4756-8CBE-1F6970FF8FEF}"/>
+                <a16:creationId xmlns:a16="http://schemas.microsoft.com/office/drawing/2014/main" id="{29998539-A4C2-4620-931E-DEC2220ED0A1}"/>
               </a:ext>
             </a:extLst>
           </p:cNvPr>
@@ -16652,7 +16652,7 @@
           <p:cNvPr id="3" name="">
             <a:extLst xmlns:a="http://schemas.openxmlformats.org/drawingml/2006/main">
               <a:ext uri="{FF2B5EF4-FFF2-40B4-BE49-F238E27FC236}">
-                <a16:creationId xmlns:a16="http://schemas.microsoft.com/office/drawing/2014/main" id="{CABFA352-6270-4CB8-83FE-09F5A2CDA85A}"/>
+                <a16:creationId xmlns:a16="http://schemas.microsoft.com/office/drawing/2014/main" id="{FC508F67-B81D-43CF-BDD0-C7AC9A50FE84}"/>
               </a:ext>
             </a:extLst>
           </p:cNvPr>
@@ -16810,7 +16810,7 @@
           <p:cNvPr id="4" name="">
             <a:extLst xmlns:a="http://schemas.openxmlformats.org/drawingml/2006/main">
               <a:ext uri="{FF2B5EF4-FFF2-40B4-BE49-F238E27FC236}">
-                <a16:creationId xmlns:a16="http://schemas.microsoft.com/office/drawing/2014/main" id="{E461B17B-5DFE-4E48-BCA9-957CBFAE6B47}"/>
+                <a16:creationId xmlns:a16="http://schemas.microsoft.com/office/drawing/2014/main" id="{7166736E-DDB8-4005-B6D8-B48456ED4607}"/>
               </a:ext>
             </a:extLst>
           </p:cNvPr>
@@ -16972,7 +16972,7 @@
           <p:cNvPr id="5" name="">
             <a:extLst xmlns:a="http://schemas.openxmlformats.org/drawingml/2006/main">
               <a:ext uri="{FF2B5EF4-FFF2-40B4-BE49-F238E27FC236}">
-                <a16:creationId xmlns:a16="http://schemas.microsoft.com/office/drawing/2014/main" id="{DB5C6EEC-2A9D-4627-BB5D-D80600040D95}"/>
+                <a16:creationId xmlns:a16="http://schemas.microsoft.com/office/drawing/2014/main" id="{C8EE7F3F-7855-4EB4-B7E0-E34187ACC91F}"/>
               </a:ext>
             </a:extLst>
           </p:cNvPr>
@@ -17134,7 +17134,7 @@
           <p:cNvPr id="6" name="">
             <a:extLst xmlns:a="http://schemas.openxmlformats.org/drawingml/2006/main">
               <a:ext uri="{FF2B5EF4-FFF2-40B4-BE49-F238E27FC236}">
-                <a16:creationId xmlns:a16="http://schemas.microsoft.com/office/drawing/2014/main" id="{0F806911-4411-428D-8F63-2D9501873BD9}"/>
+                <a16:creationId xmlns:a16="http://schemas.microsoft.com/office/drawing/2014/main" id="{08C49983-8BAF-4DCD-9BF0-1B2902477C7A}"/>
               </a:ext>
             </a:extLst>
           </p:cNvPr>
@@ -17292,7 +17292,7 @@
           <p:cNvPr id="7" name="">
             <a:extLst xmlns:a="http://schemas.openxmlformats.org/drawingml/2006/main">
               <a:ext uri="{FF2B5EF4-FFF2-40B4-BE49-F238E27FC236}">
-                <a16:creationId xmlns:a16="http://schemas.microsoft.com/office/drawing/2014/main" id="{08CDD6A2-73C9-4146-A1EE-A1D144551446}"/>
+                <a16:creationId xmlns:a16="http://schemas.microsoft.com/office/drawing/2014/main" id="{9011DB01-38B4-41BC-B1AC-1D77B1620CD9}"/>
               </a:ext>
             </a:extLst>
           </p:cNvPr>
@@ -17450,7 +17450,7 @@
           <p:cNvPr id="8" name="">
             <a:extLst xmlns:a="http://schemas.openxmlformats.org/drawingml/2006/main">
               <a:ext uri="{FF2B5EF4-FFF2-40B4-BE49-F238E27FC236}">
-                <a16:creationId xmlns:a16="http://schemas.microsoft.com/office/drawing/2014/main" id="{F5E1081E-18AF-4120-A1B0-914A94EBD2E9}"/>
+                <a16:creationId xmlns:a16="http://schemas.microsoft.com/office/drawing/2014/main" id="{76F69B65-4B90-4ADC-93FE-1A9EEACD6B8F}"/>
               </a:ext>
             </a:extLst>
           </p:cNvPr>
@@ -17608,7 +17608,7 @@
           <p:cNvPr id="9" name="">
             <a:extLst xmlns:a="http://schemas.openxmlformats.org/drawingml/2006/main">
               <a:ext uri="{FF2B5EF4-FFF2-40B4-BE49-F238E27FC236}">
-                <a16:creationId xmlns:a16="http://schemas.microsoft.com/office/drawing/2014/main" id="{742F6CFA-9399-45D0-B435-343D1B86DD9A}"/>
+                <a16:creationId xmlns:a16="http://schemas.microsoft.com/office/drawing/2014/main" id="{B8488F44-6716-4D08-9BFA-4455D5D89A76}"/>
               </a:ext>
             </a:extLst>
           </p:cNvPr>
@@ -17766,7 +17766,7 @@
           <p:cNvPr id="10" name="">
             <a:extLst xmlns:a="http://schemas.openxmlformats.org/drawingml/2006/main">
               <a:ext uri="{FF2B5EF4-FFF2-40B4-BE49-F238E27FC236}">
-                <a16:creationId xmlns:a16="http://schemas.microsoft.com/office/drawing/2014/main" id="{437B6777-2C9D-44AD-B3E4-91AD64889B50}"/>
+                <a16:creationId xmlns:a16="http://schemas.microsoft.com/office/drawing/2014/main" id="{6FAAC246-2035-42B2-9483-89FA4BAAEC25}"/>
               </a:ext>
             </a:extLst>
           </p:cNvPr>
@@ -17924,7 +17924,7 @@
           <p:cNvPr id="11" name="">
             <a:extLst xmlns:a="http://schemas.openxmlformats.org/drawingml/2006/main">
               <a:ext uri="{FF2B5EF4-FFF2-40B4-BE49-F238E27FC236}">
-                <a16:creationId xmlns:a16="http://schemas.microsoft.com/office/drawing/2014/main" id="{DC81F2F4-539B-4F31-85DE-7045FDD74102}"/>
+                <a16:creationId xmlns:a16="http://schemas.microsoft.com/office/drawing/2014/main" id="{FDF822CF-5A8B-4640-9071-5F5F387D0937}"/>
               </a:ext>
             </a:extLst>
           </p:cNvPr>
@@ -18082,7 +18082,7 @@
           <p:cNvPr id="12" name="">
             <a:extLst xmlns:a="http://schemas.openxmlformats.org/drawingml/2006/main">
               <a:ext uri="{FF2B5EF4-FFF2-40B4-BE49-F238E27FC236}">
-                <a16:creationId xmlns:a16="http://schemas.microsoft.com/office/drawing/2014/main" id="{508E0609-BB5C-4E68-A997-F00CFF8B00AD}"/>
+                <a16:creationId xmlns:a16="http://schemas.microsoft.com/office/drawing/2014/main" id="{308D6C32-62EB-4E51-9DDB-99C7707386C4}"/>
               </a:ext>
             </a:extLst>
           </p:cNvPr>
@@ -18240,7 +18240,7 @@
           <p:cNvPr id="13" name="">
             <a:extLst xmlns:a="http://schemas.openxmlformats.org/drawingml/2006/main">
               <a:ext uri="{FF2B5EF4-FFF2-40B4-BE49-F238E27FC236}">
-                <a16:creationId xmlns:a16="http://schemas.microsoft.com/office/drawing/2014/main" id="{97EAFF10-3F09-44F3-924B-BCC6A889E024}"/>
+                <a16:creationId xmlns:a16="http://schemas.microsoft.com/office/drawing/2014/main" id="{E427510F-3AC8-4B94-8820-DDA52370A9DC}"/>
               </a:ext>
             </a:extLst>
           </p:cNvPr>
@@ -18398,7 +18398,7 @@
           <p:cNvPr id="14" name="">
             <a:extLst xmlns:a="http://schemas.openxmlformats.org/drawingml/2006/main">
               <a:ext uri="{FF2B5EF4-FFF2-40B4-BE49-F238E27FC236}">
-                <a16:creationId xmlns:a16="http://schemas.microsoft.com/office/drawing/2014/main" id="{1E0864D3-7B60-4D5D-AE1B-DB3033DD493E}"/>
+                <a16:creationId xmlns:a16="http://schemas.microsoft.com/office/drawing/2014/main" id="{607F10ED-B8EA-4E6F-ADC0-12B785AB86F3}"/>
               </a:ext>
             </a:extLst>
           </p:cNvPr>
@@ -18554,7 +18554,7 @@
     </p:spTree>
     <p:extLst>
       <p:ext uri="{BB962C8B-B14F-4D97-AF65-F5344CB8AC3E}">
-        <p14:creationId xmlns:p14="http://schemas.microsoft.com/office/powerpoint/2010/main" val="1015770288"/>
+        <p14:creationId xmlns:p14="http://schemas.microsoft.com/office/powerpoint/2010/main" val="1762531753"/>
       </p:ext>
     </p:extLst>
   </p:cSld>
@@ -18585,7 +18585,7 @@
           <p:cNvPr id="13" name="">
             <a:extLst xmlns:a="http://schemas.openxmlformats.org/drawingml/2006/main">
               <a:ext uri="{FF2B5EF4-FFF2-40B4-BE49-F238E27FC236}">
-                <a16:creationId xmlns:a16="http://schemas.microsoft.com/office/drawing/2014/main" id="{DFCA2EBB-13C8-4008-9BCF-59FB213E3ACD}"/>
+                <a16:creationId xmlns:a16="http://schemas.microsoft.com/office/drawing/2014/main" id="{0BD87924-202B-4378-8582-B7D58BEC800B}"/>
               </a:ext>
             </a:extLst>
           </p:cNvPr>
@@ -18617,7 +18617,7 @@
           <p:cNvPr id="11" name="">
             <a:extLst xmlns:a="http://schemas.openxmlformats.org/drawingml/2006/main">
               <a:ext uri="{FF2B5EF4-FFF2-40B4-BE49-F238E27FC236}">
-                <a16:creationId xmlns:a16="http://schemas.microsoft.com/office/drawing/2014/main" id="{5813C40A-9C10-4940-BA6B-326294567A3E}"/>
+                <a16:creationId xmlns:a16="http://schemas.microsoft.com/office/drawing/2014/main" id="{CA28F477-15D3-42F6-9464-F9D712CF1B62}"/>
               </a:ext>
             </a:extLst>
           </p:cNvPr>
@@ -18648,7 +18648,7 @@
           <p:cNvPr id="9" name="">
             <a:extLst xmlns:a="http://schemas.openxmlformats.org/drawingml/2006/main">
               <a:ext uri="{FF2B5EF4-FFF2-40B4-BE49-F238E27FC236}">
-                <a16:creationId xmlns:a16="http://schemas.microsoft.com/office/drawing/2014/main" id="{9004FF15-AB96-49C2-AA82-D67369EB0206}"/>
+                <a16:creationId xmlns:a16="http://schemas.microsoft.com/office/drawing/2014/main" id="{756051F3-B439-447D-8696-22F48C821F05}"/>
               </a:ext>
             </a:extLst>
           </p:cNvPr>
@@ -18679,7 +18679,7 @@
           <p:cNvPr id="7" name="">
             <a:extLst xmlns:a="http://schemas.openxmlformats.org/drawingml/2006/main">
               <a:ext uri="{FF2B5EF4-FFF2-40B4-BE49-F238E27FC236}">
-                <a16:creationId xmlns:a16="http://schemas.microsoft.com/office/drawing/2014/main" id="{EF7647A2-CD4C-4B7B-9471-E0A6A0336F40}"/>
+                <a16:creationId xmlns:a16="http://schemas.microsoft.com/office/drawing/2014/main" id="{C9B8A7F7-1DF7-4C34-9CA1-33D85F5414C9}"/>
               </a:ext>
             </a:extLst>
           </p:cNvPr>
@@ -18710,7 +18710,7 @@
           <p:cNvPr id="5" name="">
             <a:extLst xmlns:a="http://schemas.openxmlformats.org/drawingml/2006/main">
               <a:ext uri="{FF2B5EF4-FFF2-40B4-BE49-F238E27FC236}">
-                <a16:creationId xmlns:a16="http://schemas.microsoft.com/office/drawing/2014/main" id="{3ABCB51F-8EE3-4078-8BB4-7C980B5CD29B}"/>
+                <a16:creationId xmlns:a16="http://schemas.microsoft.com/office/drawing/2014/main" id="{C7A86A5C-5539-475B-8B7E-91CE72D655FA}"/>
               </a:ext>
             </a:extLst>
           </p:cNvPr>
@@ -18741,7 +18741,7 @@
           <p:cNvPr id="17" name="">
             <a:extLst xmlns:a="http://schemas.openxmlformats.org/drawingml/2006/main">
               <a:ext uri="{FF2B5EF4-FFF2-40B4-BE49-F238E27FC236}">
-                <a16:creationId xmlns:a16="http://schemas.microsoft.com/office/drawing/2014/main" id="{36974817-8570-4972-88AD-652D5CE42228}"/>
+                <a16:creationId xmlns:a16="http://schemas.microsoft.com/office/drawing/2014/main" id="{605A77AC-086C-4E76-B6DA-E6DCAFC7CAD1}"/>
               </a:ext>
             </a:extLst>
           </p:cNvPr>
@@ -18899,7 +18899,7 @@
           <p:cNvPr id="2" name="">
             <a:extLst xmlns:a="http://schemas.openxmlformats.org/drawingml/2006/main">
               <a:ext uri="{FF2B5EF4-FFF2-40B4-BE49-F238E27FC236}">
-                <a16:creationId xmlns:a16="http://schemas.microsoft.com/office/drawing/2014/main" id="{EF76C50D-6B0B-4F06-B70D-36139CB08A7A}"/>
+                <a16:creationId xmlns:a16="http://schemas.microsoft.com/office/drawing/2014/main" id="{48B5B075-A978-4DA1-90C1-205FF8FBA180}"/>
               </a:ext>
             </a:extLst>
           </p:cNvPr>
@@ -19057,7 +19057,7 @@
           <p:cNvPr id="3" name="">
             <a:extLst xmlns:a="http://schemas.openxmlformats.org/drawingml/2006/main">
               <a:ext uri="{FF2B5EF4-FFF2-40B4-BE49-F238E27FC236}">
-                <a16:creationId xmlns:a16="http://schemas.microsoft.com/office/drawing/2014/main" id="{1D728C0B-10CF-4A7A-92A2-08982266F6D8}"/>
+                <a16:creationId xmlns:a16="http://schemas.microsoft.com/office/drawing/2014/main" id="{35686B2E-42C0-430A-9284-1E38E0740CC0}"/>
               </a:ext>
             </a:extLst>
           </p:cNvPr>
@@ -19242,7 +19242,7 @@
           <p:cNvPr id="4" name="">
             <a:extLst xmlns:a="http://schemas.openxmlformats.org/drawingml/2006/main">
               <a:ext uri="{FF2B5EF4-FFF2-40B4-BE49-F238E27FC236}">
-                <a16:creationId xmlns:a16="http://schemas.microsoft.com/office/drawing/2014/main" id="{65C7F7BE-2D94-4283-ACA1-B204F5C88520}"/>
+                <a16:creationId xmlns:a16="http://schemas.microsoft.com/office/drawing/2014/main" id="{4ED177C9-ABD9-4C51-BDD4-28E2906843AC}"/>
               </a:ext>
             </a:extLst>
           </p:cNvPr>
@@ -19427,7 +19427,7 @@
           <p:cNvPr id="6" name="">
             <a:extLst xmlns:a="http://schemas.openxmlformats.org/drawingml/2006/main">
               <a:ext uri="{FF2B5EF4-FFF2-40B4-BE49-F238E27FC236}">
-                <a16:creationId xmlns:a16="http://schemas.microsoft.com/office/drawing/2014/main" id="{DE5CE178-89E9-459B-8922-318A7C69D1B9}"/>
+                <a16:creationId xmlns:a16="http://schemas.microsoft.com/office/drawing/2014/main" id="{39D01CA0-7DEF-489F-BDC6-CC9FBCF39A42}"/>
               </a:ext>
             </a:extLst>
           </p:cNvPr>
@@ -19612,7 +19612,7 @@
           <p:cNvPr id="8" name="">
             <a:extLst xmlns:a="http://schemas.openxmlformats.org/drawingml/2006/main">
               <a:ext uri="{FF2B5EF4-FFF2-40B4-BE49-F238E27FC236}">
-                <a16:creationId xmlns:a16="http://schemas.microsoft.com/office/drawing/2014/main" id="{912B6A4E-130E-470B-95E2-C2A2ABE1F3BD}"/>
+                <a16:creationId xmlns:a16="http://schemas.microsoft.com/office/drawing/2014/main" id="{4C1CF181-0046-466D-A1FB-6E8008AD3EF7}"/>
               </a:ext>
             </a:extLst>
           </p:cNvPr>
@@ -19797,7 +19797,7 @@
           <p:cNvPr id="10" name="">
             <a:extLst xmlns:a="http://schemas.openxmlformats.org/drawingml/2006/main">
               <a:ext uri="{FF2B5EF4-FFF2-40B4-BE49-F238E27FC236}">
-                <a16:creationId xmlns:a16="http://schemas.microsoft.com/office/drawing/2014/main" id="{A97026E1-91AB-479C-8507-6ADE963B2634}"/>
+                <a16:creationId xmlns:a16="http://schemas.microsoft.com/office/drawing/2014/main" id="{6C1424B3-5625-4521-9154-46F96D1D94BC}"/>
               </a:ext>
             </a:extLst>
           </p:cNvPr>
@@ -19982,7 +19982,7 @@
           <p:cNvPr id="12" name="">
             <a:extLst xmlns:a="http://schemas.openxmlformats.org/drawingml/2006/main">
               <a:ext uri="{FF2B5EF4-FFF2-40B4-BE49-F238E27FC236}">
-                <a16:creationId xmlns:a16="http://schemas.microsoft.com/office/drawing/2014/main" id="{05BA7E0F-C400-4157-8E05-65F7C7F3B9EC}"/>
+                <a16:creationId xmlns:a16="http://schemas.microsoft.com/office/drawing/2014/main" id="{260F9210-E9A8-43A7-AB9F-FEFE18ECE44A}"/>
               </a:ext>
             </a:extLst>
           </p:cNvPr>
@@ -20167,7 +20167,7 @@
           <p:cNvPr id="14" name="">
             <a:extLst xmlns:a="http://schemas.openxmlformats.org/drawingml/2006/main">
               <a:ext uri="{FF2B5EF4-FFF2-40B4-BE49-F238E27FC236}">
-                <a16:creationId xmlns:a16="http://schemas.microsoft.com/office/drawing/2014/main" id="{0EDBEC12-1A72-4EEE-B3B7-6A125ABC3930}"/>
+                <a16:creationId xmlns:a16="http://schemas.microsoft.com/office/drawing/2014/main" id="{1AC786FF-AB7B-4A1E-8ADA-A02CD52EB02B}"/>
               </a:ext>
             </a:extLst>
           </p:cNvPr>
@@ -20325,7 +20325,7 @@
           <p:cNvPr id="15" name="">
             <a:extLst xmlns:a="http://schemas.openxmlformats.org/drawingml/2006/main">
               <a:ext uri="{FF2B5EF4-FFF2-40B4-BE49-F238E27FC236}">
-                <a16:creationId xmlns:a16="http://schemas.microsoft.com/office/drawing/2014/main" id="{B5D2FAF6-9BA7-4370-9B22-F589EDFEC57E}"/>
+                <a16:creationId xmlns:a16="http://schemas.microsoft.com/office/drawing/2014/main" id="{E3A06BC0-58E1-4654-9E7A-19853D978D16}"/>
               </a:ext>
             </a:extLst>
           </p:cNvPr>
@@ -20483,7 +20483,7 @@
           <p:cNvPr id="16" name="">
             <a:extLst xmlns:a="http://schemas.openxmlformats.org/drawingml/2006/main">
               <a:ext uri="{FF2B5EF4-FFF2-40B4-BE49-F238E27FC236}">
-                <a16:creationId xmlns:a16="http://schemas.microsoft.com/office/drawing/2014/main" id="{F4299190-923A-4A25-AC83-CACE227E413E}"/>
+                <a16:creationId xmlns:a16="http://schemas.microsoft.com/office/drawing/2014/main" id="{729CC56B-ED79-4063-B32C-6183767A9606}"/>
               </a:ext>
             </a:extLst>
           </p:cNvPr>
@@ -20639,7 +20639,7 @@
     </p:spTree>
     <p:extLst>
       <p:ext uri="{BB962C8B-B14F-4D97-AF65-F5344CB8AC3E}">
-        <p14:creationId xmlns:p14="http://schemas.microsoft.com/office/powerpoint/2010/main" val="204029071"/>
+        <p14:creationId xmlns:p14="http://schemas.microsoft.com/office/powerpoint/2010/main" val="1996563455"/>
       </p:ext>
     </p:extLst>
   </p:cSld>
@@ -20670,7 +20670,7 @@
           <p:cNvPr id="60" name="">
             <a:extLst xmlns:a="http://schemas.openxmlformats.org/drawingml/2006/main">
               <a:ext uri="{FF2B5EF4-FFF2-40B4-BE49-F238E27FC236}">
-                <a16:creationId xmlns:a16="http://schemas.microsoft.com/office/drawing/2014/main" id="{D38CB7ED-9999-478D-AFD3-E6A04EA89810}"/>
+                <a16:creationId xmlns:a16="http://schemas.microsoft.com/office/drawing/2014/main" id="{8EE48E48-E007-4A4A-A72E-A033A5881DEE}"/>
               </a:ext>
             </a:extLst>
           </p:cNvPr>
@@ -20828,7 +20828,7 @@
           <p:cNvPr id="2" name="">
             <a:extLst xmlns:a="http://schemas.openxmlformats.org/drawingml/2006/main">
               <a:ext uri="{FF2B5EF4-FFF2-40B4-BE49-F238E27FC236}">
-                <a16:creationId xmlns:a16="http://schemas.microsoft.com/office/drawing/2014/main" id="{F268C77E-14C9-45B9-A4F0-E46B43CBEB7B}"/>
+                <a16:creationId xmlns:a16="http://schemas.microsoft.com/office/drawing/2014/main" id="{CB49D861-7692-4BA9-83AA-F9E891A5A7F5}"/>
               </a:ext>
             </a:extLst>
           </p:cNvPr>
@@ -20986,7 +20986,7 @@
           <p:cNvPr id="3" name="">
             <a:extLst xmlns:a="http://schemas.openxmlformats.org/drawingml/2006/main">
               <a:ext uri="{FF2B5EF4-FFF2-40B4-BE49-F238E27FC236}">
-                <a16:creationId xmlns:a16="http://schemas.microsoft.com/office/drawing/2014/main" id="{CE97B32B-9E71-451E-B4FE-A6ACE9133A7B}"/>
+                <a16:creationId xmlns:a16="http://schemas.microsoft.com/office/drawing/2014/main" id="{4D8A5765-CD01-4E46-889E-E5B50EE180DE}"/>
               </a:ext>
             </a:extLst>
           </p:cNvPr>
@@ -21144,7 +21144,7 @@
           <p:cNvPr id="4" name="">
             <a:extLst xmlns:a="http://schemas.openxmlformats.org/drawingml/2006/main">
               <a:ext uri="{FF2B5EF4-FFF2-40B4-BE49-F238E27FC236}">
-                <a16:creationId xmlns:a16="http://schemas.microsoft.com/office/drawing/2014/main" id="{336A76C1-0887-4FD4-97C5-CF51F2EBE4CE}"/>
+                <a16:creationId xmlns:a16="http://schemas.microsoft.com/office/drawing/2014/main" id="{BEFF4395-DF58-430F-B96D-5C7F18255846}"/>
               </a:ext>
             </a:extLst>
           </p:cNvPr>
@@ -21302,7 +21302,7 @@
           <p:cNvPr id="5" name="">
             <a:extLst xmlns:a="http://schemas.openxmlformats.org/drawingml/2006/main">
               <a:ext uri="{FF2B5EF4-FFF2-40B4-BE49-F238E27FC236}">
-                <a16:creationId xmlns:a16="http://schemas.microsoft.com/office/drawing/2014/main" id="{4B9BE822-4841-450A-BE84-283DAB99DF6D}"/>
+                <a16:creationId xmlns:a16="http://schemas.microsoft.com/office/drawing/2014/main" id="{B9A82D6F-6060-476D-8E9F-0A9A589CD6DF}"/>
               </a:ext>
             </a:extLst>
           </p:cNvPr>
@@ -21332,7 +21332,7 @@
           <p:cNvPr id="6" name="">
             <a:extLst xmlns:a="http://schemas.openxmlformats.org/drawingml/2006/main">
               <a:ext uri="{FF2B5EF4-FFF2-40B4-BE49-F238E27FC236}">
-                <a16:creationId xmlns:a16="http://schemas.microsoft.com/office/drawing/2014/main" id="{C0532AA1-D516-4A7A-88D4-B95FC6D1079A}"/>
+                <a16:creationId xmlns:a16="http://schemas.microsoft.com/office/drawing/2014/main" id="{94CB1217-AF82-4B03-998C-ECE81C9FFA01}"/>
               </a:ext>
             </a:extLst>
           </p:cNvPr>
@@ -21371,7 +21371,7 @@
           <p:cNvPr id="7" name="">
             <a:extLst xmlns:a="http://schemas.openxmlformats.org/drawingml/2006/main">
               <a:ext uri="{FF2B5EF4-FFF2-40B4-BE49-F238E27FC236}">
-                <a16:creationId xmlns:a16="http://schemas.microsoft.com/office/drawing/2014/main" id="{025466D9-DD8A-4A03-A906-049B05BAAB41}"/>
+                <a16:creationId xmlns:a16="http://schemas.microsoft.com/office/drawing/2014/main" id="{E6E8CF59-997E-4FDE-A354-D2D5EB4C41FA}"/>
               </a:ext>
             </a:extLst>
           </p:cNvPr>
@@ -21529,7 +21529,7 @@
           <p:cNvPr id="8" name="">
             <a:extLst xmlns:a="http://schemas.openxmlformats.org/drawingml/2006/main">
               <a:ext uri="{FF2B5EF4-FFF2-40B4-BE49-F238E27FC236}">
-                <a16:creationId xmlns:a16="http://schemas.microsoft.com/office/drawing/2014/main" id="{4C51F5ED-CF1E-4D1C-A2A6-B4B2D4604F4B}"/>
+                <a16:creationId xmlns:a16="http://schemas.microsoft.com/office/drawing/2014/main" id="{F91F7C88-0508-4D5E-B421-2544323DF397}"/>
               </a:ext>
             </a:extLst>
           </p:cNvPr>
@@ -21559,7 +21559,7 @@
           <p:cNvPr id="9" name="">
             <a:extLst xmlns:a="http://schemas.openxmlformats.org/drawingml/2006/main">
               <a:ext uri="{FF2B5EF4-FFF2-40B4-BE49-F238E27FC236}">
-                <a16:creationId xmlns:a16="http://schemas.microsoft.com/office/drawing/2014/main" id="{1935C587-9217-46D7-8C4B-C649E6CE4FDC}"/>
+                <a16:creationId xmlns:a16="http://schemas.microsoft.com/office/drawing/2014/main" id="{E35475FC-3235-4AAD-BE6E-E40ADD89D974}"/>
               </a:ext>
             </a:extLst>
           </p:cNvPr>
@@ -21598,7 +21598,7 @@
           <p:cNvPr id="10" name="">
             <a:extLst xmlns:a="http://schemas.openxmlformats.org/drawingml/2006/main">
               <a:ext uri="{FF2B5EF4-FFF2-40B4-BE49-F238E27FC236}">
-                <a16:creationId xmlns:a16="http://schemas.microsoft.com/office/drawing/2014/main" id="{ABB72AE1-8B3E-424C-9D91-B1D39DE963E1}"/>
+                <a16:creationId xmlns:a16="http://schemas.microsoft.com/office/drawing/2014/main" id="{531B1E95-DA84-46D9-9CE0-644DC943AE8C}"/>
               </a:ext>
             </a:extLst>
           </p:cNvPr>
@@ -21628,7 +21628,7 @@
           <p:cNvPr id="11" name="">
             <a:extLst xmlns:a="http://schemas.openxmlformats.org/drawingml/2006/main">
               <a:ext uri="{FF2B5EF4-FFF2-40B4-BE49-F238E27FC236}">
-                <a16:creationId xmlns:a16="http://schemas.microsoft.com/office/drawing/2014/main" id="{6735D33F-097E-4A44-B3CB-A9B71E73A7F3}"/>
+                <a16:creationId xmlns:a16="http://schemas.microsoft.com/office/drawing/2014/main" id="{5022B551-7D26-4AD4-A611-DE759C695A6B}"/>
               </a:ext>
             </a:extLst>
           </p:cNvPr>
@@ -21786,7 +21786,7 @@
           <p:cNvPr id="12" name="">
             <a:extLst xmlns:a="http://schemas.openxmlformats.org/drawingml/2006/main">
               <a:ext uri="{FF2B5EF4-FFF2-40B4-BE49-F238E27FC236}">
-                <a16:creationId xmlns:a16="http://schemas.microsoft.com/office/drawing/2014/main" id="{B1CC5607-9B45-4B4D-AA51-8D641EAC04B4}"/>
+                <a16:creationId xmlns:a16="http://schemas.microsoft.com/office/drawing/2014/main" id="{9E8AD613-7E6E-40A5-8A77-12035F63489F}"/>
               </a:ext>
             </a:extLst>
           </p:cNvPr>
@@ -21944,7 +21944,7 @@
           <p:cNvPr id="13" name="">
             <a:extLst xmlns:a="http://schemas.openxmlformats.org/drawingml/2006/main">
               <a:ext uri="{FF2B5EF4-FFF2-40B4-BE49-F238E27FC236}">
-                <a16:creationId xmlns:a16="http://schemas.microsoft.com/office/drawing/2014/main" id="{A01680F7-19CC-436B-86EE-179D49B3F6E9}"/>
+                <a16:creationId xmlns:a16="http://schemas.microsoft.com/office/drawing/2014/main" id="{503435FB-B0BA-4290-A74D-DEDF4634F940}"/>
               </a:ext>
             </a:extLst>
           </p:cNvPr>
@@ -22102,7 +22102,7 @@
           <p:cNvPr id="14" name="">
             <a:extLst xmlns:a="http://schemas.openxmlformats.org/drawingml/2006/main">
               <a:ext uri="{FF2B5EF4-FFF2-40B4-BE49-F238E27FC236}">
-                <a16:creationId xmlns:a16="http://schemas.microsoft.com/office/drawing/2014/main" id="{72EF30E1-01D1-4918-919F-301A57AB3D1B}"/>
+                <a16:creationId xmlns:a16="http://schemas.microsoft.com/office/drawing/2014/main" id="{E44DB7DE-BCB1-4C9B-B1C3-C00B71575FA2}"/>
               </a:ext>
             </a:extLst>
           </p:cNvPr>
@@ -22132,7 +22132,7 @@
           <p:cNvPr id="15" name="">
             <a:extLst xmlns:a="http://schemas.openxmlformats.org/drawingml/2006/main">
               <a:ext uri="{FF2B5EF4-FFF2-40B4-BE49-F238E27FC236}">
-                <a16:creationId xmlns:a16="http://schemas.microsoft.com/office/drawing/2014/main" id="{1E4EF751-FCBD-4B6D-9FD2-2ABDFE2B71AB}"/>
+                <a16:creationId xmlns:a16="http://schemas.microsoft.com/office/drawing/2014/main" id="{E9E02170-E220-4A3F-AB3E-101D3353C9B5}"/>
               </a:ext>
             </a:extLst>
           </p:cNvPr>
@@ -22171,7 +22171,7 @@
           <p:cNvPr id="16" name="">
             <a:extLst xmlns:a="http://schemas.openxmlformats.org/drawingml/2006/main">
               <a:ext uri="{FF2B5EF4-FFF2-40B4-BE49-F238E27FC236}">
-                <a16:creationId xmlns:a16="http://schemas.microsoft.com/office/drawing/2014/main" id="{6497E8B3-A588-437B-873C-01144AA4DCDD}"/>
+                <a16:creationId xmlns:a16="http://schemas.microsoft.com/office/drawing/2014/main" id="{B7F563FD-342C-4ABA-80ED-F3E0FBD89CAB}"/>
               </a:ext>
             </a:extLst>
           </p:cNvPr>
@@ -22201,7 +22201,7 @@
           <p:cNvPr id="17" name="">
             <a:extLst xmlns:a="http://schemas.openxmlformats.org/drawingml/2006/main">
               <a:ext uri="{FF2B5EF4-FFF2-40B4-BE49-F238E27FC236}">
-                <a16:creationId xmlns:a16="http://schemas.microsoft.com/office/drawing/2014/main" id="{56E8DE12-D4B6-4E46-BA6F-62BD8A6CF115}"/>
+                <a16:creationId xmlns:a16="http://schemas.microsoft.com/office/drawing/2014/main" id="{2E1BB331-D33E-4197-B6E9-A8CEA4AD56B0}"/>
               </a:ext>
             </a:extLst>
           </p:cNvPr>
@@ -22240,7 +22240,7 @@
           <p:cNvPr id="18" name="">
             <a:extLst xmlns:a="http://schemas.openxmlformats.org/drawingml/2006/main">
               <a:ext uri="{FF2B5EF4-FFF2-40B4-BE49-F238E27FC236}">
-                <a16:creationId xmlns:a16="http://schemas.microsoft.com/office/drawing/2014/main" id="{430EA36F-71B1-49F6-85D5-648CCF71D984}"/>
+                <a16:creationId xmlns:a16="http://schemas.microsoft.com/office/drawing/2014/main" id="{0A3C9D9F-1D75-4E7C-AA2F-F08F3A9C69F8}"/>
               </a:ext>
             </a:extLst>
           </p:cNvPr>
@@ -22270,7 +22270,7 @@
           <p:cNvPr id="19" name="">
             <a:extLst xmlns:a="http://schemas.openxmlformats.org/drawingml/2006/main">
               <a:ext uri="{FF2B5EF4-FFF2-40B4-BE49-F238E27FC236}">
-                <a16:creationId xmlns:a16="http://schemas.microsoft.com/office/drawing/2014/main" id="{2CC6B01C-2679-4E13-8109-89A2904199C7}"/>
+                <a16:creationId xmlns:a16="http://schemas.microsoft.com/office/drawing/2014/main" id="{DB457867-D6AC-4867-8D5D-0D5F0A6550D7}"/>
               </a:ext>
             </a:extLst>
           </p:cNvPr>
@@ -22309,7 +22309,7 @@
           <p:cNvPr id="20" name="">
             <a:extLst xmlns:a="http://schemas.openxmlformats.org/drawingml/2006/main">
               <a:ext uri="{FF2B5EF4-FFF2-40B4-BE49-F238E27FC236}">
-                <a16:creationId xmlns:a16="http://schemas.microsoft.com/office/drawing/2014/main" id="{A7EF4E06-7B8B-49F3-8F8C-3FD4C1492DB4}"/>
+                <a16:creationId xmlns:a16="http://schemas.microsoft.com/office/drawing/2014/main" id="{8ED29944-1817-4F00-AD6A-440FF9504556}"/>
               </a:ext>
             </a:extLst>
           </p:cNvPr>
@@ -22339,7 +22339,7 @@
           <p:cNvPr id="21" name="">
             <a:extLst xmlns:a="http://schemas.openxmlformats.org/drawingml/2006/main">
               <a:ext uri="{FF2B5EF4-FFF2-40B4-BE49-F238E27FC236}">
-                <a16:creationId xmlns:a16="http://schemas.microsoft.com/office/drawing/2014/main" id="{106352A2-8DCC-418B-BC4D-19273699DB2B}"/>
+                <a16:creationId xmlns:a16="http://schemas.microsoft.com/office/drawing/2014/main" id="{2718D4F9-7661-4575-873C-7A4DF8F317F9}"/>
               </a:ext>
             </a:extLst>
           </p:cNvPr>
@@ -22378,7 +22378,7 @@
           <p:cNvPr id="22" name="">
             <a:extLst xmlns:a="http://schemas.openxmlformats.org/drawingml/2006/main">
               <a:ext uri="{FF2B5EF4-FFF2-40B4-BE49-F238E27FC236}">
-                <a16:creationId xmlns:a16="http://schemas.microsoft.com/office/drawing/2014/main" id="{DB02A701-7914-449A-B48E-F946C949EDE0}"/>
+                <a16:creationId xmlns:a16="http://schemas.microsoft.com/office/drawing/2014/main" id="{52ED3CC6-CB68-472B-910D-7AD156E2D150}"/>
               </a:ext>
             </a:extLst>
           </p:cNvPr>
@@ -22408,7 +22408,7 @@
           <p:cNvPr id="23" name="">
             <a:extLst xmlns:a="http://schemas.openxmlformats.org/drawingml/2006/main">
               <a:ext uri="{FF2B5EF4-FFF2-40B4-BE49-F238E27FC236}">
-                <a16:creationId xmlns:a16="http://schemas.microsoft.com/office/drawing/2014/main" id="{230BB566-D056-4D42-A834-170C1263AD63}"/>
+                <a16:creationId xmlns:a16="http://schemas.microsoft.com/office/drawing/2014/main" id="{3ACAA213-1341-434C-BB38-C5CACDDE7B73}"/>
               </a:ext>
             </a:extLst>
           </p:cNvPr>
@@ -22447,7 +22447,7 @@
           <p:cNvPr id="24" name="">
             <a:extLst xmlns:a="http://schemas.openxmlformats.org/drawingml/2006/main">
               <a:ext uri="{FF2B5EF4-FFF2-40B4-BE49-F238E27FC236}">
-                <a16:creationId xmlns:a16="http://schemas.microsoft.com/office/drawing/2014/main" id="{EA9DA135-65CD-44B8-8291-6C098F73778E}"/>
+                <a16:creationId xmlns:a16="http://schemas.microsoft.com/office/drawing/2014/main" id="{017AFA5E-BFC3-4474-B2B3-6056B359F7EC}"/>
               </a:ext>
             </a:extLst>
           </p:cNvPr>
@@ -22477,7 +22477,7 @@
           <p:cNvPr id="25" name="">
             <a:extLst xmlns:a="http://schemas.openxmlformats.org/drawingml/2006/main">
               <a:ext uri="{FF2B5EF4-FFF2-40B4-BE49-F238E27FC236}">
-                <a16:creationId xmlns:a16="http://schemas.microsoft.com/office/drawing/2014/main" id="{F6A53A40-99DD-42F6-A126-029FCE9B5632}"/>
+                <a16:creationId xmlns:a16="http://schemas.microsoft.com/office/drawing/2014/main" id="{B0029E6C-257B-456A-B6FF-0AD1B9ADA206}"/>
               </a:ext>
             </a:extLst>
           </p:cNvPr>
@@ -22516,7 +22516,7 @@
           <p:cNvPr id="26" name="">
             <a:extLst xmlns:a="http://schemas.openxmlformats.org/drawingml/2006/main">
               <a:ext uri="{FF2B5EF4-FFF2-40B4-BE49-F238E27FC236}">
-                <a16:creationId xmlns:a16="http://schemas.microsoft.com/office/drawing/2014/main" id="{2961A144-8555-4FF3-9101-F82E0A8456CE}"/>
+                <a16:creationId xmlns:a16="http://schemas.microsoft.com/office/drawing/2014/main" id="{314093F1-3F8D-481A-884E-5CF580599C3B}"/>
               </a:ext>
             </a:extLst>
           </p:cNvPr>
@@ -22546,7 +22546,7 @@
           <p:cNvPr id="27" name="">
             <a:extLst xmlns:a="http://schemas.openxmlformats.org/drawingml/2006/main">
               <a:ext uri="{FF2B5EF4-FFF2-40B4-BE49-F238E27FC236}">
-                <a16:creationId xmlns:a16="http://schemas.microsoft.com/office/drawing/2014/main" id="{C3FBD809-32DC-4FF0-910F-9D718054B462}"/>
+                <a16:creationId xmlns:a16="http://schemas.microsoft.com/office/drawing/2014/main" id="{696B610F-4CC6-4600-AB18-3E47A3D6808E}"/>
               </a:ext>
             </a:extLst>
           </p:cNvPr>
@@ -22585,7 +22585,7 @@
           <p:cNvPr id="28" name="">
             <a:extLst xmlns:a="http://schemas.openxmlformats.org/drawingml/2006/main">
               <a:ext uri="{FF2B5EF4-FFF2-40B4-BE49-F238E27FC236}">
-                <a16:creationId xmlns:a16="http://schemas.microsoft.com/office/drawing/2014/main" id="{0B88F034-8A5A-4C5F-B957-3BD5A4DC55E7}"/>
+                <a16:creationId xmlns:a16="http://schemas.microsoft.com/office/drawing/2014/main" id="{B262C059-AF79-4AE4-944D-88F7A151C77F}"/>
               </a:ext>
             </a:extLst>
           </p:cNvPr>
@@ -22615,7 +22615,7 @@
           <p:cNvPr id="29" name="">
             <a:extLst xmlns:a="http://schemas.openxmlformats.org/drawingml/2006/main">
               <a:ext uri="{FF2B5EF4-FFF2-40B4-BE49-F238E27FC236}">
-                <a16:creationId xmlns:a16="http://schemas.microsoft.com/office/drawing/2014/main" id="{2528992A-A04E-4FB0-A4A2-AABAEB6E4573}"/>
+                <a16:creationId xmlns:a16="http://schemas.microsoft.com/office/drawing/2014/main" id="{5C019DA9-6739-4E10-89CF-2626965CDEE7}"/>
               </a:ext>
             </a:extLst>
           </p:cNvPr>
@@ -22654,7 +22654,7 @@
           <p:cNvPr id="30" name="">
             <a:extLst xmlns:a="http://schemas.openxmlformats.org/drawingml/2006/main">
               <a:ext uri="{FF2B5EF4-FFF2-40B4-BE49-F238E27FC236}">
-                <a16:creationId xmlns:a16="http://schemas.microsoft.com/office/drawing/2014/main" id="{832CD2C8-9095-4207-992A-D91786C457E5}"/>
+                <a16:creationId xmlns:a16="http://schemas.microsoft.com/office/drawing/2014/main" id="{E1068F38-068D-48C9-96CA-DA934BD9D2D4}"/>
               </a:ext>
             </a:extLst>
           </p:cNvPr>
@@ -22684,7 +22684,7 @@
           <p:cNvPr id="31" name="">
             <a:extLst xmlns:a="http://schemas.openxmlformats.org/drawingml/2006/main">
               <a:ext uri="{FF2B5EF4-FFF2-40B4-BE49-F238E27FC236}">
-                <a16:creationId xmlns:a16="http://schemas.microsoft.com/office/drawing/2014/main" id="{8C12D87F-1979-4EC2-BC60-C42BF4E56DED}"/>
+                <a16:creationId xmlns:a16="http://schemas.microsoft.com/office/drawing/2014/main" id="{D5BDF87C-3634-43E0-AE6D-75B2F9E421C5}"/>
               </a:ext>
             </a:extLst>
           </p:cNvPr>
@@ -22723,7 +22723,7 @@
           <p:cNvPr id="32" name="">
             <a:extLst xmlns:a="http://schemas.openxmlformats.org/drawingml/2006/main">
               <a:ext uri="{FF2B5EF4-FFF2-40B4-BE49-F238E27FC236}">
-                <a16:creationId xmlns:a16="http://schemas.microsoft.com/office/drawing/2014/main" id="{81B82EE5-76A9-495D-A966-B2958B929FC8}"/>
+                <a16:creationId xmlns:a16="http://schemas.microsoft.com/office/drawing/2014/main" id="{4E2C800E-6A91-4ADF-AA6A-8C498EC68F43}"/>
               </a:ext>
             </a:extLst>
           </p:cNvPr>
@@ -22753,7 +22753,7 @@
           <p:cNvPr id="33" name="">
             <a:extLst xmlns:a="http://schemas.openxmlformats.org/drawingml/2006/main">
               <a:ext uri="{FF2B5EF4-FFF2-40B4-BE49-F238E27FC236}">
-                <a16:creationId xmlns:a16="http://schemas.microsoft.com/office/drawing/2014/main" id="{7C4AB3E4-3EFF-433A-B334-89E1EE7AD36E}"/>
+                <a16:creationId xmlns:a16="http://schemas.microsoft.com/office/drawing/2014/main" id="{2B0D7215-E63E-4B8B-A04D-05F28D3B7F95}"/>
               </a:ext>
             </a:extLst>
           </p:cNvPr>
@@ -22792,7 +22792,7 @@
           <p:cNvPr id="34" name="">
             <a:extLst xmlns:a="http://schemas.openxmlformats.org/drawingml/2006/main">
               <a:ext uri="{FF2B5EF4-FFF2-40B4-BE49-F238E27FC236}">
-                <a16:creationId xmlns:a16="http://schemas.microsoft.com/office/drawing/2014/main" id="{0A31CAFB-D530-4756-BF14-034031850961}"/>
+                <a16:creationId xmlns:a16="http://schemas.microsoft.com/office/drawing/2014/main" id="{8B671CAF-2B9B-42B2-A83A-9F555F1E6116}"/>
               </a:ext>
             </a:extLst>
           </p:cNvPr>
@@ -22822,7 +22822,7 @@
           <p:cNvPr id="35" name="">
             <a:extLst xmlns:a="http://schemas.openxmlformats.org/drawingml/2006/main">
               <a:ext uri="{FF2B5EF4-FFF2-40B4-BE49-F238E27FC236}">
-                <a16:creationId xmlns:a16="http://schemas.microsoft.com/office/drawing/2014/main" id="{9E18FFD0-F657-4DA2-B8DB-DDACB9928F15}"/>
+                <a16:creationId xmlns:a16="http://schemas.microsoft.com/office/drawing/2014/main" id="{E1ED630C-37EA-453A-8E2F-C5AD63271DD2}"/>
               </a:ext>
             </a:extLst>
           </p:cNvPr>
@@ -22861,7 +22861,7 @@
           <p:cNvPr id="36" name="">
             <a:extLst xmlns:a="http://schemas.openxmlformats.org/drawingml/2006/main">
               <a:ext uri="{FF2B5EF4-FFF2-40B4-BE49-F238E27FC236}">
-                <a16:creationId xmlns:a16="http://schemas.microsoft.com/office/drawing/2014/main" id="{AF8752D8-B982-4D8A-BF34-3E81D8703A3B}"/>
+                <a16:creationId xmlns:a16="http://schemas.microsoft.com/office/drawing/2014/main" id="{19E72055-B137-4BB4-A571-1A2647D91C36}"/>
               </a:ext>
             </a:extLst>
           </p:cNvPr>
@@ -22891,7 +22891,7 @@
           <p:cNvPr id="37" name="">
             <a:extLst xmlns:a="http://schemas.openxmlformats.org/drawingml/2006/main">
               <a:ext uri="{FF2B5EF4-FFF2-40B4-BE49-F238E27FC236}">
-                <a16:creationId xmlns:a16="http://schemas.microsoft.com/office/drawing/2014/main" id="{44357B93-4E81-40AC-BB8B-B59EC6019E04}"/>
+                <a16:creationId xmlns:a16="http://schemas.microsoft.com/office/drawing/2014/main" id="{174B7F6D-447D-4E60-818E-F36C1B354FFC}"/>
               </a:ext>
             </a:extLst>
           </p:cNvPr>
@@ -22930,7 +22930,7 @@
           <p:cNvPr id="38" name="">
             <a:extLst xmlns:a="http://schemas.openxmlformats.org/drawingml/2006/main">
               <a:ext uri="{FF2B5EF4-FFF2-40B4-BE49-F238E27FC236}">
-                <a16:creationId xmlns:a16="http://schemas.microsoft.com/office/drawing/2014/main" id="{AE150903-67B9-4BD8-9CAC-44C18DD0A505}"/>
+                <a16:creationId xmlns:a16="http://schemas.microsoft.com/office/drawing/2014/main" id="{F5661531-1D6C-444C-9596-F78A3E9C79B9}"/>
               </a:ext>
             </a:extLst>
           </p:cNvPr>
@@ -22960,7 +22960,7 @@
           <p:cNvPr id="39" name="">
             <a:extLst xmlns:a="http://schemas.openxmlformats.org/drawingml/2006/main">
               <a:ext uri="{FF2B5EF4-FFF2-40B4-BE49-F238E27FC236}">
-                <a16:creationId xmlns:a16="http://schemas.microsoft.com/office/drawing/2014/main" id="{0E8928FC-92F2-4551-B1E7-9BAC7C88CA19}"/>
+                <a16:creationId xmlns:a16="http://schemas.microsoft.com/office/drawing/2014/main" id="{3EDD7A1A-34BB-478C-A343-A11C3E930046}"/>
               </a:ext>
             </a:extLst>
           </p:cNvPr>
@@ -22999,7 +22999,7 @@
           <p:cNvPr id="40" name="">
             <a:extLst xmlns:a="http://schemas.openxmlformats.org/drawingml/2006/main">
               <a:ext uri="{FF2B5EF4-FFF2-40B4-BE49-F238E27FC236}">
-                <a16:creationId xmlns:a16="http://schemas.microsoft.com/office/drawing/2014/main" id="{0BF4304E-AC01-43EA-AF4D-BE6BB65678E2}"/>
+                <a16:creationId xmlns:a16="http://schemas.microsoft.com/office/drawing/2014/main" id="{FF9CEC8E-A60E-4C57-ABD3-DF93929D7E48}"/>
               </a:ext>
             </a:extLst>
           </p:cNvPr>
@@ -23029,7 +23029,7 @@
           <p:cNvPr id="41" name="">
             <a:extLst xmlns:a="http://schemas.openxmlformats.org/drawingml/2006/main">
               <a:ext uri="{FF2B5EF4-FFF2-40B4-BE49-F238E27FC236}">
-                <a16:creationId xmlns:a16="http://schemas.microsoft.com/office/drawing/2014/main" id="{B4817CB5-9CB9-4F5E-BD41-BBBD78EF7884}"/>
+                <a16:creationId xmlns:a16="http://schemas.microsoft.com/office/drawing/2014/main" id="{A2C267D8-99D1-4BDD-801E-87CA446ADCFF}"/>
               </a:ext>
             </a:extLst>
           </p:cNvPr>
@@ -23068,7 +23068,7 @@
           <p:cNvPr id="42" name="">
             <a:extLst xmlns:a="http://schemas.openxmlformats.org/drawingml/2006/main">
               <a:ext uri="{FF2B5EF4-FFF2-40B4-BE49-F238E27FC236}">
-                <a16:creationId xmlns:a16="http://schemas.microsoft.com/office/drawing/2014/main" id="{ED1FC1E3-87BC-4646-8CEF-EE5EE2DC8A8E}"/>
+                <a16:creationId xmlns:a16="http://schemas.microsoft.com/office/drawing/2014/main" id="{E6C807EE-3C51-451E-B654-FE46CB064773}"/>
               </a:ext>
             </a:extLst>
           </p:cNvPr>
@@ -23098,7 +23098,7 @@
           <p:cNvPr id="43" name="">
             <a:extLst xmlns:a="http://schemas.openxmlformats.org/drawingml/2006/main">
               <a:ext uri="{FF2B5EF4-FFF2-40B4-BE49-F238E27FC236}">
-                <a16:creationId xmlns:a16="http://schemas.microsoft.com/office/drawing/2014/main" id="{4096BDF6-3E21-41A9-9A47-5CE2A8768CF7}"/>
+                <a16:creationId xmlns:a16="http://schemas.microsoft.com/office/drawing/2014/main" id="{971EE776-2FE0-473A-9909-7F47F06A20A5}"/>
               </a:ext>
             </a:extLst>
           </p:cNvPr>
@@ -23137,7 +23137,7 @@
           <p:cNvPr id="44" name="">
             <a:extLst xmlns:a="http://schemas.openxmlformats.org/drawingml/2006/main">
               <a:ext uri="{FF2B5EF4-FFF2-40B4-BE49-F238E27FC236}">
-                <a16:creationId xmlns:a16="http://schemas.microsoft.com/office/drawing/2014/main" id="{8675F771-01CD-4895-8CFC-C8D3246A6952}"/>
+                <a16:creationId xmlns:a16="http://schemas.microsoft.com/office/drawing/2014/main" id="{BA4198A6-3565-49F6-A57B-D7B3A382FFBF}"/>
               </a:ext>
             </a:extLst>
           </p:cNvPr>
@@ -23167,7 +23167,7 @@
           <p:cNvPr id="45" name="">
             <a:extLst xmlns:a="http://schemas.openxmlformats.org/drawingml/2006/main">
               <a:ext uri="{FF2B5EF4-FFF2-40B4-BE49-F238E27FC236}">
-                <a16:creationId xmlns:a16="http://schemas.microsoft.com/office/drawing/2014/main" id="{9DE001AA-A949-449F-95A0-2F5CF41CEDF5}"/>
+                <a16:creationId xmlns:a16="http://schemas.microsoft.com/office/drawing/2014/main" id="{3117D457-603E-438F-BC3C-232FFCB02521}"/>
               </a:ext>
             </a:extLst>
           </p:cNvPr>
@@ -23206,7 +23206,7 @@
           <p:cNvPr id="46" name="">
             <a:extLst xmlns:a="http://schemas.openxmlformats.org/drawingml/2006/main">
               <a:ext uri="{FF2B5EF4-FFF2-40B4-BE49-F238E27FC236}">
-                <a16:creationId xmlns:a16="http://schemas.microsoft.com/office/drawing/2014/main" id="{E2DC3EFC-931C-470E-93E5-30746DDA0577}"/>
+                <a16:creationId xmlns:a16="http://schemas.microsoft.com/office/drawing/2014/main" id="{7B1553C3-86DA-487E-9295-E73204642814}"/>
               </a:ext>
             </a:extLst>
           </p:cNvPr>
@@ -23236,7 +23236,7 @@
           <p:cNvPr id="47" name="">
             <a:extLst xmlns:a="http://schemas.openxmlformats.org/drawingml/2006/main">
               <a:ext uri="{FF2B5EF4-FFF2-40B4-BE49-F238E27FC236}">
-                <a16:creationId xmlns:a16="http://schemas.microsoft.com/office/drawing/2014/main" id="{9476EFA5-1957-4390-AD0A-2140E98AB47B}"/>
+                <a16:creationId xmlns:a16="http://schemas.microsoft.com/office/drawing/2014/main" id="{2B0850DB-624A-40AD-A4DB-5E6AAA934017}"/>
               </a:ext>
             </a:extLst>
           </p:cNvPr>
@@ -23275,7 +23275,7 @@
           <p:cNvPr id="48" name="">
             <a:extLst xmlns:a="http://schemas.openxmlformats.org/drawingml/2006/main">
               <a:ext uri="{FF2B5EF4-FFF2-40B4-BE49-F238E27FC236}">
-                <a16:creationId xmlns:a16="http://schemas.microsoft.com/office/drawing/2014/main" id="{7D1D2240-EFCE-4A51-8C1D-B7073EC68CFF}"/>
+                <a16:creationId xmlns:a16="http://schemas.microsoft.com/office/drawing/2014/main" id="{6D2FAF3C-3401-43D9-A19F-7C25E9813682}"/>
               </a:ext>
             </a:extLst>
           </p:cNvPr>
@@ -23305,7 +23305,7 @@
           <p:cNvPr id="49" name="">
             <a:extLst xmlns:a="http://schemas.openxmlformats.org/drawingml/2006/main">
               <a:ext uri="{FF2B5EF4-FFF2-40B4-BE49-F238E27FC236}">
-                <a16:creationId xmlns:a16="http://schemas.microsoft.com/office/drawing/2014/main" id="{A424DE72-73FA-4F2F-9912-E4E1CA169E0B}"/>
+                <a16:creationId xmlns:a16="http://schemas.microsoft.com/office/drawing/2014/main" id="{EA73A760-E771-4C9F-8D2B-4D92CEA641AA}"/>
               </a:ext>
             </a:extLst>
           </p:cNvPr>
@@ -23344,7 +23344,7 @@
           <p:cNvPr id="50" name="">
             <a:extLst xmlns:a="http://schemas.openxmlformats.org/drawingml/2006/main">
               <a:ext uri="{FF2B5EF4-FFF2-40B4-BE49-F238E27FC236}">
-                <a16:creationId xmlns:a16="http://schemas.microsoft.com/office/drawing/2014/main" id="{BF8E5B35-CF28-4137-ABC9-7748C2080CCB}"/>
+                <a16:creationId xmlns:a16="http://schemas.microsoft.com/office/drawing/2014/main" id="{574F42DD-925A-461E-B728-2815F6D77516}"/>
               </a:ext>
             </a:extLst>
           </p:cNvPr>
@@ -23374,7 +23374,7 @@
           <p:cNvPr id="51" name="">
             <a:extLst xmlns:a="http://schemas.openxmlformats.org/drawingml/2006/main">
               <a:ext uri="{FF2B5EF4-FFF2-40B4-BE49-F238E27FC236}">
-                <a16:creationId xmlns:a16="http://schemas.microsoft.com/office/drawing/2014/main" id="{CB57F13E-2980-4B60-B5EB-AD3851E23D34}"/>
+                <a16:creationId xmlns:a16="http://schemas.microsoft.com/office/drawing/2014/main" id="{F15C516B-D18C-44FB-956F-B3F578330C04}"/>
               </a:ext>
             </a:extLst>
           </p:cNvPr>
@@ -23413,7 +23413,7 @@
           <p:cNvPr id="52" name="">
             <a:extLst xmlns:a="http://schemas.openxmlformats.org/drawingml/2006/main">
               <a:ext uri="{FF2B5EF4-FFF2-40B4-BE49-F238E27FC236}">
-                <a16:creationId xmlns:a16="http://schemas.microsoft.com/office/drawing/2014/main" id="{447C004D-AC64-4A01-93AE-05694889CC3B}"/>
+                <a16:creationId xmlns:a16="http://schemas.microsoft.com/office/drawing/2014/main" id="{E831E5D2-7D24-4528-B1D8-00A1E222C498}"/>
               </a:ext>
             </a:extLst>
           </p:cNvPr>
@@ -23443,7 +23443,7 @@
           <p:cNvPr id="53" name="">
             <a:extLst xmlns:a="http://schemas.openxmlformats.org/drawingml/2006/main">
               <a:ext uri="{FF2B5EF4-FFF2-40B4-BE49-F238E27FC236}">
-                <a16:creationId xmlns:a16="http://schemas.microsoft.com/office/drawing/2014/main" id="{E782050C-DB78-4150-8C68-38886D67FD17}"/>
+                <a16:creationId xmlns:a16="http://schemas.microsoft.com/office/drawing/2014/main" id="{A2473267-A6F5-48D0-83C3-733D7EBA1EC4}"/>
               </a:ext>
             </a:extLst>
           </p:cNvPr>
@@ -23482,7 +23482,7 @@
           <p:cNvPr id="54" name="">
             <a:extLst xmlns:a="http://schemas.openxmlformats.org/drawingml/2006/main">
               <a:ext uri="{FF2B5EF4-FFF2-40B4-BE49-F238E27FC236}">
-                <a16:creationId xmlns:a16="http://schemas.microsoft.com/office/drawing/2014/main" id="{9BC8FB2F-815F-413B-BB5F-3BECCF783758}"/>
+                <a16:creationId xmlns:a16="http://schemas.microsoft.com/office/drawing/2014/main" id="{C996D03A-13EF-441D-863B-AFCB32320CF7}"/>
               </a:ext>
             </a:extLst>
           </p:cNvPr>
@@ -23512,7 +23512,7 @@
           <p:cNvPr id="55" name="">
             <a:extLst xmlns:a="http://schemas.openxmlformats.org/drawingml/2006/main">
               <a:ext uri="{FF2B5EF4-FFF2-40B4-BE49-F238E27FC236}">
-                <a16:creationId xmlns:a16="http://schemas.microsoft.com/office/drawing/2014/main" id="{992B23B9-8679-42BC-A5C3-16CF2FDE6A76}"/>
+                <a16:creationId xmlns:a16="http://schemas.microsoft.com/office/drawing/2014/main" id="{98625045-020E-4F39-82BF-91BF19437B6E}"/>
               </a:ext>
             </a:extLst>
           </p:cNvPr>
@@ -23670,7 +23670,7 @@
           <p:cNvPr id="56" name="">
             <a:extLst xmlns:a="http://schemas.openxmlformats.org/drawingml/2006/main">
               <a:ext uri="{FF2B5EF4-FFF2-40B4-BE49-F238E27FC236}">
-                <a16:creationId xmlns:a16="http://schemas.microsoft.com/office/drawing/2014/main" id="{1B0840FC-8993-4FBA-9BBB-FAE62D25787C}"/>
+                <a16:creationId xmlns:a16="http://schemas.microsoft.com/office/drawing/2014/main" id="{B3D512B2-A0F5-4FB3-8749-ADEB0399EECF}"/>
               </a:ext>
             </a:extLst>
           </p:cNvPr>
@@ -23828,7 +23828,7 @@
           <p:cNvPr id="57" name="">
             <a:extLst xmlns:a="http://schemas.openxmlformats.org/drawingml/2006/main">
               <a:ext uri="{FF2B5EF4-FFF2-40B4-BE49-F238E27FC236}">
-                <a16:creationId xmlns:a16="http://schemas.microsoft.com/office/drawing/2014/main" id="{573A2DDA-74B3-4AA1-9F74-E365E3F21696}"/>
+                <a16:creationId xmlns:a16="http://schemas.microsoft.com/office/drawing/2014/main" id="{0C8432BC-6F23-400C-9BE0-E8E2DF30EA3A}"/>
               </a:ext>
             </a:extLst>
           </p:cNvPr>
@@ -23986,7 +23986,7 @@
           <p:cNvPr id="58" name="">
             <a:extLst xmlns:a="http://schemas.openxmlformats.org/drawingml/2006/main">
               <a:ext uri="{FF2B5EF4-FFF2-40B4-BE49-F238E27FC236}">
-                <a16:creationId xmlns:a16="http://schemas.microsoft.com/office/drawing/2014/main" id="{16C32ABB-22A9-4EF1-BB0D-DD2AD7CB96C1}"/>
+                <a16:creationId xmlns:a16="http://schemas.microsoft.com/office/drawing/2014/main" id="{9D8840E9-FD79-41B8-A7DB-4E7DA3E1C2E1}"/>
               </a:ext>
             </a:extLst>
           </p:cNvPr>
@@ -24144,7 +24144,7 @@
           <p:cNvPr id="59" name="">
             <a:extLst xmlns:a="http://schemas.openxmlformats.org/drawingml/2006/main">
               <a:ext uri="{FF2B5EF4-FFF2-40B4-BE49-F238E27FC236}">
-                <a16:creationId xmlns:a16="http://schemas.microsoft.com/office/drawing/2014/main" id="{FAD647F7-3294-4AD9-83CB-C767A9A223BA}"/>
+                <a16:creationId xmlns:a16="http://schemas.microsoft.com/office/drawing/2014/main" id="{C14AD329-2105-422E-A071-53382F1ECC9D}"/>
               </a:ext>
             </a:extLst>
           </p:cNvPr>
@@ -24300,7 +24300,7 @@
     </p:spTree>
     <p:extLst>
       <p:ext uri="{BB962C8B-B14F-4D97-AF65-F5344CB8AC3E}">
-        <p14:creationId xmlns:p14="http://schemas.microsoft.com/office/powerpoint/2010/main" val="1040324636"/>
+        <p14:creationId xmlns:p14="http://schemas.microsoft.com/office/powerpoint/2010/main" val="977762376"/>
       </p:ext>
     </p:extLst>
   </p:cSld>
@@ -24331,7 +24331,7 @@
           <p:cNvPr id="16" name="">
             <a:extLst xmlns:a="http://schemas.openxmlformats.org/drawingml/2006/main">
               <a:ext uri="{FF2B5EF4-FFF2-40B4-BE49-F238E27FC236}">
-                <a16:creationId xmlns:a16="http://schemas.microsoft.com/office/drawing/2014/main" id="{4EF45259-627E-42F1-A2AE-AF1BCD456876}"/>
+                <a16:creationId xmlns:a16="http://schemas.microsoft.com/office/drawing/2014/main" id="{E301ED6C-DF00-44DF-9D0F-B36FE1CDDFAD}"/>
               </a:ext>
             </a:extLst>
           </p:cNvPr>
@@ -24489,7 +24489,7 @@
           <p:cNvPr id="2" name="">
             <a:extLst xmlns:a="http://schemas.openxmlformats.org/drawingml/2006/main">
               <a:ext uri="{FF2B5EF4-FFF2-40B4-BE49-F238E27FC236}">
-                <a16:creationId xmlns:a16="http://schemas.microsoft.com/office/drawing/2014/main" id="{225F9CCA-FFF1-4646-BCB9-08BBA7C4C7C0}"/>
+                <a16:creationId xmlns:a16="http://schemas.microsoft.com/office/drawing/2014/main" id="{A3D891B0-CE67-413F-B903-457A15FD6ED6}"/>
               </a:ext>
             </a:extLst>
           </p:cNvPr>
@@ -24647,7 +24647,7 @@
           <p:cNvPr id="3" name="">
             <a:extLst xmlns:a="http://schemas.openxmlformats.org/drawingml/2006/main">
               <a:ext uri="{FF2B5EF4-FFF2-40B4-BE49-F238E27FC236}">
-                <a16:creationId xmlns:a16="http://schemas.microsoft.com/office/drawing/2014/main" id="{4C5A805E-A2BB-4783-B3F2-7EA3C794B635}"/>
+                <a16:creationId xmlns:a16="http://schemas.microsoft.com/office/drawing/2014/main" id="{37B2A299-75CD-4DCD-9864-B33677D848E9}"/>
               </a:ext>
             </a:extLst>
           </p:cNvPr>
@@ -24805,7 +24805,7 @@
           <p:cNvPr id="4" name="">
             <a:extLst xmlns:a="http://schemas.openxmlformats.org/drawingml/2006/main">
               <a:ext uri="{FF2B5EF4-FFF2-40B4-BE49-F238E27FC236}">
-                <a16:creationId xmlns:a16="http://schemas.microsoft.com/office/drawing/2014/main" id="{8556E481-E063-4DCE-8C4A-1DD8421CD375}"/>
+                <a16:creationId xmlns:a16="http://schemas.microsoft.com/office/drawing/2014/main" id="{5E977487-184F-4C8B-9767-6C13C5CF4E08}"/>
               </a:ext>
             </a:extLst>
           </p:cNvPr>
@@ -24963,7 +24963,7 @@
           <p:cNvPr id="5" name="">
             <a:extLst xmlns:a="http://schemas.openxmlformats.org/drawingml/2006/main">
               <a:ext uri="{FF2B5EF4-FFF2-40B4-BE49-F238E27FC236}">
-                <a16:creationId xmlns:a16="http://schemas.microsoft.com/office/drawing/2014/main" id="{944C912F-D5EE-4E7F-9BEE-3F24292E111B}"/>
+                <a16:creationId xmlns:a16="http://schemas.microsoft.com/office/drawing/2014/main" id="{0210BEF1-9240-44DD-9727-3362574819E0}"/>
               </a:ext>
             </a:extLst>
           </p:cNvPr>
@@ -25125,7 +25125,7 @@
           <p:cNvPr id="6" name="">
             <a:extLst xmlns:a="http://schemas.openxmlformats.org/drawingml/2006/main">
               <a:ext uri="{FF2B5EF4-FFF2-40B4-BE49-F238E27FC236}">
-                <a16:creationId xmlns:a16="http://schemas.microsoft.com/office/drawing/2014/main" id="{FBAFA299-0E84-4192-8D5B-910C17078A13}"/>
+                <a16:creationId xmlns:a16="http://schemas.microsoft.com/office/drawing/2014/main" id="{812AD66D-57B3-4C49-9135-E53C8DDFBA2B}"/>
               </a:ext>
             </a:extLst>
           </p:cNvPr>
@@ -25283,7 +25283,7 @@
           <p:cNvPr id="7" name="">
             <a:extLst xmlns:a="http://schemas.openxmlformats.org/drawingml/2006/main">
               <a:ext uri="{FF2B5EF4-FFF2-40B4-BE49-F238E27FC236}">
-                <a16:creationId xmlns:a16="http://schemas.microsoft.com/office/drawing/2014/main" id="{1D186CDF-E0CF-4088-A291-7A2C11D49D14}"/>
+                <a16:creationId xmlns:a16="http://schemas.microsoft.com/office/drawing/2014/main" id="{9BE66E09-7EDC-40D0-98CE-224B6B538F2C}"/>
               </a:ext>
             </a:extLst>
           </p:cNvPr>
@@ -25445,7 +25445,7 @@
           <p:cNvPr id="8" name="">
             <a:extLst xmlns:a="http://schemas.openxmlformats.org/drawingml/2006/main">
               <a:ext uri="{FF2B5EF4-FFF2-40B4-BE49-F238E27FC236}">
-                <a16:creationId xmlns:a16="http://schemas.microsoft.com/office/drawing/2014/main" id="{CAC6A929-DB4B-4D30-96C0-260035181061}"/>
+                <a16:creationId xmlns:a16="http://schemas.microsoft.com/office/drawing/2014/main" id="{AF0DEB0E-5117-4D2A-8C99-B450E2796CA2}"/>
               </a:ext>
             </a:extLst>
           </p:cNvPr>
@@ -25607,7 +25607,7 @@
           <p:cNvPr id="9" name="">
             <a:extLst xmlns:a="http://schemas.openxmlformats.org/drawingml/2006/main">
               <a:ext uri="{FF2B5EF4-FFF2-40B4-BE49-F238E27FC236}">
-                <a16:creationId xmlns:a16="http://schemas.microsoft.com/office/drawing/2014/main" id="{8558D8EA-F811-4447-895B-61EC33CB285A}"/>
+                <a16:creationId xmlns:a16="http://schemas.microsoft.com/office/drawing/2014/main" id="{92ABE131-C132-4938-89D5-99A6E93441A9}"/>
               </a:ext>
             </a:extLst>
           </p:cNvPr>
@@ -25765,7 +25765,7 @@
           <p:cNvPr id="10" name="">
             <a:extLst xmlns:a="http://schemas.openxmlformats.org/drawingml/2006/main">
               <a:ext uri="{FF2B5EF4-FFF2-40B4-BE49-F238E27FC236}">
-                <a16:creationId xmlns:a16="http://schemas.microsoft.com/office/drawing/2014/main" id="{738F4603-01F5-411B-8583-53F250AD1405}"/>
+                <a16:creationId xmlns:a16="http://schemas.microsoft.com/office/drawing/2014/main" id="{E6DF8E50-6F45-48B7-B2E9-C981BC86B236}"/>
               </a:ext>
             </a:extLst>
           </p:cNvPr>
@@ -25927,7 +25927,7 @@
           <p:cNvPr id="11" name="">
             <a:extLst xmlns:a="http://schemas.openxmlformats.org/drawingml/2006/main">
               <a:ext uri="{FF2B5EF4-FFF2-40B4-BE49-F238E27FC236}">
-                <a16:creationId xmlns:a16="http://schemas.microsoft.com/office/drawing/2014/main" id="{55B2230D-F4BB-484B-BB53-E3955FABA0EC}"/>
+                <a16:creationId xmlns:a16="http://schemas.microsoft.com/office/drawing/2014/main" id="{6932F505-5B5C-4ACA-B8DC-80741390D9A8}"/>
               </a:ext>
             </a:extLst>
           </p:cNvPr>
@@ -26089,7 +26089,7 @@
           <p:cNvPr id="12" name="">
             <a:extLst xmlns:a="http://schemas.openxmlformats.org/drawingml/2006/main">
               <a:ext uri="{FF2B5EF4-FFF2-40B4-BE49-F238E27FC236}">
-                <a16:creationId xmlns:a16="http://schemas.microsoft.com/office/drawing/2014/main" id="{686C55AC-59A4-40BC-B783-2D49272D1281}"/>
+                <a16:creationId xmlns:a16="http://schemas.microsoft.com/office/drawing/2014/main" id="{17658ADA-CD6F-4BDA-B003-FAB698BC9F1A}"/>
               </a:ext>
             </a:extLst>
           </p:cNvPr>
@@ -26251,7 +26251,7 @@
           <p:cNvPr id="13" name="">
             <a:extLst xmlns:a="http://schemas.openxmlformats.org/drawingml/2006/main">
               <a:ext uri="{FF2B5EF4-FFF2-40B4-BE49-F238E27FC236}">
-                <a16:creationId xmlns:a16="http://schemas.microsoft.com/office/drawing/2014/main" id="{F050F075-12A8-4D62-91D9-E8D36D654195}"/>
+                <a16:creationId xmlns:a16="http://schemas.microsoft.com/office/drawing/2014/main" id="{186C6683-5158-4B54-9382-49DE0ECE7D81}"/>
               </a:ext>
             </a:extLst>
           </p:cNvPr>
@@ -26413,7 +26413,7 @@
           <p:cNvPr id="14" name="">
             <a:extLst xmlns:a="http://schemas.openxmlformats.org/drawingml/2006/main">
               <a:ext uri="{FF2B5EF4-FFF2-40B4-BE49-F238E27FC236}">
-                <a16:creationId xmlns:a16="http://schemas.microsoft.com/office/drawing/2014/main" id="{9FD78768-EDFC-44C9-8B8E-684FA93924DA}"/>
+                <a16:creationId xmlns:a16="http://schemas.microsoft.com/office/drawing/2014/main" id="{4F46968D-EFD0-4B46-9EA9-CB5BD0F7A178}"/>
               </a:ext>
             </a:extLst>
           </p:cNvPr>
@@ -26571,7 +26571,7 @@
           <p:cNvPr id="15" name="">
             <a:extLst xmlns:a="http://schemas.openxmlformats.org/drawingml/2006/main">
               <a:ext uri="{FF2B5EF4-FFF2-40B4-BE49-F238E27FC236}">
-                <a16:creationId xmlns:a16="http://schemas.microsoft.com/office/drawing/2014/main" id="{63A07423-7505-4CC7-B75C-A6F64AB01EE4}"/>
+                <a16:creationId xmlns:a16="http://schemas.microsoft.com/office/drawing/2014/main" id="{782CD03F-2AF2-4D14-BEF9-C3E9C5E9344D}"/>
               </a:ext>
             </a:extLst>
           </p:cNvPr>
@@ -26727,7 +26727,7 @@
     </p:spTree>
     <p:extLst>
       <p:ext uri="{BB962C8B-B14F-4D97-AF65-F5344CB8AC3E}">
-        <p14:creationId xmlns:p14="http://schemas.microsoft.com/office/powerpoint/2010/main" val="41549408"/>
+        <p14:creationId xmlns:p14="http://schemas.microsoft.com/office/powerpoint/2010/main" val="1487821867"/>
       </p:ext>
     </p:extLst>
   </p:cSld>
@@ -26758,7 +26758,7 @@
           <p:cNvPr id="6" name="">
             <a:extLst xmlns:a="http://schemas.openxmlformats.org/drawingml/2006/main">
               <a:ext uri="{FF2B5EF4-FFF2-40B4-BE49-F238E27FC236}">
-                <a16:creationId xmlns:a16="http://schemas.microsoft.com/office/drawing/2014/main" id="{5B0A5B72-E462-4D20-863B-D815E8C7EA70}"/>
+                <a16:creationId xmlns:a16="http://schemas.microsoft.com/office/drawing/2014/main" id="{720C494A-515A-4497-A77C-A5FF148BFE4A}"/>
               </a:ext>
             </a:extLst>
           </p:cNvPr>
@@ -26916,7 +26916,7 @@
           <p:cNvPr id="2" name="">
             <a:extLst xmlns:a="http://schemas.openxmlformats.org/drawingml/2006/main">
               <a:ext uri="{FF2B5EF4-FFF2-40B4-BE49-F238E27FC236}">
-                <a16:creationId xmlns:a16="http://schemas.microsoft.com/office/drawing/2014/main" id="{C7DCAD16-151D-4E73-A27E-CE01C3767CBA}"/>
+                <a16:creationId xmlns:a16="http://schemas.microsoft.com/office/drawing/2014/main" id="{873457D5-534B-44B6-9865-BB8EB3888B12}"/>
               </a:ext>
             </a:extLst>
           </p:cNvPr>
@@ -27074,7 +27074,7 @@
           <p:cNvPr id="3" name="Chart">
             <a:extLst xmlns:a="http://schemas.openxmlformats.org/drawingml/2006/main">
               <a:ext uri="{FF2B5EF4-FFF2-40B4-BE49-F238E27FC236}">
-                <a16:creationId xmlns:a16="http://schemas.microsoft.com/office/drawing/2014/main" id="{506C1760-849C-4552-BC04-6E88F29A03C0}"/>
+                <a16:creationId xmlns:a16="http://schemas.microsoft.com/office/drawing/2014/main" id="{E6BC99B2-BB17-491D-90AB-8589D12A343A}"/>
               </a:ext>
             </a:extLst>
           </p:cNvPr>
@@ -27087,7 +27087,7 @@
         </p:xfrm>
         <a:graphic xmlns:a="http://schemas.openxmlformats.org/drawingml/2006/main">
           <a:graphicData uri="http://schemas.openxmlformats.org/drawingml/2006/chart">
-            <c:chart xmlns:r="http://schemas.openxmlformats.org/officeDocument/2006/relationships" xmlns:c="http://schemas.openxmlformats.org/drawingml/2006/chart" r:id="R0aa4f5f8168b47f9"/>
+            <c:chart xmlns:r="http://schemas.openxmlformats.org/officeDocument/2006/relationships" xmlns:c="http://schemas.openxmlformats.org/drawingml/2006/chart" r:id="Rf8cb105fa01442e4"/>
           </a:graphicData>
         </a:graphic>
       </p:graphicFrame>
@@ -27096,7 +27096,7 @@
           <p:cNvPr id="4" name="">
             <a:extLst xmlns:a="http://schemas.openxmlformats.org/drawingml/2006/main">
               <a:ext uri="{FF2B5EF4-FFF2-40B4-BE49-F238E27FC236}">
-                <a16:creationId xmlns:a16="http://schemas.microsoft.com/office/drawing/2014/main" id="{005C5499-188E-4BC0-9810-8017E74D6C26}"/>
+                <a16:creationId xmlns:a16="http://schemas.microsoft.com/office/drawing/2014/main" id="{90CDBC71-70DC-4C8C-925A-1B9EC95AEDC1}"/>
               </a:ext>
             </a:extLst>
           </p:cNvPr>
@@ -27254,7 +27254,7 @@
           <p:cNvPr id="5" name="">
             <a:extLst xmlns:a="http://schemas.openxmlformats.org/drawingml/2006/main">
               <a:ext uri="{FF2B5EF4-FFF2-40B4-BE49-F238E27FC236}">
-                <a16:creationId xmlns:a16="http://schemas.microsoft.com/office/drawing/2014/main" id="{948F5842-67E5-45FC-A438-05EF5B120B0C}"/>
+                <a16:creationId xmlns:a16="http://schemas.microsoft.com/office/drawing/2014/main" id="{45828D3F-6F4F-4BFC-938A-9822B08CCD0B}"/>
               </a:ext>
             </a:extLst>
           </p:cNvPr>
@@ -27410,7 +27410,7 @@
     </p:spTree>
     <p:extLst>
       <p:ext uri="{BB962C8B-B14F-4D97-AF65-F5344CB8AC3E}">
-        <p14:creationId xmlns:p14="http://schemas.microsoft.com/office/powerpoint/2010/main" val="651166773"/>
+        <p14:creationId xmlns:p14="http://schemas.microsoft.com/office/powerpoint/2010/main" val="107082441"/>
       </p:ext>
     </p:extLst>
   </p:cSld>
@@ -27441,7 +27441,7 @@
           <p:cNvPr id="5" name="">
             <a:extLst xmlns:a="http://schemas.openxmlformats.org/drawingml/2006/main">
               <a:ext uri="{FF2B5EF4-FFF2-40B4-BE49-F238E27FC236}">
-                <a16:creationId xmlns:a16="http://schemas.microsoft.com/office/drawing/2014/main" id="{F0D343CC-1CDB-4472-94E6-B4D88BD0D3FB}"/>
+                <a16:creationId xmlns:a16="http://schemas.microsoft.com/office/drawing/2014/main" id="{CFF00406-A5A9-418A-B7D9-243D7C7776A1}"/>
               </a:ext>
             </a:extLst>
           </p:cNvPr>
@@ -27599,7 +27599,7 @@
           <p:cNvPr id="2" name="">
             <a:extLst xmlns:a="http://schemas.openxmlformats.org/drawingml/2006/main">
               <a:ext uri="{FF2B5EF4-FFF2-40B4-BE49-F238E27FC236}">
-                <a16:creationId xmlns:a16="http://schemas.microsoft.com/office/drawing/2014/main" id="{D00C819D-3DE7-4F3C-9D0C-0E23CF760194}"/>
+                <a16:creationId xmlns:a16="http://schemas.microsoft.com/office/drawing/2014/main" id="{351AA801-65D2-4971-A694-8890B1C2480A}"/>
               </a:ext>
             </a:extLst>
           </p:cNvPr>
@@ -27757,7 +27757,7 @@
           <p:cNvPr id="3" name="Chart">
             <a:extLst xmlns:a="http://schemas.openxmlformats.org/drawingml/2006/main">
               <a:ext uri="{FF2B5EF4-FFF2-40B4-BE49-F238E27FC236}">
-                <a16:creationId xmlns:a16="http://schemas.microsoft.com/office/drawing/2014/main" id="{F6C20DE0-71F6-4E57-B832-D7D9FC2AF305}"/>
+                <a16:creationId xmlns:a16="http://schemas.microsoft.com/office/drawing/2014/main" id="{72BC854F-6D09-47D6-B75C-4D186437AB26}"/>
               </a:ext>
             </a:extLst>
           </p:cNvPr>
@@ -27770,7 +27770,7 @@
         </p:xfrm>
         <a:graphic xmlns:a="http://schemas.openxmlformats.org/drawingml/2006/main">
           <a:graphicData uri="http://schemas.openxmlformats.org/drawingml/2006/chart">
-            <c:chart xmlns:r="http://schemas.openxmlformats.org/officeDocument/2006/relationships" xmlns:c="http://schemas.openxmlformats.org/drawingml/2006/chart" r:id="R8fd2ecac487e4d67"/>
+            <c:chart xmlns:r="http://schemas.openxmlformats.org/officeDocument/2006/relationships" xmlns:c="http://schemas.openxmlformats.org/drawingml/2006/chart" r:id="R4c0fab6798484916"/>
           </a:graphicData>
         </a:graphic>
       </p:graphicFrame>
@@ -27779,7 +27779,7 @@
           <p:cNvPr id="4" name="">
             <a:extLst xmlns:a="http://schemas.openxmlformats.org/drawingml/2006/main">
               <a:ext uri="{FF2B5EF4-FFF2-40B4-BE49-F238E27FC236}">
-                <a16:creationId xmlns:a16="http://schemas.microsoft.com/office/drawing/2014/main" id="{9DC02A05-20A7-465E-8949-A71729056C4F}"/>
+                <a16:creationId xmlns:a16="http://schemas.microsoft.com/office/drawing/2014/main" id="{20315977-496F-4689-B6C8-27FAB21D7831}"/>
               </a:ext>
             </a:extLst>
           </p:cNvPr>
@@ -27935,7 +27935,7 @@
     </p:spTree>
     <p:extLst>
       <p:ext uri="{BB962C8B-B14F-4D97-AF65-F5344CB8AC3E}">
-        <p14:creationId xmlns:p14="http://schemas.microsoft.com/office/powerpoint/2010/main" val="995710271"/>
+        <p14:creationId xmlns:p14="http://schemas.microsoft.com/office/powerpoint/2010/main" val="538984445"/>
       </p:ext>
     </p:extLst>
   </p:cSld>
@@ -27966,7 +27966,7 @@
           <p:cNvPr id="6" name="">
             <a:extLst xmlns:a="http://schemas.openxmlformats.org/drawingml/2006/main">
               <a:ext uri="{FF2B5EF4-FFF2-40B4-BE49-F238E27FC236}">
-                <a16:creationId xmlns:a16="http://schemas.microsoft.com/office/drawing/2014/main" id="{B50AE451-45DE-488C-BF18-60DA8A396061}"/>
+                <a16:creationId xmlns:a16="http://schemas.microsoft.com/office/drawing/2014/main" id="{E1328A59-6797-4AD8-B611-5E36D3B35D26}"/>
               </a:ext>
             </a:extLst>
           </p:cNvPr>
@@ -28124,7 +28124,7 @@
           <p:cNvPr id="2" name="">
             <a:extLst xmlns:a="http://schemas.openxmlformats.org/drawingml/2006/main">
               <a:ext uri="{FF2B5EF4-FFF2-40B4-BE49-F238E27FC236}">
-                <a16:creationId xmlns:a16="http://schemas.microsoft.com/office/drawing/2014/main" id="{7D645C7C-3D22-4D74-ACD9-C656F4026694}"/>
+                <a16:creationId xmlns:a16="http://schemas.microsoft.com/office/drawing/2014/main" id="{11258D45-19B9-43E7-BBB6-316A90EDF7F6}"/>
               </a:ext>
             </a:extLst>
           </p:cNvPr>
@@ -28282,7 +28282,7 @@
           <p:cNvPr id="3" name="Chart">
             <a:extLst xmlns:a="http://schemas.openxmlformats.org/drawingml/2006/main">
               <a:ext uri="{FF2B5EF4-FFF2-40B4-BE49-F238E27FC236}">
-                <a16:creationId xmlns:a16="http://schemas.microsoft.com/office/drawing/2014/main" id="{442E1C8C-BD8B-4713-A381-B5BA14336778}"/>
+                <a16:creationId xmlns:a16="http://schemas.microsoft.com/office/drawing/2014/main" id="{7A21C05C-7C18-4D2B-A664-97723EB5FE1F}"/>
               </a:ext>
             </a:extLst>
           </p:cNvPr>
@@ -28295,7 +28295,7 @@
         </p:xfrm>
         <a:graphic xmlns:a="http://schemas.openxmlformats.org/drawingml/2006/main">
           <a:graphicData uri="http://schemas.openxmlformats.org/drawingml/2006/chart">
-            <c:chart xmlns:r="http://schemas.openxmlformats.org/officeDocument/2006/relationships" xmlns:c="http://schemas.openxmlformats.org/drawingml/2006/chart" r:id="R029fb281b5f34317"/>
+            <c:chart xmlns:r="http://schemas.openxmlformats.org/officeDocument/2006/relationships" xmlns:c="http://schemas.openxmlformats.org/drawingml/2006/chart" r:id="Re294b5b4157d4a8b"/>
           </a:graphicData>
         </a:graphic>
       </p:graphicFrame>
@@ -28304,7 +28304,7 @@
           <p:cNvPr id="4" name="">
             <a:extLst xmlns:a="http://schemas.openxmlformats.org/drawingml/2006/main">
               <a:ext uri="{FF2B5EF4-FFF2-40B4-BE49-F238E27FC236}">
-                <a16:creationId xmlns:a16="http://schemas.microsoft.com/office/drawing/2014/main" id="{447FBF8B-3130-4710-AE8A-A7EFB5A9C6B6}"/>
+                <a16:creationId xmlns:a16="http://schemas.microsoft.com/office/drawing/2014/main" id="{FCF33219-B808-403D-ADD3-3E1C3D9FB746}"/>
               </a:ext>
             </a:extLst>
           </p:cNvPr>
@@ -28462,7 +28462,7 @@
           <p:cNvPr id="5" name="">
             <a:extLst xmlns:a="http://schemas.openxmlformats.org/drawingml/2006/main">
               <a:ext uri="{FF2B5EF4-FFF2-40B4-BE49-F238E27FC236}">
-                <a16:creationId xmlns:a16="http://schemas.microsoft.com/office/drawing/2014/main" id="{F0B015A6-21B7-4446-8039-3B36C1566F91}"/>
+                <a16:creationId xmlns:a16="http://schemas.microsoft.com/office/drawing/2014/main" id="{5C08E11A-2B4A-455A-B294-3BC6A7E6504B}"/>
               </a:ext>
             </a:extLst>
           </p:cNvPr>
@@ -28618,7 +28618,7 @@
     </p:spTree>
     <p:extLst>
       <p:ext uri="{BB962C8B-B14F-4D97-AF65-F5344CB8AC3E}">
-        <p14:creationId xmlns:p14="http://schemas.microsoft.com/office/powerpoint/2010/main" val="381150230"/>
+        <p14:creationId xmlns:p14="http://schemas.microsoft.com/office/powerpoint/2010/main" val="174425944"/>
       </p:ext>
     </p:extLst>
   </p:cSld>

</xml_diff>